<commit_message>
Update real replay and final presentation materials
</commit_message>
<xml_diff>
--- a/PIKET_LCT2026.pptx
+++ b/PIKET_LCT2026.pptx
@@ -2,30 +2,30 @@
 <file path=ppt/presentation.xml><?xml version="1.0" encoding="utf-8"?>
 <p:presentation xmlns:p="http://schemas.openxmlformats.org/presentationml/2006/main">
   <p:sldMasterIdLst>
-    <p:sldMasterId xmlns:r="http://schemas.openxmlformats.org/officeDocument/2006/relationships" id="2147483648" r:id="Ra3825b33baca4b9c"/>
+    <p:sldMasterId xmlns:r="http://schemas.openxmlformats.org/officeDocument/2006/relationships" id="2147483648" r:id="R189507ebe1de472b"/>
   </p:sldMasterIdLst>
   <p:notesMasterIdLst>
-    <p:notesMasterId xmlns:r="http://schemas.openxmlformats.org/officeDocument/2006/relationships" r:id="Rd98748ac416f424e"/>
+    <p:notesMasterId xmlns:r="http://schemas.openxmlformats.org/officeDocument/2006/relationships" r:id="Rfa6c74b8260d4afe"/>
   </p:notesMasterIdLst>
   <p:sldIdLst>
-    <p:sldId xmlns:r="http://schemas.openxmlformats.org/officeDocument/2006/relationships" id="256" r:id="R1fa05a2802f84c58"/>
-    <p:sldId xmlns:r="http://schemas.openxmlformats.org/officeDocument/2006/relationships" id="257" r:id="Ra2e8ec39e38c4b90"/>
-    <p:sldId xmlns:r="http://schemas.openxmlformats.org/officeDocument/2006/relationships" id="258" r:id="R9c00b1fa92514c94"/>
-    <p:sldId xmlns:r="http://schemas.openxmlformats.org/officeDocument/2006/relationships" id="259" r:id="Rfc89beb8fc294c6a"/>
-    <p:sldId xmlns:r="http://schemas.openxmlformats.org/officeDocument/2006/relationships" id="260" r:id="Ra3e95268633a4423"/>
-    <p:sldId xmlns:r="http://schemas.openxmlformats.org/officeDocument/2006/relationships" id="261" r:id="R4d0ed09a351b4215"/>
-    <p:sldId xmlns:r="http://schemas.openxmlformats.org/officeDocument/2006/relationships" id="262" r:id="R9f7327919b7b4400"/>
-    <p:sldId xmlns:r="http://schemas.openxmlformats.org/officeDocument/2006/relationships" id="263" r:id="R8ec6624d40e14404"/>
-    <p:sldId xmlns:r="http://schemas.openxmlformats.org/officeDocument/2006/relationships" id="264" r:id="Rb5e36e2fd4f043bd"/>
-    <p:sldId xmlns:r="http://schemas.openxmlformats.org/officeDocument/2006/relationships" id="265" r:id="Rf17fc986313547f6"/>
-    <p:sldId xmlns:r="http://schemas.openxmlformats.org/officeDocument/2006/relationships" id="266" r:id="Re9e0d8fba7544d99"/>
-    <p:sldId xmlns:r="http://schemas.openxmlformats.org/officeDocument/2006/relationships" id="267" r:id="R63b8a1e608e14d3a"/>
-    <p:sldId xmlns:r="http://schemas.openxmlformats.org/officeDocument/2006/relationships" id="268" r:id="Raf98d2358f044335"/>
-    <p:sldId xmlns:r="http://schemas.openxmlformats.org/officeDocument/2006/relationships" id="269" r:id="R0c843895038b4858"/>
-    <p:sldId xmlns:r="http://schemas.openxmlformats.org/officeDocument/2006/relationships" id="270" r:id="Rf3c35113c9364f41"/>
-    <p:sldId xmlns:r="http://schemas.openxmlformats.org/officeDocument/2006/relationships" id="271" r:id="Rf5de34d88bd34f4e"/>
-    <p:sldId xmlns:r="http://schemas.openxmlformats.org/officeDocument/2006/relationships" id="272" r:id="R27ea3273bf894429"/>
-    <p:sldId xmlns:r="http://schemas.openxmlformats.org/officeDocument/2006/relationships" id="273" r:id="Rb8b052ceea2a436d"/>
+    <p:sldId xmlns:r="http://schemas.openxmlformats.org/officeDocument/2006/relationships" id="256" r:id="R6660d611b8014919"/>
+    <p:sldId xmlns:r="http://schemas.openxmlformats.org/officeDocument/2006/relationships" id="257" r:id="R1c9c8cea20de4e88"/>
+    <p:sldId xmlns:r="http://schemas.openxmlformats.org/officeDocument/2006/relationships" id="258" r:id="R3ce1ee9ed41c4ebb"/>
+    <p:sldId xmlns:r="http://schemas.openxmlformats.org/officeDocument/2006/relationships" id="259" r:id="R5712e11238144280"/>
+    <p:sldId xmlns:r="http://schemas.openxmlformats.org/officeDocument/2006/relationships" id="260" r:id="R6af7f82d6d9a4e21"/>
+    <p:sldId xmlns:r="http://schemas.openxmlformats.org/officeDocument/2006/relationships" id="261" r:id="Rf60c7ed14b004259"/>
+    <p:sldId xmlns:r="http://schemas.openxmlformats.org/officeDocument/2006/relationships" id="262" r:id="R309fa09281d84e8f"/>
+    <p:sldId xmlns:r="http://schemas.openxmlformats.org/officeDocument/2006/relationships" id="263" r:id="R0481d5474c5e4311"/>
+    <p:sldId xmlns:r="http://schemas.openxmlformats.org/officeDocument/2006/relationships" id="264" r:id="Reacb8753f12a4a02"/>
+    <p:sldId xmlns:r="http://schemas.openxmlformats.org/officeDocument/2006/relationships" id="265" r:id="R148cc4e067a74bba"/>
+    <p:sldId xmlns:r="http://schemas.openxmlformats.org/officeDocument/2006/relationships" id="266" r:id="R31b3cd5de90d4dfe"/>
+    <p:sldId xmlns:r="http://schemas.openxmlformats.org/officeDocument/2006/relationships" id="267" r:id="Ref0a66fff6e04e9d"/>
+    <p:sldId xmlns:r="http://schemas.openxmlformats.org/officeDocument/2006/relationships" id="268" r:id="Ra3aeb9a51b534a3a"/>
+    <p:sldId xmlns:r="http://schemas.openxmlformats.org/officeDocument/2006/relationships" id="269" r:id="R98ccf95b058f43d1"/>
+    <p:sldId xmlns:r="http://schemas.openxmlformats.org/officeDocument/2006/relationships" id="270" r:id="R41d7ef3640ab408a"/>
+    <p:sldId xmlns:r="http://schemas.openxmlformats.org/officeDocument/2006/relationships" id="271" r:id="R1f14620171824ac2"/>
+    <p:sldId xmlns:r="http://schemas.openxmlformats.org/officeDocument/2006/relationships" id="272" r:id="R4c1cbf84695a4cc4"/>
+    <p:sldId xmlns:r="http://schemas.openxmlformats.org/officeDocument/2006/relationships" id="273" r:id="R3bf0f47578ee4b0e"/>
   </p:sldIdLst>
   <p:sldSz cx="12192000" cy="6858000"/>
   <p:notesSz cx="6858000" cy="9144000"/>
@@ -529,7 +529,7 @@
           <a:lstStyle xmlns:a="http://schemas.openxmlformats.org/drawingml/2006/main"/>
           <a:p xmlns:a="http://schemas.openxmlformats.org/drawingml/2006/main">
             <a:r>
-              <a:t>Источники api/routes_work_orders.py, api/static/piket.js, api/static/demo.js. Демонстрационный сценарий сохраняет решения в текущей вкладке. Серверный контур имеет собственные роли и историю заявок. Новый исследовательский ансамбль пока не подключён к API.</a:t>
+              <a:t>Источники api/routes_work_orders.py, api/static/piket.js, api/static/demo.js. Публичный прототип показывает реальный архивный срез на 29.03.2026 и сохраняет решения локально в браузере. Серверный контур имеет собственные роли и историю заявок. Новый исследовательский ансамбль пока не подключён к API.</a:t>
             </a:r>
           </a:p>
         </p:txBody>
@@ -1299,7 +1299,7 @@
           <a:lstStyle xmlns:a="http://schemas.openxmlformats.org/drawingml/2006/main"/>
           <a:p xmlns:a="http://schemas.openxmlformats.org/drawingml/2006/main">
             <a:r>
-              <a:t>Скриншот docs/review/desktop.png. Работающий интерфейс с учебными, вымышленными данными. Учебный режим выделен в интерфейсе. Проверка моделей проводится на отдельных реальных исторических журналах.</a:t>
+              <a:t>Скриншот docs/prototype/real-desktop.png. Настоящий исторический срез на 29.03.2026: 26 групп и сохранённые прогнозы ансамбля восьми моделей. Группа 553-1 получила предложенный моделью черновик. Решения сохраняются локально в браузере, фактические выезды не создаются.</a:t>
             </a:r>
           </a:p>
         </p:txBody>
@@ -1717,7 +1717,7 @@
   </p:cSld>
   <p:clrMap bg1="lt1" tx1="dk1" bg2="lt2" tx2="dk2" accent1="accent1" accent2="accent2" accent3="accent3" accent4="accent4" accent5="accent5" accent6="accent6" hlink="hlink" folHlink="folHlink"/>
   <p:sldLayoutIdLst>
-    <p:sldLayoutId xmlns:r="http://schemas.openxmlformats.org/officeDocument/2006/relationships" id="2147483649" r:id="Ra5118aedb2384aad"/>
+    <p:sldLayoutId xmlns:r="http://schemas.openxmlformats.org/officeDocument/2006/relationships" id="2147483649" r:id="R657776b0b63849f1"/>
   </p:sldLayoutIdLst>
   <p:txStyles>
     <p:titleStyle>
@@ -3351,7 +3351,7 @@
           <p:nvPr/>
         </p:nvPicPr>
         <p:blipFill>
-          <a:blip xmlns:r="http://schemas.openxmlformats.org/officeDocument/2006/relationships" xmlns:a="http://schemas.openxmlformats.org/drawingml/2006/main" r:embed="Ra042bb6e5f224f66"/>
+          <a:blip xmlns:r="http://schemas.openxmlformats.org/officeDocument/2006/relationships" xmlns:a="http://schemas.openxmlformats.org/drawingml/2006/main" r:embed="R2a4c8cde6a384cea"/>
           <a:stretch xmlns:a="http://schemas.openxmlformats.org/drawingml/2006/main"/>
         </p:blipFill>
         <p:spPr>
@@ -3369,7 +3369,7 @@
           <p:cNvPr id="2" name="">
             <a:extLst xmlns:a="http://schemas.openxmlformats.org/drawingml/2006/main">
               <a:ext uri="{FF2B5EF4-FFF2-40B4-BE49-F238E27FC236}">
-                <a16:creationId xmlns:a16="http://schemas.microsoft.com/office/drawing/2014/main" id="{7447F9B4-E16E-4EF8-9582-FFD8CE917160}"/>
+                <a16:creationId xmlns:a16="http://schemas.microsoft.com/office/drawing/2014/main" id="{E435BDA5-8B39-4369-A00B-1084028B4120}"/>
               </a:ext>
             </a:extLst>
           </p:cNvPr>
@@ -3426,7 +3426,7 @@
           <p:cNvPr id="3" name="">
             <a:extLst xmlns:a="http://schemas.openxmlformats.org/drawingml/2006/main">
               <a:ext uri="{FF2B5EF4-FFF2-40B4-BE49-F238E27FC236}">
-                <a16:creationId xmlns:a16="http://schemas.microsoft.com/office/drawing/2014/main" id="{9B548D06-49BC-4F1F-8A92-0A3E25A94064}"/>
+                <a16:creationId xmlns:a16="http://schemas.microsoft.com/office/drawing/2014/main" id="{3AA55EB5-91F8-43FD-8D9A-48FF3306D9F3}"/>
               </a:ext>
             </a:extLst>
           </p:cNvPr>
@@ -3483,7 +3483,7 @@
           <p:cNvPr id="4" name="">
             <a:extLst xmlns:a="http://schemas.openxmlformats.org/drawingml/2006/main">
               <a:ext uri="{FF2B5EF4-FFF2-40B4-BE49-F238E27FC236}">
-                <a16:creationId xmlns:a16="http://schemas.microsoft.com/office/drawing/2014/main" id="{794593DA-BF68-49C7-B36A-3154A816B3E7}"/>
+                <a16:creationId xmlns:a16="http://schemas.microsoft.com/office/drawing/2014/main" id="{F646377C-BC70-4845-96F1-10AE608A2B2C}"/>
               </a:ext>
             </a:extLst>
           </p:cNvPr>
@@ -3563,7 +3563,7 @@
           <p:cNvPr id="5" name="">
             <a:extLst xmlns:a="http://schemas.openxmlformats.org/drawingml/2006/main">
               <a:ext uri="{FF2B5EF4-FFF2-40B4-BE49-F238E27FC236}">
-                <a16:creationId xmlns:a16="http://schemas.microsoft.com/office/drawing/2014/main" id="{D3D987C9-C3D0-477E-AEA0-9BF30129A0EF}"/>
+                <a16:creationId xmlns:a16="http://schemas.microsoft.com/office/drawing/2014/main" id="{F25AEA3C-05D6-481D-AF95-931993D0689A}"/>
               </a:ext>
             </a:extLst>
           </p:cNvPr>
@@ -3641,7 +3641,7 @@
     </p:spTree>
     <p:extLst>
       <p:ext uri="{BB962C8B-B14F-4D97-AF65-F5344CB8AC3E}">
-        <p14:creationId xmlns:p14="http://schemas.microsoft.com/office/powerpoint/2010/main" val="1880420200"/>
+        <p14:creationId xmlns:p14="http://schemas.microsoft.com/office/powerpoint/2010/main" val="182670903"/>
       </p:ext>
     </p:extLst>
   </p:cSld>
@@ -3672,7 +3672,7 @@
           <p:cNvPr id="9" name="">
             <a:extLst xmlns:a="http://schemas.openxmlformats.org/drawingml/2006/main">
               <a:ext uri="{FF2B5EF4-FFF2-40B4-BE49-F238E27FC236}">
-                <a16:creationId xmlns:a16="http://schemas.microsoft.com/office/drawing/2014/main" id="{1B77FE97-1BE6-44D6-B220-A4C0A642825F}"/>
+                <a16:creationId xmlns:a16="http://schemas.microsoft.com/office/drawing/2014/main" id="{0D7032D8-D62E-4FCE-A165-86D80FB30C9A}"/>
               </a:ext>
             </a:extLst>
           </p:cNvPr>
@@ -3756,7 +3756,7 @@
           <p:nvPr/>
         </p:nvPicPr>
         <p:blipFill>
-          <a:blip xmlns:r="http://schemas.openxmlformats.org/officeDocument/2006/relationships" xmlns:a="http://schemas.openxmlformats.org/drawingml/2006/main" r:embed="Rb5072d9b8a15415f"/>
+          <a:blip xmlns:r="http://schemas.openxmlformats.org/officeDocument/2006/relationships" xmlns:a="http://schemas.openxmlformats.org/drawingml/2006/main" r:embed="R6fd3b971986d481b"/>
           <a:stretch xmlns:a="http://schemas.openxmlformats.org/drawingml/2006/main"/>
         </p:blipFill>
         <p:spPr>
@@ -3774,7 +3774,7 @@
           <p:cNvPr id="3" name="">
             <a:extLst xmlns:a="http://schemas.openxmlformats.org/drawingml/2006/main">
               <a:ext uri="{FF2B5EF4-FFF2-40B4-BE49-F238E27FC236}">
-                <a16:creationId xmlns:a16="http://schemas.microsoft.com/office/drawing/2014/main" id="{5CB7E39A-52E1-46A7-A018-73519E81AF41}"/>
+                <a16:creationId xmlns:a16="http://schemas.microsoft.com/office/drawing/2014/main" id="{032385C5-3604-48FF-AB06-31FCC7B299E3}"/>
               </a:ext>
             </a:extLst>
           </p:cNvPr>
@@ -3831,7 +3831,7 @@
           <p:cNvPr id="4" name="">
             <a:extLst xmlns:a="http://schemas.openxmlformats.org/drawingml/2006/main">
               <a:ext uri="{FF2B5EF4-FFF2-40B4-BE49-F238E27FC236}">
-                <a16:creationId xmlns:a16="http://schemas.microsoft.com/office/drawing/2014/main" id="{FE0B3A79-7DFE-4495-A370-9CE6C14C094C}"/>
+                <a16:creationId xmlns:a16="http://schemas.microsoft.com/office/drawing/2014/main" id="{B512AB7B-E9A7-47BE-B13B-F61BDBF39110}"/>
               </a:ext>
             </a:extLst>
           </p:cNvPr>
@@ -3911,7 +3911,7 @@
           <p:cNvPr id="5" name="">
             <a:extLst xmlns:a="http://schemas.openxmlformats.org/drawingml/2006/main">
               <a:ext uri="{FF2B5EF4-FFF2-40B4-BE49-F238E27FC236}">
-                <a16:creationId xmlns:a16="http://schemas.microsoft.com/office/drawing/2014/main" id="{EAAC8AFD-1BB3-4479-90B1-5A9B11A84D30}"/>
+                <a16:creationId xmlns:a16="http://schemas.microsoft.com/office/drawing/2014/main" id="{698FACB5-CF59-43F2-A65C-424F85E4B3B7}"/>
               </a:ext>
             </a:extLst>
           </p:cNvPr>
@@ -3968,7 +3968,7 @@
           <p:cNvPr id="6" name="">
             <a:extLst xmlns:a="http://schemas.openxmlformats.org/drawingml/2006/main">
               <a:ext uri="{FF2B5EF4-FFF2-40B4-BE49-F238E27FC236}">
-                <a16:creationId xmlns:a16="http://schemas.microsoft.com/office/drawing/2014/main" id="{382310E7-45CE-4B35-A2D9-6AB594C52879}"/>
+                <a16:creationId xmlns:a16="http://schemas.microsoft.com/office/drawing/2014/main" id="{ED75F82B-BAC3-4B68-A127-8C7A768C6C3D}"/>
               </a:ext>
             </a:extLst>
           </p:cNvPr>
@@ -4025,7 +4025,7 @@
           <p:cNvPr id="7" name="">
             <a:extLst xmlns:a="http://schemas.openxmlformats.org/drawingml/2006/main">
               <a:ext uri="{FF2B5EF4-FFF2-40B4-BE49-F238E27FC236}">
-                <a16:creationId xmlns:a16="http://schemas.microsoft.com/office/drawing/2014/main" id="{54990A34-7798-4B13-A071-5C0B3950E296}"/>
+                <a16:creationId xmlns:a16="http://schemas.microsoft.com/office/drawing/2014/main" id="{6D188BD5-691C-4009-A715-9AD7B39711CE}"/>
               </a:ext>
             </a:extLst>
           </p:cNvPr>
@@ -4072,7 +4072,7 @@
                 <a:ea typeface="Arial"/>
                 <a:cs typeface="Arial"/>
               </a:rPr>
-              <a:t>На экране учебный сценарий. Автоматического назначения или выполнения ремонта нет.</a:t>
+              <a:t>Архивный срез 29.03.2026. Решения хранятся в браузере. Заявки не означают состоявшийся выезд.</a:t>
             </a:r>
           </a:p>
         </p:txBody>
@@ -4082,7 +4082,7 @@
           <p:cNvPr id="8" name="">
             <a:extLst xmlns:a="http://schemas.openxmlformats.org/drawingml/2006/main">
               <a:ext uri="{FF2B5EF4-FFF2-40B4-BE49-F238E27FC236}">
-                <a16:creationId xmlns:a16="http://schemas.microsoft.com/office/drawing/2014/main" id="{49ED38A2-9B8C-4FE6-AE7C-CDCD9A559349}"/>
+                <a16:creationId xmlns:a16="http://schemas.microsoft.com/office/drawing/2014/main" id="{1A43A9E6-0B91-47C6-878C-2CEA38F652AC}"/>
               </a:ext>
             </a:extLst>
           </p:cNvPr>
@@ -4137,7 +4137,7 @@
     </p:spTree>
     <p:extLst>
       <p:ext uri="{BB962C8B-B14F-4D97-AF65-F5344CB8AC3E}">
-        <p14:creationId xmlns:p14="http://schemas.microsoft.com/office/powerpoint/2010/main" val="1988592659"/>
+        <p14:creationId xmlns:p14="http://schemas.microsoft.com/office/powerpoint/2010/main" val="1498978151"/>
       </p:ext>
     </p:extLst>
   </p:cSld>
@@ -4168,7 +4168,7 @@
           <p:cNvPr id="10" name="">
             <a:extLst xmlns:a="http://schemas.openxmlformats.org/drawingml/2006/main">
               <a:ext uri="{FF2B5EF4-FFF2-40B4-BE49-F238E27FC236}">
-                <a16:creationId xmlns:a16="http://schemas.microsoft.com/office/drawing/2014/main" id="{E80D030B-D573-4CBF-83E8-B380F8D17943}"/>
+                <a16:creationId xmlns:a16="http://schemas.microsoft.com/office/drawing/2014/main" id="{0CA5F68B-BCA4-462D-B7A1-C88EEA8EAD9A}"/>
               </a:ext>
             </a:extLst>
           </p:cNvPr>
@@ -4225,7 +4225,7 @@
           <p:cNvPr id="2" name="">
             <a:extLst xmlns:a="http://schemas.openxmlformats.org/drawingml/2006/main">
               <a:ext uri="{FF2B5EF4-FFF2-40B4-BE49-F238E27FC236}">
-                <a16:creationId xmlns:a16="http://schemas.microsoft.com/office/drawing/2014/main" id="{EA5E5234-840B-41BD-BB84-6F4B28E6C62A}"/>
+                <a16:creationId xmlns:a16="http://schemas.microsoft.com/office/drawing/2014/main" id="{EDEE65F3-80BE-461B-84C3-ABFE5711C33A}"/>
               </a:ext>
             </a:extLst>
           </p:cNvPr>
@@ -4282,7 +4282,7 @@
           <p:cNvPr id="3" name="">
             <a:extLst xmlns:a="http://schemas.openxmlformats.org/drawingml/2006/main">
               <a:ext uri="{FF2B5EF4-FFF2-40B4-BE49-F238E27FC236}">
-                <a16:creationId xmlns:a16="http://schemas.microsoft.com/office/drawing/2014/main" id="{EB74400E-9C3A-41D8-B0A1-E586B4265CFA}"/>
+                <a16:creationId xmlns:a16="http://schemas.microsoft.com/office/drawing/2014/main" id="{9596F75C-1E53-41E6-814F-0D5C1DACE556}"/>
               </a:ext>
             </a:extLst>
           </p:cNvPr>
@@ -4339,7 +4339,7 @@
           <p:cNvPr id="4" name="">
             <a:extLst xmlns:a="http://schemas.openxmlformats.org/drawingml/2006/main">
               <a:ext uri="{FF2B5EF4-FFF2-40B4-BE49-F238E27FC236}">
-                <a16:creationId xmlns:a16="http://schemas.microsoft.com/office/drawing/2014/main" id="{62F490DC-2054-4BBE-96C5-F4EBAEB29A78}"/>
+                <a16:creationId xmlns:a16="http://schemas.microsoft.com/office/drawing/2014/main" id="{147EE5BC-8B29-47DC-A67B-508484FF3099}"/>
               </a:ext>
             </a:extLst>
           </p:cNvPr>
@@ -4419,7 +4419,7 @@
           <p:cNvPr id="5" name="">
             <a:extLst xmlns:a="http://schemas.openxmlformats.org/drawingml/2006/main">
               <a:ext uri="{FF2B5EF4-FFF2-40B4-BE49-F238E27FC236}">
-                <a16:creationId xmlns:a16="http://schemas.microsoft.com/office/drawing/2014/main" id="{27AB7E69-BA83-43B6-8CAE-184F9D256BC1}"/>
+                <a16:creationId xmlns:a16="http://schemas.microsoft.com/office/drawing/2014/main" id="{1DF757CD-88ED-4267-BF9B-14317EBA303F}"/>
               </a:ext>
             </a:extLst>
           </p:cNvPr>
@@ -4476,7 +4476,7 @@
           <p:cNvPr id="6" name="">
             <a:extLst xmlns:a="http://schemas.openxmlformats.org/drawingml/2006/main">
               <a:ext uri="{FF2B5EF4-FFF2-40B4-BE49-F238E27FC236}">
-                <a16:creationId xmlns:a16="http://schemas.microsoft.com/office/drawing/2014/main" id="{37A42AFE-94B1-4A63-B825-79E0D561B5AB}"/>
+                <a16:creationId xmlns:a16="http://schemas.microsoft.com/office/drawing/2014/main" id="{793ADEC1-FD91-4090-8BA5-3C74575AEFE3}"/>
               </a:ext>
             </a:extLst>
           </p:cNvPr>
@@ -4533,7 +4533,7 @@
           <p:cNvPr id="7" name="">
             <a:extLst xmlns:a="http://schemas.openxmlformats.org/drawingml/2006/main">
               <a:ext uri="{FF2B5EF4-FFF2-40B4-BE49-F238E27FC236}">
-                <a16:creationId xmlns:a16="http://schemas.microsoft.com/office/drawing/2014/main" id="{C494B2CB-E2A4-4A57-9127-00274CAE4CCF}"/>
+                <a16:creationId xmlns:a16="http://schemas.microsoft.com/office/drawing/2014/main" id="{C95C20BE-2D8C-47BF-B688-38928C0B41E4}"/>
               </a:ext>
             </a:extLst>
           </p:cNvPr>
@@ -4613,7 +4613,7 @@
           <p:cNvPr id="8" name="">
             <a:extLst xmlns:a="http://schemas.openxmlformats.org/drawingml/2006/main">
               <a:ext uri="{FF2B5EF4-FFF2-40B4-BE49-F238E27FC236}">
-                <a16:creationId xmlns:a16="http://schemas.microsoft.com/office/drawing/2014/main" id="{A402180E-BCAD-41CA-ADF4-8D154229ACD8}"/>
+                <a16:creationId xmlns:a16="http://schemas.microsoft.com/office/drawing/2014/main" id="{58314049-8FED-4FE3-8964-7F5A27A70A9A}"/>
               </a:ext>
             </a:extLst>
           </p:cNvPr>
@@ -4670,7 +4670,7 @@
           <p:cNvPr id="9" name="">
             <a:extLst xmlns:a="http://schemas.openxmlformats.org/drawingml/2006/main">
               <a:ext uri="{FF2B5EF4-FFF2-40B4-BE49-F238E27FC236}">
-                <a16:creationId xmlns:a16="http://schemas.microsoft.com/office/drawing/2014/main" id="{E972BADF-9715-4DC5-AE70-E70411786B5D}"/>
+                <a16:creationId xmlns:a16="http://schemas.microsoft.com/office/drawing/2014/main" id="{9F36896E-55C0-4229-B274-15458276556C}"/>
               </a:ext>
             </a:extLst>
           </p:cNvPr>
@@ -4725,7 +4725,7 @@
     </p:spTree>
     <p:extLst>
       <p:ext uri="{BB962C8B-B14F-4D97-AF65-F5344CB8AC3E}">
-        <p14:creationId xmlns:p14="http://schemas.microsoft.com/office/powerpoint/2010/main" val="1345495948"/>
+        <p14:creationId xmlns:p14="http://schemas.microsoft.com/office/powerpoint/2010/main" val="224013374"/>
       </p:ext>
     </p:extLst>
   </p:cSld>
@@ -4756,7 +4756,7 @@
           <p:cNvPr id="5" name="">
             <a:extLst xmlns:a="http://schemas.openxmlformats.org/drawingml/2006/main">
               <a:ext uri="{FF2B5EF4-FFF2-40B4-BE49-F238E27FC236}">
-                <a16:creationId xmlns:a16="http://schemas.microsoft.com/office/drawing/2014/main" id="{48DB387B-CA0F-431C-B740-DB07B0E14BE7}"/>
+                <a16:creationId xmlns:a16="http://schemas.microsoft.com/office/drawing/2014/main" id="{9B238FF6-35E3-467B-A8CC-39D05E9AF75D}"/>
               </a:ext>
             </a:extLst>
           </p:cNvPr>
@@ -4813,7 +4813,7 @@
           <p:cNvPr id="2" name="">
             <a:extLst xmlns:a="http://schemas.openxmlformats.org/drawingml/2006/main">
               <a:ext uri="{FF2B5EF4-FFF2-40B4-BE49-F238E27FC236}">
-                <a16:creationId xmlns:a16="http://schemas.microsoft.com/office/drawing/2014/main" id="{51E9272D-9F9E-45C2-BAAC-C9CB00A0F422}"/>
+                <a16:creationId xmlns:a16="http://schemas.microsoft.com/office/drawing/2014/main" id="{087014B5-6847-427A-9D4F-71B176CD923C}"/>
               </a:ext>
             </a:extLst>
           </p:cNvPr>
@@ -4870,7 +4870,7 @@
           <p:cNvPr id="3" name="">
             <a:extLst xmlns:a="http://schemas.openxmlformats.org/drawingml/2006/main">
               <a:ext uri="{FF2B5EF4-FFF2-40B4-BE49-F238E27FC236}">
-                <a16:creationId xmlns:a16="http://schemas.microsoft.com/office/drawing/2014/main" id="{C06AFB1E-5D99-48F1-A4A4-A703F36E4913}"/>
+                <a16:creationId xmlns:a16="http://schemas.microsoft.com/office/drawing/2014/main" id="{11388B4E-C95C-4885-94F3-6FD71A203950}"/>
               </a:ext>
             </a:extLst>
           </p:cNvPr>
@@ -4950,7 +4950,7 @@
           <p:cNvPr id="4" name="">
             <a:extLst xmlns:a="http://schemas.openxmlformats.org/drawingml/2006/main">
               <a:ext uri="{FF2B5EF4-FFF2-40B4-BE49-F238E27FC236}">
-                <a16:creationId xmlns:a16="http://schemas.microsoft.com/office/drawing/2014/main" id="{0E6286EF-210B-4726-896B-80585AF281D9}"/>
+                <a16:creationId xmlns:a16="http://schemas.microsoft.com/office/drawing/2014/main" id="{11FFD614-DB61-4468-B83E-246669B43C15}"/>
               </a:ext>
             </a:extLst>
           </p:cNvPr>
@@ -4997,7 +4997,7 @@
                 <a:ea typeface="Arial"/>
                 <a:cs typeface="Arial"/>
               </a:rPr>
-              <a:t>piket-lct2026.skygen.workers.dev</a:t>
+              <a:t>mshperling.github.io/piket-lct2026-demo</a:t>
             </a:r>
           </a:p>
         </p:txBody>
@@ -5005,7 +5005,7 @@
     </p:spTree>
     <p:extLst>
       <p:ext uri="{BB962C8B-B14F-4D97-AF65-F5344CB8AC3E}">
-        <p14:creationId xmlns:p14="http://schemas.microsoft.com/office/powerpoint/2010/main" val="1138548682"/>
+        <p14:creationId xmlns:p14="http://schemas.microsoft.com/office/powerpoint/2010/main" val="1468663046"/>
       </p:ext>
     </p:extLst>
   </p:cSld>
@@ -5036,7 +5036,7 @@
           <p:cNvPr id="5" name="">
             <a:extLst xmlns:a="http://schemas.openxmlformats.org/drawingml/2006/main">
               <a:ext uri="{FF2B5EF4-FFF2-40B4-BE49-F238E27FC236}">
-                <a16:creationId xmlns:a16="http://schemas.microsoft.com/office/drawing/2014/main" id="{6F5BC17E-75AD-42CC-A09E-D455C44B6784}"/>
+                <a16:creationId xmlns:a16="http://schemas.microsoft.com/office/drawing/2014/main" id="{FBFE226F-8E36-486F-86F5-EDCB2F361F3B}"/>
               </a:ext>
             </a:extLst>
           </p:cNvPr>
@@ -5438,7 +5438,7 @@
           <p:cNvPr id="3" name="">
             <a:extLst xmlns:a="http://schemas.openxmlformats.org/drawingml/2006/main">
               <a:ext uri="{FF2B5EF4-FFF2-40B4-BE49-F238E27FC236}">
-                <a16:creationId xmlns:a16="http://schemas.microsoft.com/office/drawing/2014/main" id="{9E8B96E9-B157-43D2-B94C-6EED325E0BE7}"/>
+                <a16:creationId xmlns:a16="http://schemas.microsoft.com/office/drawing/2014/main" id="{D8970A10-56AF-4E20-B8DD-098654149E94}"/>
               </a:ext>
             </a:extLst>
           </p:cNvPr>
@@ -5495,7 +5495,7 @@
           <p:cNvPr id="4" name="">
             <a:extLst xmlns:a="http://schemas.openxmlformats.org/drawingml/2006/main">
               <a:ext uri="{FF2B5EF4-FFF2-40B4-BE49-F238E27FC236}">
-                <a16:creationId xmlns:a16="http://schemas.microsoft.com/office/drawing/2014/main" id="{4AA68F2E-63F2-4884-900F-D9F2C99940C2}"/>
+                <a16:creationId xmlns:a16="http://schemas.microsoft.com/office/drawing/2014/main" id="{D605B136-815B-4729-9769-018A36F61416}"/>
               </a:ext>
             </a:extLst>
           </p:cNvPr>
@@ -5550,7 +5550,7 @@
     </p:spTree>
     <p:extLst>
       <p:ext uri="{BB962C8B-B14F-4D97-AF65-F5344CB8AC3E}">
-        <p14:creationId xmlns:p14="http://schemas.microsoft.com/office/powerpoint/2010/main" val="792703097"/>
+        <p14:creationId xmlns:p14="http://schemas.microsoft.com/office/powerpoint/2010/main" val="1165920062"/>
       </p:ext>
     </p:extLst>
   </p:cSld>
@@ -5581,7 +5581,7 @@
           <p:cNvPr id="8" name="">
             <a:extLst xmlns:a="http://schemas.openxmlformats.org/drawingml/2006/main">
               <a:ext uri="{FF2B5EF4-FFF2-40B4-BE49-F238E27FC236}">
-                <a16:creationId xmlns:a16="http://schemas.microsoft.com/office/drawing/2014/main" id="{82602E1B-4B86-4AE9-B723-5372C505FF91}"/>
+                <a16:creationId xmlns:a16="http://schemas.microsoft.com/office/drawing/2014/main" id="{3CA54359-5761-40AD-A08A-47F58F1AA68E}"/>
               </a:ext>
             </a:extLst>
           </p:cNvPr>
@@ -5638,7 +5638,7 @@
           <p:cNvPr id="2" name="">
             <a:extLst xmlns:a="http://schemas.openxmlformats.org/drawingml/2006/main">
               <a:ext uri="{FF2B5EF4-FFF2-40B4-BE49-F238E27FC236}">
-                <a16:creationId xmlns:a16="http://schemas.microsoft.com/office/drawing/2014/main" id="{1947EA52-ACF5-4234-8C83-89B67D7C47CD}"/>
+                <a16:creationId xmlns:a16="http://schemas.microsoft.com/office/drawing/2014/main" id="{03AFD325-789F-4B94-96AA-F80816A3DE81}"/>
               </a:ext>
             </a:extLst>
           </p:cNvPr>
@@ -5695,7 +5695,7 @@
           <p:cNvPr id="3" name="">
             <a:extLst xmlns:a="http://schemas.openxmlformats.org/drawingml/2006/main">
               <a:ext uri="{FF2B5EF4-FFF2-40B4-BE49-F238E27FC236}">
-                <a16:creationId xmlns:a16="http://schemas.microsoft.com/office/drawing/2014/main" id="{DCC39445-B5E4-4BA6-A9D5-C18B8BD70572}"/>
+                <a16:creationId xmlns:a16="http://schemas.microsoft.com/office/drawing/2014/main" id="{BF91386C-07E2-4E76-B095-B25442AA038E}"/>
               </a:ext>
             </a:extLst>
           </p:cNvPr>
@@ -5752,7 +5752,7 @@
           <p:cNvPr id="4" name="">
             <a:extLst xmlns:a="http://schemas.openxmlformats.org/drawingml/2006/main">
               <a:ext uri="{FF2B5EF4-FFF2-40B4-BE49-F238E27FC236}">
-                <a16:creationId xmlns:a16="http://schemas.microsoft.com/office/drawing/2014/main" id="{886E35BA-E50D-4114-AFA6-08291415FBD2}"/>
+                <a16:creationId xmlns:a16="http://schemas.microsoft.com/office/drawing/2014/main" id="{40DC600E-BAA0-431C-928D-30E78272EA43}"/>
               </a:ext>
             </a:extLst>
           </p:cNvPr>
@@ -5809,7 +5809,7 @@
           <p:cNvPr id="5" name="">
             <a:extLst xmlns:a="http://schemas.openxmlformats.org/drawingml/2006/main">
               <a:ext uri="{FF2B5EF4-FFF2-40B4-BE49-F238E27FC236}">
-                <a16:creationId xmlns:a16="http://schemas.microsoft.com/office/drawing/2014/main" id="{670C30AF-FF56-4EFF-8AFC-C5A042585103}"/>
+                <a16:creationId xmlns:a16="http://schemas.microsoft.com/office/drawing/2014/main" id="{6EF82A42-A7BE-453C-AAE1-884610E59030}"/>
               </a:ext>
             </a:extLst>
           </p:cNvPr>
@@ -5889,7 +5889,7 @@
           <p:cNvPr id="6" name="">
             <a:extLst xmlns:a="http://schemas.openxmlformats.org/drawingml/2006/main">
               <a:ext uri="{FF2B5EF4-FFF2-40B4-BE49-F238E27FC236}">
-                <a16:creationId xmlns:a16="http://schemas.microsoft.com/office/drawing/2014/main" id="{6E6DEADB-6ADB-4727-8B99-29F158EA2BAD}"/>
+                <a16:creationId xmlns:a16="http://schemas.microsoft.com/office/drawing/2014/main" id="{3826511D-60B2-44B1-A035-B2B2420B85E5}"/>
               </a:ext>
             </a:extLst>
           </p:cNvPr>
@@ -5946,7 +5946,7 @@
           <p:cNvPr id="7" name="">
             <a:extLst xmlns:a="http://schemas.openxmlformats.org/drawingml/2006/main">
               <a:ext uri="{FF2B5EF4-FFF2-40B4-BE49-F238E27FC236}">
-                <a16:creationId xmlns:a16="http://schemas.microsoft.com/office/drawing/2014/main" id="{E190A5F4-6E2C-44D8-A8A0-2C53140A1922}"/>
+                <a16:creationId xmlns:a16="http://schemas.microsoft.com/office/drawing/2014/main" id="{B3AC31FD-2415-4FA1-9656-6BB718EF65BC}"/>
               </a:ext>
             </a:extLst>
           </p:cNvPr>
@@ -6001,7 +6001,7 @@
     </p:spTree>
     <p:extLst>
       <p:ext uri="{BB962C8B-B14F-4D97-AF65-F5344CB8AC3E}">
-        <p14:creationId xmlns:p14="http://schemas.microsoft.com/office/powerpoint/2010/main" val="1337635654"/>
+        <p14:creationId xmlns:p14="http://schemas.microsoft.com/office/powerpoint/2010/main" val="914274376"/>
       </p:ext>
     </p:extLst>
   </p:cSld>
@@ -6032,7 +6032,7 @@
           <p:cNvPr id="5" name="">
             <a:extLst xmlns:a="http://schemas.openxmlformats.org/drawingml/2006/main">
               <a:ext uri="{FF2B5EF4-FFF2-40B4-BE49-F238E27FC236}">
-                <a16:creationId xmlns:a16="http://schemas.microsoft.com/office/drawing/2014/main" id="{02497496-F1B1-4E6A-9471-11AAE221B687}"/>
+                <a16:creationId xmlns:a16="http://schemas.microsoft.com/office/drawing/2014/main" id="{FD9B8DA2-8030-4994-B38A-F21530D41424}"/>
               </a:ext>
             </a:extLst>
           </p:cNvPr>
@@ -7090,7 +7090,7 @@
           <p:cNvPr id="3" name="">
             <a:extLst xmlns:a="http://schemas.openxmlformats.org/drawingml/2006/main">
               <a:ext uri="{FF2B5EF4-FFF2-40B4-BE49-F238E27FC236}">
-                <a16:creationId xmlns:a16="http://schemas.microsoft.com/office/drawing/2014/main" id="{F30D8A24-1550-4AD0-94DB-1F863D5D6E9F}"/>
+                <a16:creationId xmlns:a16="http://schemas.microsoft.com/office/drawing/2014/main" id="{E32D5052-91F3-4B3B-8C48-9CF02A570DB8}"/>
               </a:ext>
             </a:extLst>
           </p:cNvPr>
@@ -7147,7 +7147,7 @@
           <p:cNvPr id="4" name="">
             <a:extLst xmlns:a="http://schemas.openxmlformats.org/drawingml/2006/main">
               <a:ext uri="{FF2B5EF4-FFF2-40B4-BE49-F238E27FC236}">
-                <a16:creationId xmlns:a16="http://schemas.microsoft.com/office/drawing/2014/main" id="{7F796319-1EB3-477C-9FA8-FE725E2B95BE}"/>
+                <a16:creationId xmlns:a16="http://schemas.microsoft.com/office/drawing/2014/main" id="{F462587A-DD46-478E-B2A6-9F8CFC8E2084}"/>
               </a:ext>
             </a:extLst>
           </p:cNvPr>
@@ -7202,7 +7202,7 @@
     </p:spTree>
     <p:extLst>
       <p:ext uri="{BB962C8B-B14F-4D97-AF65-F5344CB8AC3E}">
-        <p14:creationId xmlns:p14="http://schemas.microsoft.com/office/powerpoint/2010/main" val="82604488"/>
+        <p14:creationId xmlns:p14="http://schemas.microsoft.com/office/powerpoint/2010/main" val="1075142501"/>
       </p:ext>
     </p:extLst>
   </p:cSld>
@@ -7233,7 +7233,7 @@
           <p:cNvPr id="5" name="">
             <a:extLst xmlns:a="http://schemas.openxmlformats.org/drawingml/2006/main">
               <a:ext uri="{FF2B5EF4-FFF2-40B4-BE49-F238E27FC236}">
-                <a16:creationId xmlns:a16="http://schemas.microsoft.com/office/drawing/2014/main" id="{6F5CFF04-E576-454B-A6D5-635FE115B03C}"/>
+                <a16:creationId xmlns:a16="http://schemas.microsoft.com/office/drawing/2014/main" id="{CF3E522B-1007-4419-95F0-471D1D49AE71}"/>
               </a:ext>
             </a:extLst>
           </p:cNvPr>
@@ -7562,7 +7562,7 @@
           <p:cNvPr id="3" name="">
             <a:extLst xmlns:a="http://schemas.openxmlformats.org/drawingml/2006/main">
               <a:ext uri="{FF2B5EF4-FFF2-40B4-BE49-F238E27FC236}">
-                <a16:creationId xmlns:a16="http://schemas.microsoft.com/office/drawing/2014/main" id="{2F1A27D4-8A76-4E90-BE13-F079901AD262}"/>
+                <a16:creationId xmlns:a16="http://schemas.microsoft.com/office/drawing/2014/main" id="{B089CA74-4083-44F5-86C0-488D0528E0AC}"/>
               </a:ext>
             </a:extLst>
           </p:cNvPr>
@@ -7619,7 +7619,7 @@
           <p:cNvPr id="4" name="">
             <a:extLst xmlns:a="http://schemas.openxmlformats.org/drawingml/2006/main">
               <a:ext uri="{FF2B5EF4-FFF2-40B4-BE49-F238E27FC236}">
-                <a16:creationId xmlns:a16="http://schemas.microsoft.com/office/drawing/2014/main" id="{67A30028-B51C-477B-8A1D-B5C746099763}"/>
+                <a16:creationId xmlns:a16="http://schemas.microsoft.com/office/drawing/2014/main" id="{3202D9DA-3B5C-4685-94AB-C1BA1662B52D}"/>
               </a:ext>
             </a:extLst>
           </p:cNvPr>
@@ -7674,7 +7674,7 @@
     </p:spTree>
     <p:extLst>
       <p:ext uri="{BB962C8B-B14F-4D97-AF65-F5344CB8AC3E}">
-        <p14:creationId xmlns:p14="http://schemas.microsoft.com/office/powerpoint/2010/main" val="1890348373"/>
+        <p14:creationId xmlns:p14="http://schemas.microsoft.com/office/powerpoint/2010/main" val="316007379"/>
       </p:ext>
     </p:extLst>
   </p:cSld>
@@ -7705,7 +7705,7 @@
           <p:cNvPr id="8" name="">
             <a:extLst xmlns:a="http://schemas.openxmlformats.org/drawingml/2006/main">
               <a:ext uri="{FF2B5EF4-FFF2-40B4-BE49-F238E27FC236}">
-                <a16:creationId xmlns:a16="http://schemas.microsoft.com/office/drawing/2014/main" id="{7C6CD774-8DB7-4629-9486-AA0848A2C3DA}"/>
+                <a16:creationId xmlns:a16="http://schemas.microsoft.com/office/drawing/2014/main" id="{4B1DDF85-099F-4BB1-A016-8F6620C39E72}"/>
               </a:ext>
             </a:extLst>
           </p:cNvPr>
@@ -7762,7 +7762,7 @@
           <p:cNvPr id="2" name="">
             <a:extLst xmlns:a="http://schemas.openxmlformats.org/drawingml/2006/main">
               <a:ext uri="{FF2B5EF4-FFF2-40B4-BE49-F238E27FC236}">
-                <a16:creationId xmlns:a16="http://schemas.microsoft.com/office/drawing/2014/main" id="{878A8E61-1615-41F2-B2AC-C84021F7D24D}"/>
+                <a16:creationId xmlns:a16="http://schemas.microsoft.com/office/drawing/2014/main" id="{2451A6B6-B4D7-41A4-96C8-700B7ACA16F0}"/>
               </a:ext>
             </a:extLst>
           </p:cNvPr>
@@ -7819,7 +7819,7 @@
           <p:cNvPr id="3" name="">
             <a:extLst xmlns:a="http://schemas.openxmlformats.org/drawingml/2006/main">
               <a:ext uri="{FF2B5EF4-FFF2-40B4-BE49-F238E27FC236}">
-                <a16:creationId xmlns:a16="http://schemas.microsoft.com/office/drawing/2014/main" id="{7B74B02F-986A-4098-AFB2-04D3694AE430}"/>
+                <a16:creationId xmlns:a16="http://schemas.microsoft.com/office/drawing/2014/main" id="{CAE9A360-6985-4CCF-A2C4-4A354214ADC5}"/>
               </a:ext>
             </a:extLst>
           </p:cNvPr>
@@ -7876,7 +7876,7 @@
           <p:cNvPr id="4" name="">
             <a:extLst xmlns:a="http://schemas.openxmlformats.org/drawingml/2006/main">
               <a:ext uri="{FF2B5EF4-FFF2-40B4-BE49-F238E27FC236}">
-                <a16:creationId xmlns:a16="http://schemas.microsoft.com/office/drawing/2014/main" id="{9FE9C1D3-3B27-4DDA-A9E9-20055026E729}"/>
+                <a16:creationId xmlns:a16="http://schemas.microsoft.com/office/drawing/2014/main" id="{3F65240C-9990-4E5F-B650-4F93A3C39590}"/>
               </a:ext>
             </a:extLst>
           </p:cNvPr>
@@ -7933,7 +7933,7 @@
           <p:cNvPr id="5" name="">
             <a:extLst xmlns:a="http://schemas.openxmlformats.org/drawingml/2006/main">
               <a:ext uri="{FF2B5EF4-FFF2-40B4-BE49-F238E27FC236}">
-                <a16:creationId xmlns:a16="http://schemas.microsoft.com/office/drawing/2014/main" id="{44C0B59D-8701-490F-AD9A-3D8F5E66EB70}"/>
+                <a16:creationId xmlns:a16="http://schemas.microsoft.com/office/drawing/2014/main" id="{4E200ECB-3372-4978-8A84-832303B33651}"/>
               </a:ext>
             </a:extLst>
           </p:cNvPr>
@@ -8013,7 +8013,7 @@
           <p:cNvPr id="6" name="">
             <a:extLst xmlns:a="http://schemas.openxmlformats.org/drawingml/2006/main">
               <a:ext uri="{FF2B5EF4-FFF2-40B4-BE49-F238E27FC236}">
-                <a16:creationId xmlns:a16="http://schemas.microsoft.com/office/drawing/2014/main" id="{7A4E9152-27CF-4C31-BE21-6C0045662085}"/>
+                <a16:creationId xmlns:a16="http://schemas.microsoft.com/office/drawing/2014/main" id="{552DA118-70F8-4E50-82DC-ED8731B8E8AA}"/>
               </a:ext>
             </a:extLst>
           </p:cNvPr>
@@ -8070,7 +8070,7 @@
           <p:cNvPr id="7" name="">
             <a:extLst xmlns:a="http://schemas.openxmlformats.org/drawingml/2006/main">
               <a:ext uri="{FF2B5EF4-FFF2-40B4-BE49-F238E27FC236}">
-                <a16:creationId xmlns:a16="http://schemas.microsoft.com/office/drawing/2014/main" id="{96DAC28D-9AC5-4068-9012-3ADAC105EDF4}"/>
+                <a16:creationId xmlns:a16="http://schemas.microsoft.com/office/drawing/2014/main" id="{F471D902-8DA9-4380-A0EF-67F7329FB8F8}"/>
               </a:ext>
             </a:extLst>
           </p:cNvPr>
@@ -8125,7 +8125,7 @@
     </p:spTree>
     <p:extLst>
       <p:ext uri="{BB962C8B-B14F-4D97-AF65-F5344CB8AC3E}">
-        <p14:creationId xmlns:p14="http://schemas.microsoft.com/office/powerpoint/2010/main" val="1634953560"/>
+        <p14:creationId xmlns:p14="http://schemas.microsoft.com/office/powerpoint/2010/main" val="1177473365"/>
       </p:ext>
     </p:extLst>
   </p:cSld>
@@ -8156,7 +8156,7 @@
           <p:cNvPr id="6" name="">
             <a:extLst xmlns:a="http://schemas.openxmlformats.org/drawingml/2006/main">
               <a:ext uri="{FF2B5EF4-FFF2-40B4-BE49-F238E27FC236}">
-                <a16:creationId xmlns:a16="http://schemas.microsoft.com/office/drawing/2014/main" id="{034FD8D2-9FEF-41F9-9C0D-B51E54F1EAB0}"/>
+                <a16:creationId xmlns:a16="http://schemas.microsoft.com/office/drawing/2014/main" id="{CEBBF60E-314C-4F55-809E-D90402838430}"/>
               </a:ext>
             </a:extLst>
           </p:cNvPr>
@@ -8848,7 +8848,7 @@
           <p:cNvPr id="3" name="">
             <a:extLst xmlns:a="http://schemas.openxmlformats.org/drawingml/2006/main">
               <a:ext uri="{FF2B5EF4-FFF2-40B4-BE49-F238E27FC236}">
-                <a16:creationId xmlns:a16="http://schemas.microsoft.com/office/drawing/2014/main" id="{2C7A9E45-1ED6-436C-A828-8ABFA78DF089}"/>
+                <a16:creationId xmlns:a16="http://schemas.microsoft.com/office/drawing/2014/main" id="{769FF710-A0A5-4762-9C39-C9E6B043DD11}"/>
               </a:ext>
             </a:extLst>
           </p:cNvPr>
@@ -8905,7 +8905,7 @@
           <p:cNvPr id="4" name="">
             <a:extLst xmlns:a="http://schemas.openxmlformats.org/drawingml/2006/main">
               <a:ext uri="{FF2B5EF4-FFF2-40B4-BE49-F238E27FC236}">
-                <a16:creationId xmlns:a16="http://schemas.microsoft.com/office/drawing/2014/main" id="{379BA76E-8F26-49E9-848A-7E3B141EA0B6}"/>
+                <a16:creationId xmlns:a16="http://schemas.microsoft.com/office/drawing/2014/main" id="{DD3B8A86-592B-4487-B739-F46DD33DA12F}"/>
               </a:ext>
             </a:extLst>
           </p:cNvPr>
@@ -8962,7 +8962,7 @@
           <p:cNvPr id="5" name="">
             <a:extLst xmlns:a="http://schemas.openxmlformats.org/drawingml/2006/main">
               <a:ext uri="{FF2B5EF4-FFF2-40B4-BE49-F238E27FC236}">
-                <a16:creationId xmlns:a16="http://schemas.microsoft.com/office/drawing/2014/main" id="{6C1F2BA4-0E38-4044-9E2D-41D4C5E4A5A1}"/>
+                <a16:creationId xmlns:a16="http://schemas.microsoft.com/office/drawing/2014/main" id="{E51E3075-3B1C-4D27-ACF7-53D293526F97}"/>
               </a:ext>
             </a:extLst>
           </p:cNvPr>
@@ -9017,7 +9017,7 @@
     </p:spTree>
     <p:extLst>
       <p:ext uri="{BB962C8B-B14F-4D97-AF65-F5344CB8AC3E}">
-        <p14:creationId xmlns:p14="http://schemas.microsoft.com/office/powerpoint/2010/main" val="1592638621"/>
+        <p14:creationId xmlns:p14="http://schemas.microsoft.com/office/powerpoint/2010/main" val="1814263152"/>
       </p:ext>
     </p:extLst>
   </p:cSld>
@@ -9048,7 +9048,7 @@
           <p:cNvPr id="10" name="">
             <a:extLst xmlns:a="http://schemas.openxmlformats.org/drawingml/2006/main">
               <a:ext uri="{FF2B5EF4-FFF2-40B4-BE49-F238E27FC236}">
-                <a16:creationId xmlns:a16="http://schemas.microsoft.com/office/drawing/2014/main" id="{6815D9DF-41F0-41A7-8BA1-06195877A988}"/>
+                <a16:creationId xmlns:a16="http://schemas.microsoft.com/office/drawing/2014/main" id="{E5287397-DD24-4B1F-94FA-3701B54BD283}"/>
               </a:ext>
             </a:extLst>
           </p:cNvPr>
@@ -9128,7 +9128,7 @@
           <p:cNvPr id="2" name="">
             <a:extLst xmlns:a="http://schemas.openxmlformats.org/drawingml/2006/main">
               <a:ext uri="{FF2B5EF4-FFF2-40B4-BE49-F238E27FC236}">
-                <a16:creationId xmlns:a16="http://schemas.microsoft.com/office/drawing/2014/main" id="{A1E8DADE-C16F-4749-8E7C-5E4EC8BD5CEC}"/>
+                <a16:creationId xmlns:a16="http://schemas.microsoft.com/office/drawing/2014/main" id="{103387C4-400A-422F-B289-883015EBF302}"/>
               </a:ext>
             </a:extLst>
           </p:cNvPr>
@@ -9185,7 +9185,7 @@
           <p:cNvPr id="3" name="">
             <a:extLst xmlns:a="http://schemas.openxmlformats.org/drawingml/2006/main">
               <a:ext uri="{FF2B5EF4-FFF2-40B4-BE49-F238E27FC236}">
-                <a16:creationId xmlns:a16="http://schemas.microsoft.com/office/drawing/2014/main" id="{393F25AE-9B5A-4B19-A154-3A5C55D7F351}"/>
+                <a16:creationId xmlns:a16="http://schemas.microsoft.com/office/drawing/2014/main" id="{E7A85FDB-A13F-496D-9355-C4A4FCEA374A}"/>
               </a:ext>
             </a:extLst>
           </p:cNvPr>
@@ -9242,7 +9242,7 @@
           <p:cNvPr id="4" name="">
             <a:extLst xmlns:a="http://schemas.openxmlformats.org/drawingml/2006/main">
               <a:ext uri="{FF2B5EF4-FFF2-40B4-BE49-F238E27FC236}">
-                <a16:creationId xmlns:a16="http://schemas.microsoft.com/office/drawing/2014/main" id="{2FF5EF02-E49A-490A-BEFC-A331D0DAF251}"/>
+                <a16:creationId xmlns:a16="http://schemas.microsoft.com/office/drawing/2014/main" id="{3E0EF037-5458-434C-A43F-2562CAE17A91}"/>
               </a:ext>
             </a:extLst>
           </p:cNvPr>
@@ -9299,7 +9299,7 @@
           <p:cNvPr id="5" name="">
             <a:extLst xmlns:a="http://schemas.openxmlformats.org/drawingml/2006/main">
               <a:ext uri="{FF2B5EF4-FFF2-40B4-BE49-F238E27FC236}">
-                <a16:creationId xmlns:a16="http://schemas.microsoft.com/office/drawing/2014/main" id="{CBBF81BA-5782-488D-A720-F35167681D1F}"/>
+                <a16:creationId xmlns:a16="http://schemas.microsoft.com/office/drawing/2014/main" id="{4451C953-EC2E-4F7F-8E5A-E7246EB85759}"/>
               </a:ext>
             </a:extLst>
           </p:cNvPr>
@@ -9356,7 +9356,7 @@
           <p:cNvPr id="6" name="">
             <a:extLst xmlns:a="http://schemas.openxmlformats.org/drawingml/2006/main">
               <a:ext uri="{FF2B5EF4-FFF2-40B4-BE49-F238E27FC236}">
-                <a16:creationId xmlns:a16="http://schemas.microsoft.com/office/drawing/2014/main" id="{12D5AAAD-C01A-4404-85CC-44DDBF446BF8}"/>
+                <a16:creationId xmlns:a16="http://schemas.microsoft.com/office/drawing/2014/main" id="{BA8ABD65-6A60-4951-9258-DBAB7D7D3C33}"/>
               </a:ext>
             </a:extLst>
           </p:cNvPr>
@@ -9413,7 +9413,7 @@
           <p:cNvPr id="7" name="">
             <a:extLst xmlns:a="http://schemas.openxmlformats.org/drawingml/2006/main">
               <a:ext uri="{FF2B5EF4-FFF2-40B4-BE49-F238E27FC236}">
-                <a16:creationId xmlns:a16="http://schemas.microsoft.com/office/drawing/2014/main" id="{6176B69D-5523-449C-8CA6-4731B24C7EC6}"/>
+                <a16:creationId xmlns:a16="http://schemas.microsoft.com/office/drawing/2014/main" id="{FE97E8DC-CFB6-4734-8A87-D520C50C8DA6}"/>
               </a:ext>
             </a:extLst>
           </p:cNvPr>
@@ -9470,7 +9470,7 @@
           <p:cNvPr id="8" name="">
             <a:extLst xmlns:a="http://schemas.openxmlformats.org/drawingml/2006/main">
               <a:ext uri="{FF2B5EF4-FFF2-40B4-BE49-F238E27FC236}">
-                <a16:creationId xmlns:a16="http://schemas.microsoft.com/office/drawing/2014/main" id="{86D3A3DF-F53F-4D51-8558-07FBD559C345}"/>
+                <a16:creationId xmlns:a16="http://schemas.microsoft.com/office/drawing/2014/main" id="{4F0FEDC7-C212-4D36-918D-14C7F64155A8}"/>
               </a:ext>
             </a:extLst>
           </p:cNvPr>
@@ -9527,7 +9527,7 @@
           <p:cNvPr id="9" name="">
             <a:extLst xmlns:a="http://schemas.openxmlformats.org/drawingml/2006/main">
               <a:ext uri="{FF2B5EF4-FFF2-40B4-BE49-F238E27FC236}">
-                <a16:creationId xmlns:a16="http://schemas.microsoft.com/office/drawing/2014/main" id="{FD0FBBB9-87ED-455C-8813-F75B692BA796}"/>
+                <a16:creationId xmlns:a16="http://schemas.microsoft.com/office/drawing/2014/main" id="{1B92B93B-D642-408F-B233-18313EEFEE4F}"/>
               </a:ext>
             </a:extLst>
           </p:cNvPr>
@@ -9582,7 +9582,7 @@
     </p:spTree>
     <p:extLst>
       <p:ext uri="{BB962C8B-B14F-4D97-AF65-F5344CB8AC3E}">
-        <p14:creationId xmlns:p14="http://schemas.microsoft.com/office/powerpoint/2010/main" val="610527449"/>
+        <p14:creationId xmlns:p14="http://schemas.microsoft.com/office/powerpoint/2010/main" val="386744656"/>
       </p:ext>
     </p:extLst>
   </p:cSld>
@@ -9613,7 +9613,7 @@
           <p:cNvPr id="8" name="">
             <a:extLst xmlns:a="http://schemas.openxmlformats.org/drawingml/2006/main">
               <a:ext uri="{FF2B5EF4-FFF2-40B4-BE49-F238E27FC236}">
-                <a16:creationId xmlns:a16="http://schemas.microsoft.com/office/drawing/2014/main" id="{5A070527-2B38-4F10-9188-B0D0463137ED}"/>
+                <a16:creationId xmlns:a16="http://schemas.microsoft.com/office/drawing/2014/main" id="{EBAA0359-6399-403E-9072-1E71910DDF03}"/>
               </a:ext>
             </a:extLst>
           </p:cNvPr>
@@ -9693,7 +9693,7 @@
           <p:cNvPr id="2" name="">
             <a:extLst xmlns:a="http://schemas.openxmlformats.org/drawingml/2006/main">
               <a:ext uri="{FF2B5EF4-FFF2-40B4-BE49-F238E27FC236}">
-                <a16:creationId xmlns:a16="http://schemas.microsoft.com/office/drawing/2014/main" id="{2C934BB5-67D4-4678-9B32-A0568F082B1E}"/>
+                <a16:creationId xmlns:a16="http://schemas.microsoft.com/office/drawing/2014/main" id="{0880EFF4-FD85-478E-B7E6-4E86D032B8AC}"/>
               </a:ext>
             </a:extLst>
           </p:cNvPr>
@@ -9750,7 +9750,7 @@
           <p:cNvPr id="3" name="">
             <a:extLst xmlns:a="http://schemas.openxmlformats.org/drawingml/2006/main">
               <a:ext uri="{FF2B5EF4-FFF2-40B4-BE49-F238E27FC236}">
-                <a16:creationId xmlns:a16="http://schemas.microsoft.com/office/drawing/2014/main" id="{F22301C7-324F-4DCB-873C-95B221A87B50}"/>
+                <a16:creationId xmlns:a16="http://schemas.microsoft.com/office/drawing/2014/main" id="{47DF8F2A-F581-4A17-9D5B-E47460E2B851}"/>
               </a:ext>
             </a:extLst>
           </p:cNvPr>
@@ -9807,7 +9807,7 @@
           <p:cNvPr id="4" name="">
             <a:extLst xmlns:a="http://schemas.openxmlformats.org/drawingml/2006/main">
               <a:ext uri="{FF2B5EF4-FFF2-40B4-BE49-F238E27FC236}">
-                <a16:creationId xmlns:a16="http://schemas.microsoft.com/office/drawing/2014/main" id="{BD75275D-19FD-4D25-9655-2E56B238CE1C}"/>
+                <a16:creationId xmlns:a16="http://schemas.microsoft.com/office/drawing/2014/main" id="{D38D3F1B-FC23-4609-A34D-23B3B5DBE711}"/>
               </a:ext>
             </a:extLst>
           </p:cNvPr>
@@ -9864,7 +9864,7 @@
           <p:cNvPr id="5" name="">
             <a:extLst xmlns:a="http://schemas.openxmlformats.org/drawingml/2006/main">
               <a:ext uri="{FF2B5EF4-FFF2-40B4-BE49-F238E27FC236}">
-                <a16:creationId xmlns:a16="http://schemas.microsoft.com/office/drawing/2014/main" id="{E84E065C-F71B-426D-9E60-F07CF2CC93D3}"/>
+                <a16:creationId xmlns:a16="http://schemas.microsoft.com/office/drawing/2014/main" id="{3A3315C9-C60B-4B44-9DE1-18A8E77D7CB2}"/>
               </a:ext>
             </a:extLst>
           </p:cNvPr>
@@ -9977,7 +9977,7 @@
           <p:cNvPr id="6" name="">
             <a:extLst xmlns:a="http://schemas.openxmlformats.org/drawingml/2006/main">
               <a:ext uri="{FF2B5EF4-FFF2-40B4-BE49-F238E27FC236}">
-                <a16:creationId xmlns:a16="http://schemas.microsoft.com/office/drawing/2014/main" id="{C0E27C36-F8A5-4A10-8F08-E70FBA13E753}"/>
+                <a16:creationId xmlns:a16="http://schemas.microsoft.com/office/drawing/2014/main" id="{1B2535AF-057E-4BAC-AFD7-092081BE6104}"/>
               </a:ext>
             </a:extLst>
           </p:cNvPr>
@@ -10034,7 +10034,7 @@
           <p:cNvPr id="7" name="">
             <a:extLst xmlns:a="http://schemas.openxmlformats.org/drawingml/2006/main">
               <a:ext uri="{FF2B5EF4-FFF2-40B4-BE49-F238E27FC236}">
-                <a16:creationId xmlns:a16="http://schemas.microsoft.com/office/drawing/2014/main" id="{F4BBE972-DAD4-4B81-8DD3-004B03561ADE}"/>
+                <a16:creationId xmlns:a16="http://schemas.microsoft.com/office/drawing/2014/main" id="{D95C47F6-07E0-426C-B466-278864D841F0}"/>
               </a:ext>
             </a:extLst>
           </p:cNvPr>
@@ -10089,7 +10089,7 @@
     </p:spTree>
     <p:extLst>
       <p:ext uri="{BB962C8B-B14F-4D97-AF65-F5344CB8AC3E}">
-        <p14:creationId xmlns:p14="http://schemas.microsoft.com/office/powerpoint/2010/main" val="1579387155"/>
+        <p14:creationId xmlns:p14="http://schemas.microsoft.com/office/powerpoint/2010/main" val="393925908"/>
       </p:ext>
     </p:extLst>
   </p:cSld>
@@ -10120,7 +10120,7 @@
           <p:cNvPr id="9" name="">
             <a:extLst xmlns:a="http://schemas.openxmlformats.org/drawingml/2006/main">
               <a:ext uri="{FF2B5EF4-FFF2-40B4-BE49-F238E27FC236}">
-                <a16:creationId xmlns:a16="http://schemas.microsoft.com/office/drawing/2014/main" id="{98007329-6B39-41FF-9EFF-9D6FD822FD80}"/>
+                <a16:creationId xmlns:a16="http://schemas.microsoft.com/office/drawing/2014/main" id="{E858CDB6-8EE3-430F-B0D1-778DC9D483D3}"/>
               </a:ext>
             </a:extLst>
           </p:cNvPr>
@@ -10181,7 +10181,7 @@
           <p:nvPr/>
         </p:nvPicPr>
         <p:blipFill>
-          <a:blip xmlns:r="http://schemas.openxmlformats.org/officeDocument/2006/relationships" xmlns:a="http://schemas.openxmlformats.org/drawingml/2006/main" r:embed="R7c808b03526a4133"/>
+          <a:blip xmlns:r="http://schemas.openxmlformats.org/officeDocument/2006/relationships" xmlns:a="http://schemas.openxmlformats.org/drawingml/2006/main" r:embed="Rde1066cfd6714622"/>
           <a:stretch xmlns:a="http://schemas.openxmlformats.org/drawingml/2006/main"/>
         </p:blipFill>
         <p:spPr>
@@ -10199,7 +10199,7 @@
           <p:cNvPr id="3" name="">
             <a:extLst xmlns:a="http://schemas.openxmlformats.org/drawingml/2006/main">
               <a:ext uri="{FF2B5EF4-FFF2-40B4-BE49-F238E27FC236}">
-                <a16:creationId xmlns:a16="http://schemas.microsoft.com/office/drawing/2014/main" id="{82E91B27-D05A-42EE-BC85-60AF0A0BFCC0}"/>
+                <a16:creationId xmlns:a16="http://schemas.microsoft.com/office/drawing/2014/main" id="{CE183929-02C1-4C46-AC51-E7E67648C706}"/>
               </a:ext>
             </a:extLst>
           </p:cNvPr>
@@ -10256,7 +10256,7 @@
           <p:cNvPr id="4" name="">
             <a:extLst xmlns:a="http://schemas.openxmlformats.org/drawingml/2006/main">
               <a:ext uri="{FF2B5EF4-FFF2-40B4-BE49-F238E27FC236}">
-                <a16:creationId xmlns:a16="http://schemas.microsoft.com/office/drawing/2014/main" id="{F73A00C7-36C5-4F8B-9EAB-F343818CEFA1}"/>
+                <a16:creationId xmlns:a16="http://schemas.microsoft.com/office/drawing/2014/main" id="{68748E8C-25EA-4752-88D4-F4DA5F6107B0}"/>
               </a:ext>
             </a:extLst>
           </p:cNvPr>
@@ -10313,7 +10313,7 @@
           <p:cNvPr id="5" name="">
             <a:extLst xmlns:a="http://schemas.openxmlformats.org/drawingml/2006/main">
               <a:ext uri="{FF2B5EF4-FFF2-40B4-BE49-F238E27FC236}">
-                <a16:creationId xmlns:a16="http://schemas.microsoft.com/office/drawing/2014/main" id="{502C7074-0683-44AB-9383-78907D08C7A8}"/>
+                <a16:creationId xmlns:a16="http://schemas.microsoft.com/office/drawing/2014/main" id="{5CB3E775-6172-4C02-AA8B-6D1872799D88}"/>
               </a:ext>
             </a:extLst>
           </p:cNvPr>
@@ -10370,7 +10370,7 @@
           <p:cNvPr id="6" name="">
             <a:extLst xmlns:a="http://schemas.openxmlformats.org/drawingml/2006/main">
               <a:ext uri="{FF2B5EF4-FFF2-40B4-BE49-F238E27FC236}">
-                <a16:creationId xmlns:a16="http://schemas.microsoft.com/office/drawing/2014/main" id="{1C22E110-6183-4E77-8716-E40D406EADA5}"/>
+                <a16:creationId xmlns:a16="http://schemas.microsoft.com/office/drawing/2014/main" id="{20984F67-FB4E-41A6-BAAA-D56E9E0F0141}"/>
               </a:ext>
             </a:extLst>
           </p:cNvPr>
@@ -10427,7 +10427,7 @@
           <p:cNvPr id="7" name="">
             <a:extLst xmlns:a="http://schemas.openxmlformats.org/drawingml/2006/main">
               <a:ext uri="{FF2B5EF4-FFF2-40B4-BE49-F238E27FC236}">
-                <a16:creationId xmlns:a16="http://schemas.microsoft.com/office/drawing/2014/main" id="{74853D72-EAAF-4A17-8A27-BA3C80BA8C60}"/>
+                <a16:creationId xmlns:a16="http://schemas.microsoft.com/office/drawing/2014/main" id="{8534D3E4-C081-4183-BC15-C26D581CF26D}"/>
               </a:ext>
             </a:extLst>
           </p:cNvPr>
@@ -10484,7 +10484,7 @@
           <p:cNvPr id="8" name="">
             <a:extLst xmlns:a="http://schemas.openxmlformats.org/drawingml/2006/main">
               <a:ext uri="{FF2B5EF4-FFF2-40B4-BE49-F238E27FC236}">
-                <a16:creationId xmlns:a16="http://schemas.microsoft.com/office/drawing/2014/main" id="{393D9F22-30CF-4B8E-A482-100FF2ACF7C1}"/>
+                <a16:creationId xmlns:a16="http://schemas.microsoft.com/office/drawing/2014/main" id="{800302EF-2EF1-4A39-968C-82D6A6E83C3F}"/>
               </a:ext>
             </a:extLst>
           </p:cNvPr>
@@ -10539,7 +10539,7 @@
     </p:spTree>
     <p:extLst>
       <p:ext uri="{BB962C8B-B14F-4D97-AF65-F5344CB8AC3E}">
-        <p14:creationId xmlns:p14="http://schemas.microsoft.com/office/powerpoint/2010/main" val="986392704"/>
+        <p14:creationId xmlns:p14="http://schemas.microsoft.com/office/powerpoint/2010/main" val="405503024"/>
       </p:ext>
     </p:extLst>
   </p:cSld>
@@ -10570,7 +10570,7 @@
           <p:cNvPr id="8" name="">
             <a:extLst xmlns:a="http://schemas.openxmlformats.org/drawingml/2006/main">
               <a:ext uri="{FF2B5EF4-FFF2-40B4-BE49-F238E27FC236}">
-                <a16:creationId xmlns:a16="http://schemas.microsoft.com/office/drawing/2014/main" id="{4EC01FE4-6371-4D42-840B-04770F217DDA}"/>
+                <a16:creationId xmlns:a16="http://schemas.microsoft.com/office/drawing/2014/main" id="{C5171D51-D817-414C-8DD5-E32C371BE682}"/>
               </a:ext>
             </a:extLst>
           </p:cNvPr>
@@ -10634,7 +10634,7 @@
         </p:xfrm>
         <a:graphic xmlns:a="http://schemas.openxmlformats.org/drawingml/2006/main">
           <a:graphicData uri="http://schemas.openxmlformats.org/drawingml/2006/chart">
-            <c:chart xmlns:r="http://schemas.openxmlformats.org/officeDocument/2006/relationships" xmlns:c="http://schemas.openxmlformats.org/drawingml/2006/chart" r:id="Rb6f8d6a6d1ed493b"/>
+            <c:chart xmlns:r="http://schemas.openxmlformats.org/officeDocument/2006/relationships" xmlns:c="http://schemas.openxmlformats.org/drawingml/2006/chart" r:id="Rd6ad760abfc443b5"/>
           </a:graphicData>
         </a:graphic>
       </p:graphicFrame>
@@ -10643,7 +10643,7 @@
           <p:cNvPr id="3" name="">
             <a:extLst xmlns:a="http://schemas.openxmlformats.org/drawingml/2006/main">
               <a:ext uri="{FF2B5EF4-FFF2-40B4-BE49-F238E27FC236}">
-                <a16:creationId xmlns:a16="http://schemas.microsoft.com/office/drawing/2014/main" id="{A8F6EA02-C5D5-4868-9054-6F00C485A839}"/>
+                <a16:creationId xmlns:a16="http://schemas.microsoft.com/office/drawing/2014/main" id="{B29C0568-5EDA-4626-AC57-1183DC5B1AAE}"/>
               </a:ext>
             </a:extLst>
           </p:cNvPr>
@@ -10700,7 +10700,7 @@
           <p:cNvPr id="4" name="">
             <a:extLst xmlns:a="http://schemas.openxmlformats.org/drawingml/2006/main">
               <a:ext uri="{FF2B5EF4-FFF2-40B4-BE49-F238E27FC236}">
-                <a16:creationId xmlns:a16="http://schemas.microsoft.com/office/drawing/2014/main" id="{CC1CE53E-06E9-436A-A987-166997582EE4}"/>
+                <a16:creationId xmlns:a16="http://schemas.microsoft.com/office/drawing/2014/main" id="{67B4ED50-031F-41E1-9673-15C2743910B0}"/>
               </a:ext>
             </a:extLst>
           </p:cNvPr>
@@ -10780,7 +10780,7 @@
           <p:cNvPr id="5" name="">
             <a:extLst xmlns:a="http://schemas.openxmlformats.org/drawingml/2006/main">
               <a:ext uri="{FF2B5EF4-FFF2-40B4-BE49-F238E27FC236}">
-                <a16:creationId xmlns:a16="http://schemas.microsoft.com/office/drawing/2014/main" id="{BB34B38C-842A-4DBA-89C2-44F2776F2495}"/>
+                <a16:creationId xmlns:a16="http://schemas.microsoft.com/office/drawing/2014/main" id="{3497F813-59C8-4096-A4C0-2F73BBF97134}"/>
               </a:ext>
             </a:extLst>
           </p:cNvPr>
@@ -10860,7 +10860,7 @@
           <p:cNvPr id="6" name="">
             <a:extLst xmlns:a="http://schemas.openxmlformats.org/drawingml/2006/main">
               <a:ext uri="{FF2B5EF4-FFF2-40B4-BE49-F238E27FC236}">
-                <a16:creationId xmlns:a16="http://schemas.microsoft.com/office/drawing/2014/main" id="{3B97EB15-DC2E-44D3-A4A1-CB061C610A70}"/>
+                <a16:creationId xmlns:a16="http://schemas.microsoft.com/office/drawing/2014/main" id="{C31A5EC9-BFC2-4049-9C29-30116DA4E32F}"/>
               </a:ext>
             </a:extLst>
           </p:cNvPr>
@@ -10917,7 +10917,7 @@
           <p:cNvPr id="7" name="">
             <a:extLst xmlns:a="http://schemas.openxmlformats.org/drawingml/2006/main">
               <a:ext uri="{FF2B5EF4-FFF2-40B4-BE49-F238E27FC236}">
-                <a16:creationId xmlns:a16="http://schemas.microsoft.com/office/drawing/2014/main" id="{48D4912E-8DFA-48A2-A9AB-6ABF51316AE5}"/>
+                <a16:creationId xmlns:a16="http://schemas.microsoft.com/office/drawing/2014/main" id="{405D396A-625C-477A-A610-AFB4DB8F6C8A}"/>
               </a:ext>
             </a:extLst>
           </p:cNvPr>
@@ -10972,7 +10972,7 @@
     </p:spTree>
     <p:extLst>
       <p:ext uri="{BB962C8B-B14F-4D97-AF65-F5344CB8AC3E}">
-        <p14:creationId xmlns:p14="http://schemas.microsoft.com/office/powerpoint/2010/main" val="90987970"/>
+        <p14:creationId xmlns:p14="http://schemas.microsoft.com/office/powerpoint/2010/main" val="99444501"/>
       </p:ext>
     </p:extLst>
   </p:cSld>
@@ -11003,7 +11003,7 @@
           <p:cNvPr id="5" name="">
             <a:extLst xmlns:a="http://schemas.openxmlformats.org/drawingml/2006/main">
               <a:ext uri="{FF2B5EF4-FFF2-40B4-BE49-F238E27FC236}">
-                <a16:creationId xmlns:a16="http://schemas.microsoft.com/office/drawing/2014/main" id="{4A298DE7-F315-4472-9FED-FE30FE0DDB0D}"/>
+                <a16:creationId xmlns:a16="http://schemas.microsoft.com/office/drawing/2014/main" id="{BBB8F3F3-37C9-4CD7-A0A2-04B1C268EA43}"/>
               </a:ext>
             </a:extLst>
           </p:cNvPr>
@@ -11332,7 +11332,7 @@
           <p:cNvPr id="3" name="">
             <a:extLst xmlns:a="http://schemas.openxmlformats.org/drawingml/2006/main">
               <a:ext uri="{FF2B5EF4-FFF2-40B4-BE49-F238E27FC236}">
-                <a16:creationId xmlns:a16="http://schemas.microsoft.com/office/drawing/2014/main" id="{3BCE3203-3EDA-4CC4-8D7B-FE5FA6EA863A}"/>
+                <a16:creationId xmlns:a16="http://schemas.microsoft.com/office/drawing/2014/main" id="{31D6B961-B01E-4AF7-BD09-F4986991E6EC}"/>
               </a:ext>
             </a:extLst>
           </p:cNvPr>
@@ -11389,7 +11389,7 @@
           <p:cNvPr id="4" name="">
             <a:extLst xmlns:a="http://schemas.openxmlformats.org/drawingml/2006/main">
               <a:ext uri="{FF2B5EF4-FFF2-40B4-BE49-F238E27FC236}">
-                <a16:creationId xmlns:a16="http://schemas.microsoft.com/office/drawing/2014/main" id="{089925E3-3FEA-4E5A-9D4A-75CED92F3308}"/>
+                <a16:creationId xmlns:a16="http://schemas.microsoft.com/office/drawing/2014/main" id="{88BA48AB-6B3D-42F6-B35B-63B7F3EFD716}"/>
               </a:ext>
             </a:extLst>
           </p:cNvPr>
@@ -11444,7 +11444,7 @@
     </p:spTree>
     <p:extLst>
       <p:ext uri="{BB962C8B-B14F-4D97-AF65-F5344CB8AC3E}">
-        <p14:creationId xmlns:p14="http://schemas.microsoft.com/office/powerpoint/2010/main" val="506707778"/>
+        <p14:creationId xmlns:p14="http://schemas.microsoft.com/office/powerpoint/2010/main" val="330615068"/>
       </p:ext>
     </p:extLst>
   </p:cSld>
@@ -11475,7 +11475,7 @@
           <p:cNvPr id="12" name="">
             <a:extLst xmlns:a="http://schemas.openxmlformats.org/drawingml/2006/main">
               <a:ext uri="{FF2B5EF4-FFF2-40B4-BE49-F238E27FC236}">
-                <a16:creationId xmlns:a16="http://schemas.microsoft.com/office/drawing/2014/main" id="{9B3105E5-B272-416A-8144-13591C28BDB1}"/>
+                <a16:creationId xmlns:a16="http://schemas.microsoft.com/office/drawing/2014/main" id="{437CEA1F-FFD2-4C20-B4EC-8B93C952BCD4}"/>
               </a:ext>
             </a:extLst>
           </p:cNvPr>
@@ -11555,7 +11555,7 @@
           <p:cNvPr id="2" name="">
             <a:extLst xmlns:a="http://schemas.openxmlformats.org/drawingml/2006/main">
               <a:ext uri="{FF2B5EF4-FFF2-40B4-BE49-F238E27FC236}">
-                <a16:creationId xmlns:a16="http://schemas.microsoft.com/office/drawing/2014/main" id="{BC8EBB48-38B0-47C3-9827-274C463F46B2}"/>
+                <a16:creationId xmlns:a16="http://schemas.microsoft.com/office/drawing/2014/main" id="{133B3C98-F693-46FA-B8BD-2BC47A278204}"/>
               </a:ext>
             </a:extLst>
           </p:cNvPr>
@@ -11612,7 +11612,7 @@
           <p:cNvPr id="3" name="">
             <a:extLst xmlns:a="http://schemas.openxmlformats.org/drawingml/2006/main">
               <a:ext uri="{FF2B5EF4-FFF2-40B4-BE49-F238E27FC236}">
-                <a16:creationId xmlns:a16="http://schemas.microsoft.com/office/drawing/2014/main" id="{770212E7-9B90-4886-9F26-AD32C4883751}"/>
+                <a16:creationId xmlns:a16="http://schemas.microsoft.com/office/drawing/2014/main" id="{F846A056-F2DB-4ADD-837C-70C11E55AD43}"/>
               </a:ext>
             </a:extLst>
           </p:cNvPr>
@@ -11692,7 +11692,7 @@
           <p:cNvPr id="4" name="">
             <a:extLst xmlns:a="http://schemas.openxmlformats.org/drawingml/2006/main">
               <a:ext uri="{FF2B5EF4-FFF2-40B4-BE49-F238E27FC236}">
-                <a16:creationId xmlns:a16="http://schemas.microsoft.com/office/drawing/2014/main" id="{CCDF1C19-9B4C-49C7-B605-530237577851}"/>
+                <a16:creationId xmlns:a16="http://schemas.microsoft.com/office/drawing/2014/main" id="{80F4E31F-43C0-49F1-9635-97ADA8900720}"/>
               </a:ext>
             </a:extLst>
           </p:cNvPr>
@@ -11749,7 +11749,7 @@
           <p:cNvPr id="5" name="">
             <a:extLst xmlns:a="http://schemas.openxmlformats.org/drawingml/2006/main">
               <a:ext uri="{FF2B5EF4-FFF2-40B4-BE49-F238E27FC236}">
-                <a16:creationId xmlns:a16="http://schemas.microsoft.com/office/drawing/2014/main" id="{265707CC-5C23-43CB-B167-717F25BB2F1A}"/>
+                <a16:creationId xmlns:a16="http://schemas.microsoft.com/office/drawing/2014/main" id="{54A46A15-FF62-4827-B75F-EC354693DD1B}"/>
               </a:ext>
             </a:extLst>
           </p:cNvPr>
@@ -11829,7 +11829,7 @@
           <p:cNvPr id="6" name="">
             <a:extLst xmlns:a="http://schemas.openxmlformats.org/drawingml/2006/main">
               <a:ext uri="{FF2B5EF4-FFF2-40B4-BE49-F238E27FC236}">
-                <a16:creationId xmlns:a16="http://schemas.microsoft.com/office/drawing/2014/main" id="{CC882BA8-FF2F-4B77-ADD0-E772E51D66A1}"/>
+                <a16:creationId xmlns:a16="http://schemas.microsoft.com/office/drawing/2014/main" id="{3719C41D-5FFB-4060-B24A-70AE8012F7B7}"/>
               </a:ext>
             </a:extLst>
           </p:cNvPr>
@@ -11886,7 +11886,7 @@
           <p:cNvPr id="7" name="">
             <a:extLst xmlns:a="http://schemas.openxmlformats.org/drawingml/2006/main">
               <a:ext uri="{FF2B5EF4-FFF2-40B4-BE49-F238E27FC236}">
-                <a16:creationId xmlns:a16="http://schemas.microsoft.com/office/drawing/2014/main" id="{5B90D877-AC9E-4A8F-A42E-568D0A77EFED}"/>
+                <a16:creationId xmlns:a16="http://schemas.microsoft.com/office/drawing/2014/main" id="{156CF968-35ED-4C50-A75A-5C64B149259A}"/>
               </a:ext>
             </a:extLst>
           </p:cNvPr>
@@ -11966,7 +11966,7 @@
           <p:cNvPr id="8" name="">
             <a:extLst xmlns:a="http://schemas.openxmlformats.org/drawingml/2006/main">
               <a:ext uri="{FF2B5EF4-FFF2-40B4-BE49-F238E27FC236}">
-                <a16:creationId xmlns:a16="http://schemas.microsoft.com/office/drawing/2014/main" id="{55885385-CFF6-4D21-8531-DD6CD30AFA27}"/>
+                <a16:creationId xmlns:a16="http://schemas.microsoft.com/office/drawing/2014/main" id="{FAE200A5-848C-4D25-8EBB-B1670988479A}"/>
               </a:ext>
             </a:extLst>
           </p:cNvPr>
@@ -12023,7 +12023,7 @@
           <p:cNvPr id="9" name="">
             <a:extLst xmlns:a="http://schemas.openxmlformats.org/drawingml/2006/main">
               <a:ext uri="{FF2B5EF4-FFF2-40B4-BE49-F238E27FC236}">
-                <a16:creationId xmlns:a16="http://schemas.microsoft.com/office/drawing/2014/main" id="{6757A462-49D8-48FC-9419-CB58425607B0}"/>
+                <a16:creationId xmlns:a16="http://schemas.microsoft.com/office/drawing/2014/main" id="{013069EA-724A-4706-83FF-5CBD36EFA410}"/>
               </a:ext>
             </a:extLst>
           </p:cNvPr>
@@ -12103,7 +12103,7 @@
           <p:cNvPr id="10" name="">
             <a:extLst xmlns:a="http://schemas.openxmlformats.org/drawingml/2006/main">
               <a:ext uri="{FF2B5EF4-FFF2-40B4-BE49-F238E27FC236}">
-                <a16:creationId xmlns:a16="http://schemas.microsoft.com/office/drawing/2014/main" id="{500341B5-79CE-44DA-BDEA-029CB8EACE8A}"/>
+                <a16:creationId xmlns:a16="http://schemas.microsoft.com/office/drawing/2014/main" id="{34CD9C4D-B22E-4C89-9E85-AAD8E6F6A136}"/>
               </a:ext>
             </a:extLst>
           </p:cNvPr>
@@ -12160,7 +12160,7 @@
           <p:cNvPr id="11" name="">
             <a:extLst xmlns:a="http://schemas.openxmlformats.org/drawingml/2006/main">
               <a:ext uri="{FF2B5EF4-FFF2-40B4-BE49-F238E27FC236}">
-                <a16:creationId xmlns:a16="http://schemas.microsoft.com/office/drawing/2014/main" id="{18B0ECD5-C14B-4FDE-9D88-A0CD977CEC9E}"/>
+                <a16:creationId xmlns:a16="http://schemas.microsoft.com/office/drawing/2014/main" id="{CFEE3D13-246B-4AF9-8AF5-1D0D6627A344}"/>
               </a:ext>
             </a:extLst>
           </p:cNvPr>
@@ -12215,7 +12215,7 @@
     </p:spTree>
     <p:extLst>
       <p:ext uri="{BB962C8B-B14F-4D97-AF65-F5344CB8AC3E}">
-        <p14:creationId xmlns:p14="http://schemas.microsoft.com/office/powerpoint/2010/main" val="266570025"/>
+        <p14:creationId xmlns:p14="http://schemas.microsoft.com/office/powerpoint/2010/main" val="25633071"/>
       </p:ext>
     </p:extLst>
   </p:cSld>
@@ -12246,7 +12246,7 @@
           <p:cNvPr id="7" name="">
             <a:extLst xmlns:a="http://schemas.openxmlformats.org/drawingml/2006/main">
               <a:ext uri="{FF2B5EF4-FFF2-40B4-BE49-F238E27FC236}">
-                <a16:creationId xmlns:a16="http://schemas.microsoft.com/office/drawing/2014/main" id="{0D4C1389-D3D3-4D85-8A06-6EE9087CFD0C}"/>
+                <a16:creationId xmlns:a16="http://schemas.microsoft.com/office/drawing/2014/main" id="{DF8D3C19-3AA0-4356-9DCE-96789C330952}"/>
               </a:ext>
             </a:extLst>
           </p:cNvPr>
@@ -12525,7 +12525,7 @@
           <p:cNvPr id="3" name="">
             <a:extLst xmlns:a="http://schemas.openxmlformats.org/drawingml/2006/main">
               <a:ext uri="{FF2B5EF4-FFF2-40B4-BE49-F238E27FC236}">
-                <a16:creationId xmlns:a16="http://schemas.microsoft.com/office/drawing/2014/main" id="{C8F34796-CE33-4AF8-9F80-82EBD7EDE500}"/>
+                <a16:creationId xmlns:a16="http://schemas.microsoft.com/office/drawing/2014/main" id="{DC0CBD80-A5CE-4FCC-9059-C1666C30DABE}"/>
               </a:ext>
             </a:extLst>
           </p:cNvPr>
@@ -12582,7 +12582,7 @@
           <p:cNvPr id="4" name="">
             <a:extLst xmlns:a="http://schemas.openxmlformats.org/drawingml/2006/main">
               <a:ext uri="{FF2B5EF4-FFF2-40B4-BE49-F238E27FC236}">
-                <a16:creationId xmlns:a16="http://schemas.microsoft.com/office/drawing/2014/main" id="{4391535D-14C6-46BF-BE34-3CE6FE0BDC64}"/>
+                <a16:creationId xmlns:a16="http://schemas.microsoft.com/office/drawing/2014/main" id="{65E7D66D-134B-4A72-9780-4C3D2A164AA6}"/>
               </a:ext>
             </a:extLst>
           </p:cNvPr>
@@ -12662,7 +12662,7 @@
           <p:cNvPr id="5" name="">
             <a:extLst xmlns:a="http://schemas.openxmlformats.org/drawingml/2006/main">
               <a:ext uri="{FF2B5EF4-FFF2-40B4-BE49-F238E27FC236}">
-                <a16:creationId xmlns:a16="http://schemas.microsoft.com/office/drawing/2014/main" id="{DE983F14-7692-49BF-94FF-E019774C66EE}"/>
+                <a16:creationId xmlns:a16="http://schemas.microsoft.com/office/drawing/2014/main" id="{D1CD9B29-6F9F-4389-9013-08D59E8162A5}"/>
               </a:ext>
             </a:extLst>
           </p:cNvPr>
@@ -12719,7 +12719,7 @@
           <p:cNvPr id="6" name="">
             <a:extLst xmlns:a="http://schemas.openxmlformats.org/drawingml/2006/main">
               <a:ext uri="{FF2B5EF4-FFF2-40B4-BE49-F238E27FC236}">
-                <a16:creationId xmlns:a16="http://schemas.microsoft.com/office/drawing/2014/main" id="{3E5BC445-A9AA-4CE3-9E7D-147831E341E2}"/>
+                <a16:creationId xmlns:a16="http://schemas.microsoft.com/office/drawing/2014/main" id="{55904BC8-BB83-4CBE-BFC5-559D04E2DEB1}"/>
               </a:ext>
             </a:extLst>
           </p:cNvPr>
@@ -12774,7 +12774,7 @@
     </p:spTree>
     <p:extLst>
       <p:ext uri="{BB962C8B-B14F-4D97-AF65-F5344CB8AC3E}">
-        <p14:creationId xmlns:p14="http://schemas.microsoft.com/office/powerpoint/2010/main" val="473562139"/>
+        <p14:creationId xmlns:p14="http://schemas.microsoft.com/office/powerpoint/2010/main" val="640956263"/>
       </p:ext>
     </p:extLst>
   </p:cSld>
@@ -12805,7 +12805,7 @@
           <p:cNvPr id="9" name="">
             <a:extLst xmlns:a="http://schemas.openxmlformats.org/drawingml/2006/main">
               <a:ext uri="{FF2B5EF4-FFF2-40B4-BE49-F238E27FC236}">
-                <a16:creationId xmlns:a16="http://schemas.microsoft.com/office/drawing/2014/main" id="{75F3256C-8EFF-452C-BFDB-222E8441274F}"/>
+                <a16:creationId xmlns:a16="http://schemas.microsoft.com/office/drawing/2014/main" id="{99F70084-A3F8-43F0-ADED-ACD6B2AEDFCD}"/>
               </a:ext>
             </a:extLst>
           </p:cNvPr>
@@ -12892,7 +12892,7 @@
         </p:xfrm>
         <a:graphic xmlns:a="http://schemas.openxmlformats.org/drawingml/2006/main">
           <a:graphicData uri="http://schemas.openxmlformats.org/drawingml/2006/chart">
-            <c:chart xmlns:r="http://schemas.openxmlformats.org/officeDocument/2006/relationships" xmlns:c="http://schemas.openxmlformats.org/drawingml/2006/chart" r:id="R15be03d8c5f74db7"/>
+            <c:chart xmlns:r="http://schemas.openxmlformats.org/officeDocument/2006/relationships" xmlns:c="http://schemas.openxmlformats.org/drawingml/2006/chart" r:id="R96de10a66f7a488d"/>
           </a:graphicData>
         </a:graphic>
       </p:graphicFrame>
@@ -12901,7 +12901,7 @@
           <p:cNvPr id="3" name="">
             <a:extLst xmlns:a="http://schemas.openxmlformats.org/drawingml/2006/main">
               <a:ext uri="{FF2B5EF4-FFF2-40B4-BE49-F238E27FC236}">
-                <a16:creationId xmlns:a16="http://schemas.microsoft.com/office/drawing/2014/main" id="{FD83EB1E-E855-4E42-B97C-1F06C52A525B}"/>
+                <a16:creationId xmlns:a16="http://schemas.microsoft.com/office/drawing/2014/main" id="{BFE47772-E54A-4FE1-9E32-D9E115287C39}"/>
               </a:ext>
             </a:extLst>
           </p:cNvPr>
@@ -12958,7 +12958,7 @@
           <p:cNvPr id="4" name="">
             <a:extLst xmlns:a="http://schemas.openxmlformats.org/drawingml/2006/main">
               <a:ext uri="{FF2B5EF4-FFF2-40B4-BE49-F238E27FC236}">
-                <a16:creationId xmlns:a16="http://schemas.microsoft.com/office/drawing/2014/main" id="{48FFC972-4E8F-4D24-898C-520FE018AD47}"/>
+                <a16:creationId xmlns:a16="http://schemas.microsoft.com/office/drawing/2014/main" id="{45EF13B4-568B-401B-A07F-3F0737FE8095}"/>
               </a:ext>
             </a:extLst>
           </p:cNvPr>
@@ -13015,7 +13015,7 @@
           <p:cNvPr id="5" name="">
             <a:extLst xmlns:a="http://schemas.openxmlformats.org/drawingml/2006/main">
               <a:ext uri="{FF2B5EF4-FFF2-40B4-BE49-F238E27FC236}">
-                <a16:creationId xmlns:a16="http://schemas.microsoft.com/office/drawing/2014/main" id="{D752A97A-9814-48C0-95F8-7DAD9EFA5CB7}"/>
+                <a16:creationId xmlns:a16="http://schemas.microsoft.com/office/drawing/2014/main" id="{CB8EBE80-54F8-4585-A12B-DB4259734123}"/>
               </a:ext>
             </a:extLst>
           </p:cNvPr>
@@ -13072,7 +13072,7 @@
           <p:cNvPr id="6" name="">
             <a:extLst xmlns:a="http://schemas.openxmlformats.org/drawingml/2006/main">
               <a:ext uri="{FF2B5EF4-FFF2-40B4-BE49-F238E27FC236}">
-                <a16:creationId xmlns:a16="http://schemas.microsoft.com/office/drawing/2014/main" id="{F2EF8CED-F6D5-42F6-B77E-2E26CD497221}"/>
+                <a16:creationId xmlns:a16="http://schemas.microsoft.com/office/drawing/2014/main" id="{2DF14FA9-9A2A-40A3-B466-0701D7D4DE46}"/>
               </a:ext>
             </a:extLst>
           </p:cNvPr>
@@ -13129,7 +13129,7 @@
           <p:cNvPr id="7" name="">
             <a:extLst xmlns:a="http://schemas.openxmlformats.org/drawingml/2006/main">
               <a:ext uri="{FF2B5EF4-FFF2-40B4-BE49-F238E27FC236}">
-                <a16:creationId xmlns:a16="http://schemas.microsoft.com/office/drawing/2014/main" id="{31E0B032-81FB-4197-BF1F-DED122C187D9}"/>
+                <a16:creationId xmlns:a16="http://schemas.microsoft.com/office/drawing/2014/main" id="{137177D3-BC90-44B4-9A0F-F01DF978FEA0}"/>
               </a:ext>
             </a:extLst>
           </p:cNvPr>
@@ -13186,7 +13186,7 @@
           <p:cNvPr id="8" name="">
             <a:extLst xmlns:a="http://schemas.openxmlformats.org/drawingml/2006/main">
               <a:ext uri="{FF2B5EF4-FFF2-40B4-BE49-F238E27FC236}">
-                <a16:creationId xmlns:a16="http://schemas.microsoft.com/office/drawing/2014/main" id="{92FDCE6E-45E7-4056-98E6-C6AB1053CF82}"/>
+                <a16:creationId xmlns:a16="http://schemas.microsoft.com/office/drawing/2014/main" id="{D5EB9667-5118-4B19-8979-16A0DD71E1BA}"/>
               </a:ext>
             </a:extLst>
           </p:cNvPr>
@@ -13241,7 +13241,7 @@
     </p:spTree>
     <p:extLst>
       <p:ext uri="{BB962C8B-B14F-4D97-AF65-F5344CB8AC3E}">
-        <p14:creationId xmlns:p14="http://schemas.microsoft.com/office/powerpoint/2010/main" val="1625477605"/>
+        <p14:creationId xmlns:p14="http://schemas.microsoft.com/office/powerpoint/2010/main" val="1261270232"/>
       </p:ext>
     </p:extLst>
   </p:cSld>

</xml_diff>

<commit_message>
Publish final presentation and verified inference materials
</commit_message>
<xml_diff>
--- a/PIKET_LCT2026.pptx
+++ b/PIKET_LCT2026.pptx
@@ -2,30 +2,30 @@
 <file path=ppt/presentation.xml><?xml version="1.0" encoding="utf-8"?>
 <p:presentation xmlns:p="http://schemas.openxmlformats.org/presentationml/2006/main">
   <p:sldMasterIdLst>
-    <p:sldMasterId xmlns:r="http://schemas.openxmlformats.org/officeDocument/2006/relationships" id="2147483648" r:id="R189507ebe1de472b"/>
+    <p:sldMasterId xmlns:r="http://schemas.openxmlformats.org/officeDocument/2006/relationships" id="2147483648" r:id="R1d41fef24b444935"/>
   </p:sldMasterIdLst>
   <p:notesMasterIdLst>
-    <p:notesMasterId xmlns:r="http://schemas.openxmlformats.org/officeDocument/2006/relationships" r:id="Rfa6c74b8260d4afe"/>
+    <p:notesMasterId xmlns:r="http://schemas.openxmlformats.org/officeDocument/2006/relationships" r:id="Re679dce6bdd84c19"/>
   </p:notesMasterIdLst>
   <p:sldIdLst>
-    <p:sldId xmlns:r="http://schemas.openxmlformats.org/officeDocument/2006/relationships" id="256" r:id="R6660d611b8014919"/>
-    <p:sldId xmlns:r="http://schemas.openxmlformats.org/officeDocument/2006/relationships" id="257" r:id="R1c9c8cea20de4e88"/>
-    <p:sldId xmlns:r="http://schemas.openxmlformats.org/officeDocument/2006/relationships" id="258" r:id="R3ce1ee9ed41c4ebb"/>
-    <p:sldId xmlns:r="http://schemas.openxmlformats.org/officeDocument/2006/relationships" id="259" r:id="R5712e11238144280"/>
-    <p:sldId xmlns:r="http://schemas.openxmlformats.org/officeDocument/2006/relationships" id="260" r:id="R6af7f82d6d9a4e21"/>
-    <p:sldId xmlns:r="http://schemas.openxmlformats.org/officeDocument/2006/relationships" id="261" r:id="Rf60c7ed14b004259"/>
-    <p:sldId xmlns:r="http://schemas.openxmlformats.org/officeDocument/2006/relationships" id="262" r:id="R309fa09281d84e8f"/>
-    <p:sldId xmlns:r="http://schemas.openxmlformats.org/officeDocument/2006/relationships" id="263" r:id="R0481d5474c5e4311"/>
-    <p:sldId xmlns:r="http://schemas.openxmlformats.org/officeDocument/2006/relationships" id="264" r:id="Reacb8753f12a4a02"/>
-    <p:sldId xmlns:r="http://schemas.openxmlformats.org/officeDocument/2006/relationships" id="265" r:id="R148cc4e067a74bba"/>
-    <p:sldId xmlns:r="http://schemas.openxmlformats.org/officeDocument/2006/relationships" id="266" r:id="R31b3cd5de90d4dfe"/>
-    <p:sldId xmlns:r="http://schemas.openxmlformats.org/officeDocument/2006/relationships" id="267" r:id="Ref0a66fff6e04e9d"/>
-    <p:sldId xmlns:r="http://schemas.openxmlformats.org/officeDocument/2006/relationships" id="268" r:id="Ra3aeb9a51b534a3a"/>
-    <p:sldId xmlns:r="http://schemas.openxmlformats.org/officeDocument/2006/relationships" id="269" r:id="R98ccf95b058f43d1"/>
-    <p:sldId xmlns:r="http://schemas.openxmlformats.org/officeDocument/2006/relationships" id="270" r:id="R41d7ef3640ab408a"/>
-    <p:sldId xmlns:r="http://schemas.openxmlformats.org/officeDocument/2006/relationships" id="271" r:id="R1f14620171824ac2"/>
-    <p:sldId xmlns:r="http://schemas.openxmlformats.org/officeDocument/2006/relationships" id="272" r:id="R4c1cbf84695a4cc4"/>
-    <p:sldId xmlns:r="http://schemas.openxmlformats.org/officeDocument/2006/relationships" id="273" r:id="R3bf0f47578ee4b0e"/>
+    <p:sldId xmlns:r="http://schemas.openxmlformats.org/officeDocument/2006/relationships" id="256" r:id="Rd759e8f25d964126"/>
+    <p:sldId xmlns:r="http://schemas.openxmlformats.org/officeDocument/2006/relationships" id="257" r:id="Rb898dc4164934313"/>
+    <p:sldId xmlns:r="http://schemas.openxmlformats.org/officeDocument/2006/relationships" id="258" r:id="R3983b401aa9244dc"/>
+    <p:sldId xmlns:r="http://schemas.openxmlformats.org/officeDocument/2006/relationships" id="259" r:id="R5e2e211206944664"/>
+    <p:sldId xmlns:r="http://schemas.openxmlformats.org/officeDocument/2006/relationships" id="260" r:id="Rea6c42303b2a4362"/>
+    <p:sldId xmlns:r="http://schemas.openxmlformats.org/officeDocument/2006/relationships" id="261" r:id="R7f2d83d8ecdf45fb"/>
+    <p:sldId xmlns:r="http://schemas.openxmlformats.org/officeDocument/2006/relationships" id="262" r:id="R7d5e2774726f4dea"/>
+    <p:sldId xmlns:r="http://schemas.openxmlformats.org/officeDocument/2006/relationships" id="263" r:id="R63db7a55186b4aeb"/>
+    <p:sldId xmlns:r="http://schemas.openxmlformats.org/officeDocument/2006/relationships" id="264" r:id="R389862309a164791"/>
+    <p:sldId xmlns:r="http://schemas.openxmlformats.org/officeDocument/2006/relationships" id="265" r:id="Rb8078ea735ea44de"/>
+    <p:sldId xmlns:r="http://schemas.openxmlformats.org/officeDocument/2006/relationships" id="266" r:id="R29f41c9fec5d4690"/>
+    <p:sldId xmlns:r="http://schemas.openxmlformats.org/officeDocument/2006/relationships" id="267" r:id="Ra6e6a76d69e945c3"/>
+    <p:sldId xmlns:r="http://schemas.openxmlformats.org/officeDocument/2006/relationships" id="268" r:id="R25171afd1d314030"/>
+    <p:sldId xmlns:r="http://schemas.openxmlformats.org/officeDocument/2006/relationships" id="269" r:id="R68faa96239ae487a"/>
+    <p:sldId xmlns:r="http://schemas.openxmlformats.org/officeDocument/2006/relationships" id="270" r:id="Rd10de3d7feae4056"/>
+    <p:sldId xmlns:r="http://schemas.openxmlformats.org/officeDocument/2006/relationships" id="271" r:id="R8d80ebfc02f04fcc"/>
+    <p:sldId xmlns:r="http://schemas.openxmlformats.org/officeDocument/2006/relationships" id="272" r:id="Rd4912a4a78b14b6a"/>
+    <p:sldId xmlns:r="http://schemas.openxmlformats.org/officeDocument/2006/relationships" id="273" r:id="R992f946130004113"/>
   </p:sldIdLst>
   <p:sldSz cx="12192000" cy="6858000"/>
   <p:notesSz cx="6858000" cy="9144000"/>
@@ -175,9 +175,9 @@
 </file>
 
 <file path=ppt/notesMasters/theme/theme3.xml><?xml version="1.0" encoding="utf-8"?>
-<a:theme xmlns:a="http://schemas.openxmlformats.org/drawingml/2006/main" name="ChatGPT">
+<a:theme xmlns:a="http://schemas.openxmlformats.org/drawingml/2006/main" name="PIKET">
   <a:themeElements>
-    <a:clrScheme name="ChatGPT">
+    <a:clrScheme name="PIKET">
       <a:dk1>
         <a:srgbClr val="000000"/>
       </a:dk1>
@@ -227,7 +227,7 @@
         <a:cs typeface="Calibri"/>
       </a:minorFont>
     </a:fontScheme>
-    <a:fmtScheme name="ChatGPT">
+    <a:fmtScheme name="PIKET">
       <a:fillStyleLst>
         <a:solidFill>
           <a:schemeClr val="phClr"/>
@@ -529,7 +529,7 @@
           <a:lstStyle xmlns:a="http://schemas.openxmlformats.org/drawingml/2006/main"/>
           <a:p xmlns:a="http://schemas.openxmlformats.org/drawingml/2006/main">
             <a:r>
-              <a:t>Источники api/routes_work_orders.py, api/static/piket.js, api/static/demo.js. Публичный прототип показывает реальный архивный срез на 29.03.2026 и сохраняет решения локально в браузере. Серверный контур имеет собственные роли и историю заявок. Новый исследовательский ансамбль пока не подключён к API.</a:t>
+              <a:t>Источник prototype/inference/model.json, schema.json, parity.json. Скриншот docs/prototype/forecast-top.png. В браузере исполняются все 8 моделей: 5 LightGBM, CatBoost, Extra Trees, Logistic. Вход CSV: 178 признаков и дата. Архивный пример содержит 26 строк 01.06.2026, первая по рангу 672-1 получила 0.5958. CSV не передаётся на сервер. Версия piket-eight-2026-06 обучена по 16.05.2026 и применяется с 01.06.2026. Балл не равен подтверждённому событию.</a:t>
             </a:r>
           </a:p>
         </p:txBody>
@@ -949,7 +949,7 @@
           <a:lstStyle xmlns:a="http://schemas.openxmlformats.org/drawingml/2006/main"/>
           <a:p xmlns:a="http://schemas.openxmlformats.org/drawingml/2006/main">
             <a:r>
-              <a:t>Источники README.md, api/main.py, api/routes_work_orders.py, models/production.json. Исследовательский ансамбль пока не заменил production bundle. Для промышленного внедрения необходимы новый закрытый период, интеграция inference и признаки свежести.</a:t>
+              <a:t>Источники prototype/inference/model.json, schema.json, parity.json. Проверка на 783 строках, включая неизвестную группу, все числовые значения пропущены или равны нулю. Максимальное абсолютное отклонение 3.885780586188048e-16 при допуске 1e-10. Это численное соответствие реализаций, не качество предсказания. Метрики H1 2026 получены с ежемесячным переобучением, не являются новой оценкой фиксированной июньской версии.</a:t>
             </a:r>
           </a:p>
         </p:txBody>
@@ -1299,7 +1299,7 @@
           <a:lstStyle xmlns:a="http://schemas.openxmlformats.org/drawingml/2006/main"/>
           <a:p xmlns:a="http://schemas.openxmlformats.org/drawingml/2006/main">
             <a:r>
-              <a:t>Скриншот docs/prototype/real-desktop.png. Настоящий исторический срез на 29.03.2026: 26 групп и сохранённые прогнозы ансамбля восьми моделей. Группа 553-1 получила предложенный моделью черновик. Решения сохраняются локально в браузере, фактические выезды не создаются.</a:t>
+              <a:t>Скриншот docs/prototype/editorial-desktop.png. Настоящий исторический срез на 29.03.2026: 26 групп и сохранённые прогнозы ансамбля восьми моделей. Группа 553-1 получила предложенный моделью черновик. Решения сохраняются локально в браузере, фактические выезды не создаются.</a:t>
             </a:r>
           </a:p>
         </p:txBody>
@@ -1717,7 +1717,7 @@
   </p:cSld>
   <p:clrMap bg1="lt1" tx1="dk1" bg2="lt2" tx2="dk2" accent1="accent1" accent2="accent2" accent3="accent3" accent4="accent4" accent5="accent5" accent6="accent6" hlink="hlink" folHlink="folHlink"/>
   <p:sldLayoutIdLst>
-    <p:sldLayoutId xmlns:r="http://schemas.openxmlformats.org/officeDocument/2006/relationships" id="2147483649" r:id="R657776b0b63849f1"/>
+    <p:sldLayoutId xmlns:r="http://schemas.openxmlformats.org/officeDocument/2006/relationships" id="2147483649" r:id="Re1be4a6597a4475a"/>
   </p:sldLayoutIdLst>
   <p:txStyles>
     <p:titleStyle>
@@ -2000,9 +2000,9 @@
 </file>
 
 <file path=ppt/slideMasters/theme/theme2.xml><?xml version="1.0" encoding="utf-8"?>
-<a:theme xmlns:a="http://schemas.openxmlformats.org/drawingml/2006/main" name="ChatGPT">
+<a:theme xmlns:a="http://schemas.openxmlformats.org/drawingml/2006/main" name="PIKET">
   <a:themeElements>
-    <a:clrScheme name="ChatGPT">
+    <a:clrScheme name="PIKET">
       <a:dk1>
         <a:srgbClr val="000000"/>
       </a:dk1>
@@ -2052,7 +2052,7 @@
         <a:cs typeface="Calibri"/>
       </a:minorFont>
     </a:fontScheme>
-    <a:fmtScheme name="ChatGPT">
+    <a:fmtScheme name="PIKET">
       <a:fillStyleLst>
         <a:solidFill>
           <a:schemeClr val="phClr"/>
@@ -3351,7 +3351,7 @@
           <p:nvPr/>
         </p:nvPicPr>
         <p:blipFill>
-          <a:blip xmlns:r="http://schemas.openxmlformats.org/officeDocument/2006/relationships" xmlns:a="http://schemas.openxmlformats.org/drawingml/2006/main" r:embed="R2a4c8cde6a384cea"/>
+          <a:blip xmlns:r="http://schemas.openxmlformats.org/officeDocument/2006/relationships" xmlns:a="http://schemas.openxmlformats.org/drawingml/2006/main" r:embed="R04ebdc0c7e1d4d31"/>
           <a:stretch xmlns:a="http://schemas.openxmlformats.org/drawingml/2006/main"/>
         </p:blipFill>
         <p:spPr>
@@ -3369,7 +3369,7 @@
           <p:cNvPr id="2" name="">
             <a:extLst xmlns:a="http://schemas.openxmlformats.org/drawingml/2006/main">
               <a:ext uri="{FF2B5EF4-FFF2-40B4-BE49-F238E27FC236}">
-                <a16:creationId xmlns:a16="http://schemas.microsoft.com/office/drawing/2014/main" id="{E435BDA5-8B39-4369-A00B-1084028B4120}"/>
+                <a16:creationId xmlns:a16="http://schemas.microsoft.com/office/drawing/2014/main" id="{5410835A-56F1-4C1B-BBA3-D2B304F2911B}"/>
               </a:ext>
             </a:extLst>
           </p:cNvPr>
@@ -3426,7 +3426,7 @@
           <p:cNvPr id="3" name="">
             <a:extLst xmlns:a="http://schemas.openxmlformats.org/drawingml/2006/main">
               <a:ext uri="{FF2B5EF4-FFF2-40B4-BE49-F238E27FC236}">
-                <a16:creationId xmlns:a16="http://schemas.microsoft.com/office/drawing/2014/main" id="{3AA55EB5-91F8-43FD-8D9A-48FF3306D9F3}"/>
+                <a16:creationId xmlns:a16="http://schemas.microsoft.com/office/drawing/2014/main" id="{6EE294CE-6C59-427F-992C-99A82723494B}"/>
               </a:ext>
             </a:extLst>
           </p:cNvPr>
@@ -3483,7 +3483,7 @@
           <p:cNvPr id="4" name="">
             <a:extLst xmlns:a="http://schemas.openxmlformats.org/drawingml/2006/main">
               <a:ext uri="{FF2B5EF4-FFF2-40B4-BE49-F238E27FC236}">
-                <a16:creationId xmlns:a16="http://schemas.microsoft.com/office/drawing/2014/main" id="{F646377C-BC70-4845-96F1-10AE608A2B2C}"/>
+                <a16:creationId xmlns:a16="http://schemas.microsoft.com/office/drawing/2014/main" id="{A47E8E80-18B1-4A38-9825-F21470F3474D}"/>
               </a:ext>
             </a:extLst>
           </p:cNvPr>
@@ -3563,7 +3563,7 @@
           <p:cNvPr id="5" name="">
             <a:extLst xmlns:a="http://schemas.openxmlformats.org/drawingml/2006/main">
               <a:ext uri="{FF2B5EF4-FFF2-40B4-BE49-F238E27FC236}">
-                <a16:creationId xmlns:a16="http://schemas.microsoft.com/office/drawing/2014/main" id="{F25AEA3C-05D6-481D-AF95-931993D0689A}"/>
+                <a16:creationId xmlns:a16="http://schemas.microsoft.com/office/drawing/2014/main" id="{DD6C35B2-3DF5-4F4E-A850-8DB0F7EF9AAF}"/>
               </a:ext>
             </a:extLst>
           </p:cNvPr>
@@ -3641,7 +3641,7 @@
     </p:spTree>
     <p:extLst>
       <p:ext uri="{BB962C8B-B14F-4D97-AF65-F5344CB8AC3E}">
-        <p14:creationId xmlns:p14="http://schemas.microsoft.com/office/powerpoint/2010/main" val="182670903"/>
+        <p14:creationId xmlns:p14="http://schemas.microsoft.com/office/powerpoint/2010/main" val="93319800"/>
       </p:ext>
     </p:extLst>
   </p:cSld>
@@ -3669,10 +3669,10 @@
       </p:grpSpPr>
       <p:sp>
         <p:nvSpPr>
-          <p:cNvPr id="9" name="">
+          <p:cNvPr id="8" name="">
             <a:extLst xmlns:a="http://schemas.openxmlformats.org/drawingml/2006/main">
               <a:ext uri="{FF2B5EF4-FFF2-40B4-BE49-F238E27FC236}">
-                <a16:creationId xmlns:a16="http://schemas.microsoft.com/office/drawing/2014/main" id="{0D7032D8-D62E-4FCE-A165-86D80FB30C9A}"/>
+                <a16:creationId xmlns:a16="http://schemas.microsoft.com/office/drawing/2014/main" id="{869E1933-50D1-4ABF-9E83-6150C9810F01}"/>
               </a:ext>
             </a:extLst>
           </p:cNvPr>
@@ -3719,50 +3719,27 @@
                 <a:ea typeface="Arial"/>
                 <a:cs typeface="Arial"/>
               </a:rPr>
-              <a:t>Прогноз заканчивается</a:t>
-            </a:r>
-          </a:p>
-          <a:p xmlns:a="http://schemas.openxmlformats.org/drawingml/2006/main">
-            <a:pPr>
-              <a:defRPr sz="3600" b="1">
-                <a:solidFill>
-                  <a:srgbClr val="183C30"/>
-                </a:solidFill>
-                <a:latin typeface="Arial"/>
-                <a:ea typeface="Arial"/>
-                <a:cs typeface="Arial"/>
-              </a:defRPr>
-            </a:pPr>
-            <a:r>
-              <a:rPr sz="3600" b="1">
-                <a:solidFill>
-                  <a:srgbClr val="183C30"/>
-                </a:solidFill>
-                <a:latin typeface="Arial"/>
-                <a:ea typeface="Arial"/>
-                <a:cs typeface="Arial"/>
-              </a:rPr>
-              <a:t>решением диспетчера</a:t>
+              <a:t>Настоящий расчёт по вашему CSV</a:t>
             </a:r>
           </a:p>
         </p:txBody>
       </p:sp>
       <p:pic>
         <p:nvPicPr>
-          <p:cNvPr id="10" name=""/>
+          <p:cNvPr id="9" name=""/>
           <p:cNvPicPr>
             <a:picLocks xmlns:a="http://schemas.openxmlformats.org/drawingml/2006/main" noChangeAspect="1"/>
           </p:cNvPicPr>
           <p:nvPr/>
         </p:nvPicPr>
         <p:blipFill>
-          <a:blip xmlns:r="http://schemas.openxmlformats.org/officeDocument/2006/relationships" xmlns:a="http://schemas.openxmlformats.org/drawingml/2006/main" r:embed="R6fd3b971986d481b"/>
+          <a:blip xmlns:r="http://schemas.openxmlformats.org/officeDocument/2006/relationships" xmlns:a="http://schemas.openxmlformats.org/drawingml/2006/main" r:embed="R0d9649cc961b4781"/>
           <a:stretch xmlns:a="http://schemas.openxmlformats.org/drawingml/2006/main"/>
         </p:blipFill>
         <p:spPr>
           <a:xfrm xmlns:a="http://schemas.openxmlformats.org/drawingml/2006/main">
-            <a:off x="738086" y="1790700"/>
-            <a:ext cx="2029028" cy="4391025"/>
+            <a:off x="4726686" y="1504950"/>
+            <a:ext cx="6967728" cy="4838700"/>
           </a:xfrm>
           <a:prstGeom xmlns:a="http://schemas.openxmlformats.org/drawingml/2006/main" prst="rect">
             <a:avLst/>
@@ -3774,7 +3751,7 @@
           <p:cNvPr id="3" name="">
             <a:extLst xmlns:a="http://schemas.openxmlformats.org/drawingml/2006/main">
               <a:ext uri="{FF2B5EF4-FFF2-40B4-BE49-F238E27FC236}">
-                <a16:creationId xmlns:a16="http://schemas.microsoft.com/office/drawing/2014/main" id="{032385C5-3604-48FF-AB06-31FCC7B299E3}"/>
+                <a16:creationId xmlns:a16="http://schemas.microsoft.com/office/drawing/2014/main" id="{9695BA6D-3CF4-439B-86B5-0E714B7DEEE5}"/>
               </a:ext>
             </a:extLst>
           </p:cNvPr>
@@ -3785,8 +3762,8 @@
         </p:nvSpPr>
         <p:spPr>
           <a:xfrm xmlns:a="http://schemas.openxmlformats.org/drawingml/2006/main">
-            <a:off x="3762375" y="1952625"/>
-            <a:ext cx="7629525" cy="676275"/>
+            <a:off x="609600" y="1952625"/>
+            <a:ext cx="3952875" cy="828675"/>
           </a:xfrm>
           <a:prstGeom xmlns:a="http://schemas.openxmlformats.org/drawingml/2006/main" prst="rect">
             <a:avLst/>
@@ -3803,7 +3780,7 @@
           <a:lstStyle xmlns:a="http://schemas.openxmlformats.org/drawingml/2006/main"/>
           <a:p xmlns:a="http://schemas.openxmlformats.org/drawingml/2006/main">
             <a:pPr>
-              <a:defRPr sz="2850" b="1">
+              <a:defRPr sz="3825" b="1">
                 <a:solidFill>
                   <a:srgbClr val="183C30"/>
                 </a:solidFill>
@@ -3813,7 +3790,7 @@
               </a:defRPr>
             </a:pPr>
             <a:r>
-              <a:rPr sz="2850" b="1">
+              <a:rPr sz="3825" b="1">
                 <a:solidFill>
                   <a:srgbClr val="183C30"/>
                 </a:solidFill>
@@ -3821,7 +3798,7 @@
                 <a:ea typeface="Arial"/>
                 <a:cs typeface="Arial"/>
               </a:rPr>
-              <a:t>Проверка имеет владельца</a:t>
+              <a:t>8 моделей</a:t>
             </a:r>
           </a:p>
         </p:txBody>
@@ -3831,7 +3808,7 @@
           <p:cNvPr id="4" name="">
             <a:extLst xmlns:a="http://schemas.openxmlformats.org/drawingml/2006/main">
               <a:ext uri="{FF2B5EF4-FFF2-40B4-BE49-F238E27FC236}">
-                <a16:creationId xmlns:a16="http://schemas.microsoft.com/office/drawing/2014/main" id="{B512AB7B-E9A7-47BE-B13B-F61BDBF39110}"/>
+                <a16:creationId xmlns:a16="http://schemas.microsoft.com/office/drawing/2014/main" id="{E0056B49-BFB2-44FE-9BA2-8830A6C53F9B}"/>
               </a:ext>
             </a:extLst>
           </p:cNvPr>
@@ -3842,8 +3819,8 @@
         </p:nvSpPr>
         <p:spPr>
           <a:xfrm xmlns:a="http://schemas.openxmlformats.org/drawingml/2006/main">
-            <a:off x="3810000" y="2867025"/>
-            <a:ext cx="7381875" cy="1028700"/>
+            <a:off x="609600" y="3228975"/>
+            <a:ext cx="3952875" cy="828675"/>
           </a:xfrm>
           <a:prstGeom xmlns:a="http://schemas.openxmlformats.org/drawingml/2006/main" prst="rect">
             <a:avLst/>
@@ -3860,9 +3837,9 @@
           <a:lstStyle xmlns:a="http://schemas.openxmlformats.org/drawingml/2006/main"/>
           <a:p xmlns:a="http://schemas.openxmlformats.org/drawingml/2006/main">
             <a:pPr>
-              <a:defRPr sz="2325" b="0">
-                <a:solidFill>
-                  <a:srgbClr val="65766B"/>
+              <a:defRPr sz="3225" b="1">
+                <a:solidFill>
+                  <a:srgbClr val="183C30"/>
                 </a:solidFill>
                 <a:latin typeface="Arial"/>
                 <a:ea typeface="Arial"/>
@@ -3870,38 +3847,15 @@
               </a:defRPr>
             </a:pPr>
             <a:r>
-              <a:rPr sz="2325" b="0">
-                <a:solidFill>
-                  <a:srgbClr val="65766B"/>
+              <a:rPr sz="3225" b="1">
+                <a:solidFill>
+                  <a:srgbClr val="183C30"/>
                 </a:solidFill>
                 <a:latin typeface="Arial"/>
                 <a:ea typeface="Arial"/>
                 <a:cs typeface="Arial"/>
               </a:rPr>
-              <a:t>Сотрудник подтверждает заявку,</a:t>
-            </a:r>
-          </a:p>
-          <a:p xmlns:a="http://schemas.openxmlformats.org/drawingml/2006/main">
-            <a:pPr>
-              <a:defRPr sz="2325" b="0">
-                <a:solidFill>
-                  <a:srgbClr val="65766B"/>
-                </a:solidFill>
-                <a:latin typeface="Arial"/>
-                <a:ea typeface="Arial"/>
-                <a:cs typeface="Arial"/>
-              </a:defRPr>
-            </a:pPr>
-            <a:r>
-              <a:rPr sz="2325" b="0">
-                <a:solidFill>
-                  <a:srgbClr val="65766B"/>
-                </a:solidFill>
-                <a:latin typeface="Arial"/>
-                <a:ea typeface="Arial"/>
-                <a:cs typeface="Arial"/>
-              </a:rPr>
-              <a:t>видит основания и фиксирует результат.</a:t>
+              <a:t>178 признаков</a:t>
             </a:r>
           </a:p>
         </p:txBody>
@@ -3911,7 +3865,7 @@
           <p:cNvPr id="5" name="">
             <a:extLst xmlns:a="http://schemas.openxmlformats.org/drawingml/2006/main">
               <a:ext uri="{FF2B5EF4-FFF2-40B4-BE49-F238E27FC236}">
-                <a16:creationId xmlns:a16="http://schemas.microsoft.com/office/drawing/2014/main" id="{698FACB5-CF59-43F2-A65C-424F85E4B3B7}"/>
+                <a16:creationId xmlns:a16="http://schemas.microsoft.com/office/drawing/2014/main" id="{7ECF7FFE-5E3D-4708-B52F-469652613D29}"/>
               </a:ext>
             </a:extLst>
           </p:cNvPr>
@@ -3922,8 +3876,8 @@
         </p:nvSpPr>
         <p:spPr>
           <a:xfrm xmlns:a="http://schemas.openxmlformats.org/drawingml/2006/main">
-            <a:off x="3762375" y="4438650"/>
-            <a:ext cx="7686675" cy="904875"/>
+            <a:off x="647700" y="4648200"/>
+            <a:ext cx="3857625" cy="1276350"/>
           </a:xfrm>
           <a:prstGeom xmlns:a="http://schemas.openxmlformats.org/drawingml/2006/main" prst="rect">
             <a:avLst/>
@@ -3940,7 +3894,7 @@
           <a:lstStyle xmlns:a="http://schemas.openxmlformats.org/drawingml/2006/main"/>
           <a:p xmlns:a="http://schemas.openxmlformats.org/drawingml/2006/main">
             <a:pPr>
-              <a:defRPr sz="2625" b="1">
+              <a:defRPr sz="2775" b="1">
                 <a:solidFill>
                   <a:srgbClr val="183C30"/>
                 </a:solidFill>
@@ -3950,7 +3904,7 @@
               </a:defRPr>
             </a:pPr>
             <a:r>
-              <a:rPr sz="2625" b="1">
+              <a:rPr sz="2775" b="1">
                 <a:solidFill>
                   <a:srgbClr val="183C30"/>
                 </a:solidFill>
@@ -3958,7 +3912,30 @@
                 <a:ea typeface="Arial"/>
                 <a:cs typeface="Arial"/>
               </a:rPr>
-              <a:t>Результат осмотра станет новой меткой</a:t>
+              <a:t>Файл остаётся</a:t>
+            </a:r>
+          </a:p>
+          <a:p xmlns:a="http://schemas.openxmlformats.org/drawingml/2006/main">
+            <a:pPr>
+              <a:defRPr sz="2775" b="1">
+                <a:solidFill>
+                  <a:srgbClr val="183C30"/>
+                </a:solidFill>
+                <a:latin typeface="Arial"/>
+                <a:ea typeface="Arial"/>
+                <a:cs typeface="Arial"/>
+              </a:defRPr>
+            </a:pPr>
+            <a:r>
+              <a:rPr sz="2775" b="1">
+                <a:solidFill>
+                  <a:srgbClr val="183C30"/>
+                </a:solidFill>
+                <a:latin typeface="Arial"/>
+                <a:ea typeface="Arial"/>
+                <a:cs typeface="Arial"/>
+              </a:rPr>
+              <a:t>в браузере</a:t>
             </a:r>
           </a:p>
         </p:txBody>
@@ -3968,64 +3945,7 @@
           <p:cNvPr id="6" name="">
             <a:extLst xmlns:a="http://schemas.openxmlformats.org/drawingml/2006/main">
               <a:ext uri="{FF2B5EF4-FFF2-40B4-BE49-F238E27FC236}">
-                <a16:creationId xmlns:a16="http://schemas.microsoft.com/office/drawing/2014/main" id="{ED75F82B-BAC3-4B68-A127-8C7A768C6C3D}"/>
-              </a:ext>
-            </a:extLst>
-          </p:cNvPr>
-          <p:cNvSpPr>
-            <a:spLocks xmlns:a="http://schemas.openxmlformats.org/drawingml/2006/main" noGrp="1"/>
-          </p:cNvSpPr>
-          <p:nvPr/>
-        </p:nvSpPr>
-        <p:spPr>
-          <a:xfrm xmlns:a="http://schemas.openxmlformats.org/drawingml/2006/main">
-            <a:off x="3810000" y="5486400"/>
-            <a:ext cx="7534275" cy="552450"/>
-          </a:xfrm>
-          <a:prstGeom xmlns:a="http://schemas.openxmlformats.org/drawingml/2006/main" prst="rect">
-            <a:avLst/>
-          </a:prstGeom>
-          <a:noFill xmlns:a="http://schemas.openxmlformats.org/drawingml/2006/main"/>
-          <a:ln xmlns:a="http://schemas.openxmlformats.org/drawingml/2006/main" w="0">
-            <a:noFill/>
-          </a:ln>
-        </p:spPr>
-        <p:txBody>
-          <a:bodyPr xmlns:a="http://schemas.openxmlformats.org/drawingml/2006/main">
-            <a:noAutofit/>
-          </a:bodyPr>
-          <a:lstStyle xmlns:a="http://schemas.openxmlformats.org/drawingml/2006/main"/>
-          <a:p xmlns:a="http://schemas.openxmlformats.org/drawingml/2006/main">
-            <a:pPr>
-              <a:defRPr sz="2025" b="0">
-                <a:solidFill>
-                  <a:srgbClr val="65766B"/>
-                </a:solidFill>
-                <a:latin typeface="Arial"/>
-                <a:ea typeface="Arial"/>
-                <a:cs typeface="Arial"/>
-              </a:defRPr>
-            </a:pPr>
-            <a:r>
-              <a:rPr sz="2025" b="0">
-                <a:solidFill>
-                  <a:srgbClr val="65766B"/>
-                </a:solidFill>
-                <a:latin typeface="Arial"/>
-                <a:ea typeface="Arial"/>
-                <a:cs typeface="Arial"/>
-              </a:rPr>
-              <a:t>Связь с журналом ремонта входит в план пилота.</a:t>
-            </a:r>
-          </a:p>
-        </p:txBody>
-      </p:sp>
-      <p:sp>
-        <p:nvSpPr>
-          <p:cNvPr id="7" name="">
-            <a:extLst xmlns:a="http://schemas.openxmlformats.org/drawingml/2006/main">
-              <a:ext uri="{FF2B5EF4-FFF2-40B4-BE49-F238E27FC236}">
-                <a16:creationId xmlns:a16="http://schemas.microsoft.com/office/drawing/2014/main" id="{6D188BD5-691C-4009-A715-9AD7B39711CE}"/>
+                <a16:creationId xmlns:a16="http://schemas.microsoft.com/office/drawing/2014/main" id="{0829F1D1-1C22-4F18-B543-952EE9119801}"/>
               </a:ext>
             </a:extLst>
           </p:cNvPr>
@@ -4072,17 +3992,17 @@
                 <a:ea typeface="Arial"/>
                 <a:cs typeface="Arial"/>
               </a:rPr>
-              <a:t>Архивный срез 29.03.2026. Решения хранятся в браузере. Заявки не означают состоявшийся выезд.</a:t>
-            </a:r>
-          </a:p>
-        </p:txBody>
-      </p:sp>
-      <p:sp>
-        <p:nvSpPr>
-          <p:cNvPr id="8" name="">
+              <a:t>Вход: подготовленная таблица признаков. Архивный пример: 26 настоящих строк за 01.06.2026.</a:t>
+            </a:r>
+          </a:p>
+        </p:txBody>
+      </p:sp>
+      <p:sp>
+        <p:nvSpPr>
+          <p:cNvPr id="7" name="">
             <a:extLst xmlns:a="http://schemas.openxmlformats.org/drawingml/2006/main">
               <a:ext uri="{FF2B5EF4-FFF2-40B4-BE49-F238E27FC236}">
-                <a16:creationId xmlns:a16="http://schemas.microsoft.com/office/drawing/2014/main" id="{1A43A9E6-0B91-47C6-878C-2CEA38F652AC}"/>
+                <a16:creationId xmlns:a16="http://schemas.microsoft.com/office/drawing/2014/main" id="{77AE4878-E63F-406A-8AFB-D1A28788DB51}"/>
               </a:ext>
             </a:extLst>
           </p:cNvPr>
@@ -4137,7 +4057,7 @@
     </p:spTree>
     <p:extLst>
       <p:ext uri="{BB962C8B-B14F-4D97-AF65-F5344CB8AC3E}">
-        <p14:creationId xmlns:p14="http://schemas.microsoft.com/office/powerpoint/2010/main" val="1498978151"/>
+        <p14:creationId xmlns:p14="http://schemas.microsoft.com/office/powerpoint/2010/main" val="43085734"/>
       </p:ext>
     </p:extLst>
   </p:cSld>
@@ -4168,7 +4088,7 @@
           <p:cNvPr id="10" name="">
             <a:extLst xmlns:a="http://schemas.openxmlformats.org/drawingml/2006/main">
               <a:ext uri="{FF2B5EF4-FFF2-40B4-BE49-F238E27FC236}">
-                <a16:creationId xmlns:a16="http://schemas.microsoft.com/office/drawing/2014/main" id="{0CA5F68B-BCA4-462D-B7A1-C88EEA8EAD9A}"/>
+                <a16:creationId xmlns:a16="http://schemas.microsoft.com/office/drawing/2014/main" id="{2F436824-0043-49AA-AA43-435CD418C83D}"/>
               </a:ext>
             </a:extLst>
           </p:cNvPr>
@@ -4225,7 +4145,7 @@
           <p:cNvPr id="2" name="">
             <a:extLst xmlns:a="http://schemas.openxmlformats.org/drawingml/2006/main">
               <a:ext uri="{FF2B5EF4-FFF2-40B4-BE49-F238E27FC236}">
-                <a16:creationId xmlns:a16="http://schemas.microsoft.com/office/drawing/2014/main" id="{EDEE65F3-80BE-461B-84C3-ABFE5711C33A}"/>
+                <a16:creationId xmlns:a16="http://schemas.microsoft.com/office/drawing/2014/main" id="{AD5FF952-EA28-41F1-A92B-0B07C15BBF42}"/>
               </a:ext>
             </a:extLst>
           </p:cNvPr>
@@ -4282,7 +4202,7 @@
           <p:cNvPr id="3" name="">
             <a:extLst xmlns:a="http://schemas.openxmlformats.org/drawingml/2006/main">
               <a:ext uri="{FF2B5EF4-FFF2-40B4-BE49-F238E27FC236}">
-                <a16:creationId xmlns:a16="http://schemas.microsoft.com/office/drawing/2014/main" id="{9596F75C-1E53-41E6-814F-0D5C1DACE556}"/>
+                <a16:creationId xmlns:a16="http://schemas.microsoft.com/office/drawing/2014/main" id="{0B004355-BB7F-4B67-BF4C-8CB69C316869}"/>
               </a:ext>
             </a:extLst>
           </p:cNvPr>
@@ -4339,7 +4259,7 @@
           <p:cNvPr id="4" name="">
             <a:extLst xmlns:a="http://schemas.openxmlformats.org/drawingml/2006/main">
               <a:ext uri="{FF2B5EF4-FFF2-40B4-BE49-F238E27FC236}">
-                <a16:creationId xmlns:a16="http://schemas.microsoft.com/office/drawing/2014/main" id="{147EE5BC-8B29-47DC-A67B-508484FF3099}"/>
+                <a16:creationId xmlns:a16="http://schemas.microsoft.com/office/drawing/2014/main" id="{59A3B3F3-8AB4-43D2-A7AD-D36B881797DD}"/>
               </a:ext>
             </a:extLst>
           </p:cNvPr>
@@ -4419,7 +4339,7 @@
           <p:cNvPr id="5" name="">
             <a:extLst xmlns:a="http://schemas.openxmlformats.org/drawingml/2006/main">
               <a:ext uri="{FF2B5EF4-FFF2-40B4-BE49-F238E27FC236}">
-                <a16:creationId xmlns:a16="http://schemas.microsoft.com/office/drawing/2014/main" id="{1DF757CD-88ED-4267-BF9B-14317EBA303F}"/>
+                <a16:creationId xmlns:a16="http://schemas.microsoft.com/office/drawing/2014/main" id="{BBBF9603-44CC-458C-9A4C-0207FE524F4E}"/>
               </a:ext>
             </a:extLst>
           </p:cNvPr>
@@ -4476,7 +4396,7 @@
           <p:cNvPr id="6" name="">
             <a:extLst xmlns:a="http://schemas.openxmlformats.org/drawingml/2006/main">
               <a:ext uri="{FF2B5EF4-FFF2-40B4-BE49-F238E27FC236}">
-                <a16:creationId xmlns:a16="http://schemas.microsoft.com/office/drawing/2014/main" id="{793ADEC1-FD91-4090-8BA5-3C74575AEFE3}"/>
+                <a16:creationId xmlns:a16="http://schemas.microsoft.com/office/drawing/2014/main" id="{B530ACA9-ECD2-4B32-AAD4-B959B3C5D95A}"/>
               </a:ext>
             </a:extLst>
           </p:cNvPr>
@@ -4533,7 +4453,7 @@
           <p:cNvPr id="7" name="">
             <a:extLst xmlns:a="http://schemas.openxmlformats.org/drawingml/2006/main">
               <a:ext uri="{FF2B5EF4-FFF2-40B4-BE49-F238E27FC236}">
-                <a16:creationId xmlns:a16="http://schemas.microsoft.com/office/drawing/2014/main" id="{C95C20BE-2D8C-47BF-B688-38928C0B41E4}"/>
+                <a16:creationId xmlns:a16="http://schemas.microsoft.com/office/drawing/2014/main" id="{52822621-EB58-4689-8BE9-CC73C2DF74B0}"/>
               </a:ext>
             </a:extLst>
           </p:cNvPr>
@@ -4613,7 +4533,7 @@
           <p:cNvPr id="8" name="">
             <a:extLst xmlns:a="http://schemas.openxmlformats.org/drawingml/2006/main">
               <a:ext uri="{FF2B5EF4-FFF2-40B4-BE49-F238E27FC236}">
-                <a16:creationId xmlns:a16="http://schemas.microsoft.com/office/drawing/2014/main" id="{58314049-8FED-4FE3-8964-7F5A27A70A9A}"/>
+                <a16:creationId xmlns:a16="http://schemas.microsoft.com/office/drawing/2014/main" id="{F9FC07B5-3824-494B-9D8F-3E3A014A4FC9}"/>
               </a:ext>
             </a:extLst>
           </p:cNvPr>
@@ -4670,7 +4590,7 @@
           <p:cNvPr id="9" name="">
             <a:extLst xmlns:a="http://schemas.openxmlformats.org/drawingml/2006/main">
               <a:ext uri="{FF2B5EF4-FFF2-40B4-BE49-F238E27FC236}">
-                <a16:creationId xmlns:a16="http://schemas.microsoft.com/office/drawing/2014/main" id="{9F36896E-55C0-4229-B274-15458276556C}"/>
+                <a16:creationId xmlns:a16="http://schemas.microsoft.com/office/drawing/2014/main" id="{30BBE73C-DB04-4A26-834B-AE07F10E316A}"/>
               </a:ext>
             </a:extLst>
           </p:cNvPr>
@@ -4725,7 +4645,7 @@
     </p:spTree>
     <p:extLst>
       <p:ext uri="{BB962C8B-B14F-4D97-AF65-F5344CB8AC3E}">
-        <p14:creationId xmlns:p14="http://schemas.microsoft.com/office/powerpoint/2010/main" val="224013374"/>
+        <p14:creationId xmlns:p14="http://schemas.microsoft.com/office/powerpoint/2010/main" val="108472725"/>
       </p:ext>
     </p:extLst>
   </p:cSld>
@@ -4756,7 +4676,7 @@
           <p:cNvPr id="5" name="">
             <a:extLst xmlns:a="http://schemas.openxmlformats.org/drawingml/2006/main">
               <a:ext uri="{FF2B5EF4-FFF2-40B4-BE49-F238E27FC236}">
-                <a16:creationId xmlns:a16="http://schemas.microsoft.com/office/drawing/2014/main" id="{9B238FF6-35E3-467B-A8CC-39D05E9AF75D}"/>
+                <a16:creationId xmlns:a16="http://schemas.microsoft.com/office/drawing/2014/main" id="{2CFB42C2-5DF5-49BC-BC15-111D845D3690}"/>
               </a:ext>
             </a:extLst>
           </p:cNvPr>
@@ -4813,7 +4733,7 @@
           <p:cNvPr id="2" name="">
             <a:extLst xmlns:a="http://schemas.openxmlformats.org/drawingml/2006/main">
               <a:ext uri="{FF2B5EF4-FFF2-40B4-BE49-F238E27FC236}">
-                <a16:creationId xmlns:a16="http://schemas.microsoft.com/office/drawing/2014/main" id="{087014B5-6847-427A-9D4F-71B176CD923C}"/>
+                <a16:creationId xmlns:a16="http://schemas.microsoft.com/office/drawing/2014/main" id="{18864A80-E083-45ED-8E19-9BE8EE5659CB}"/>
               </a:ext>
             </a:extLst>
           </p:cNvPr>
@@ -4870,7 +4790,7 @@
           <p:cNvPr id="3" name="">
             <a:extLst xmlns:a="http://schemas.openxmlformats.org/drawingml/2006/main">
               <a:ext uri="{FF2B5EF4-FFF2-40B4-BE49-F238E27FC236}">
-                <a16:creationId xmlns:a16="http://schemas.microsoft.com/office/drawing/2014/main" id="{11388B4E-C95C-4885-94F3-6FD71A203950}"/>
+                <a16:creationId xmlns:a16="http://schemas.microsoft.com/office/drawing/2014/main" id="{ED67893A-CC5B-4E5E-828C-85F8D6E1C276}"/>
               </a:ext>
             </a:extLst>
           </p:cNvPr>
@@ -4950,7 +4870,7 @@
           <p:cNvPr id="4" name="">
             <a:extLst xmlns:a="http://schemas.openxmlformats.org/drawingml/2006/main">
               <a:ext uri="{FF2B5EF4-FFF2-40B4-BE49-F238E27FC236}">
-                <a16:creationId xmlns:a16="http://schemas.microsoft.com/office/drawing/2014/main" id="{11FFD614-DB61-4468-B83E-246669B43C15}"/>
+                <a16:creationId xmlns:a16="http://schemas.microsoft.com/office/drawing/2014/main" id="{6859E0F7-CA5B-4243-9E4A-47A4CEC9715E}"/>
               </a:ext>
             </a:extLst>
           </p:cNvPr>
@@ -5005,7 +4925,7 @@
     </p:spTree>
     <p:extLst>
       <p:ext uri="{BB962C8B-B14F-4D97-AF65-F5344CB8AC3E}">
-        <p14:creationId xmlns:p14="http://schemas.microsoft.com/office/powerpoint/2010/main" val="1468663046"/>
+        <p14:creationId xmlns:p14="http://schemas.microsoft.com/office/powerpoint/2010/main" val="1700863170"/>
       </p:ext>
     </p:extLst>
   </p:cSld>
@@ -5036,7 +4956,7 @@
           <p:cNvPr id="5" name="">
             <a:extLst xmlns:a="http://schemas.openxmlformats.org/drawingml/2006/main">
               <a:ext uri="{FF2B5EF4-FFF2-40B4-BE49-F238E27FC236}">
-                <a16:creationId xmlns:a16="http://schemas.microsoft.com/office/drawing/2014/main" id="{FBFE226F-8E36-486F-86F5-EDCB2F361F3B}"/>
+                <a16:creationId xmlns:a16="http://schemas.microsoft.com/office/drawing/2014/main" id="{58224C1E-FBFF-49BF-AD56-77FD14C35568}"/>
               </a:ext>
             </a:extLst>
           </p:cNvPr>
@@ -5438,7 +5358,7 @@
           <p:cNvPr id="3" name="">
             <a:extLst xmlns:a="http://schemas.openxmlformats.org/drawingml/2006/main">
               <a:ext uri="{FF2B5EF4-FFF2-40B4-BE49-F238E27FC236}">
-                <a16:creationId xmlns:a16="http://schemas.microsoft.com/office/drawing/2014/main" id="{D8970A10-56AF-4E20-B8DD-098654149E94}"/>
+                <a16:creationId xmlns:a16="http://schemas.microsoft.com/office/drawing/2014/main" id="{28C2AC0C-299E-4AB5-91A1-B3CDE7B62C03}"/>
               </a:ext>
             </a:extLst>
           </p:cNvPr>
@@ -5495,7 +5415,7 @@
           <p:cNvPr id="4" name="">
             <a:extLst xmlns:a="http://schemas.openxmlformats.org/drawingml/2006/main">
               <a:ext uri="{FF2B5EF4-FFF2-40B4-BE49-F238E27FC236}">
-                <a16:creationId xmlns:a16="http://schemas.microsoft.com/office/drawing/2014/main" id="{D605B136-815B-4729-9769-018A36F61416}"/>
+                <a16:creationId xmlns:a16="http://schemas.microsoft.com/office/drawing/2014/main" id="{4C155A30-2238-47C6-BA9D-56D7115C1B6E}"/>
               </a:ext>
             </a:extLst>
           </p:cNvPr>
@@ -5550,7 +5470,7 @@
     </p:spTree>
     <p:extLst>
       <p:ext uri="{BB962C8B-B14F-4D97-AF65-F5344CB8AC3E}">
-        <p14:creationId xmlns:p14="http://schemas.microsoft.com/office/powerpoint/2010/main" val="1165920062"/>
+        <p14:creationId xmlns:p14="http://schemas.microsoft.com/office/powerpoint/2010/main" val="1944344864"/>
       </p:ext>
     </p:extLst>
   </p:cSld>
@@ -5581,7 +5501,7 @@
           <p:cNvPr id="8" name="">
             <a:extLst xmlns:a="http://schemas.openxmlformats.org/drawingml/2006/main">
               <a:ext uri="{FF2B5EF4-FFF2-40B4-BE49-F238E27FC236}">
-                <a16:creationId xmlns:a16="http://schemas.microsoft.com/office/drawing/2014/main" id="{3CA54359-5761-40AD-A08A-47F58F1AA68E}"/>
+                <a16:creationId xmlns:a16="http://schemas.microsoft.com/office/drawing/2014/main" id="{DF816304-03A3-42F5-8657-707CC90C2998}"/>
               </a:ext>
             </a:extLst>
           </p:cNvPr>
@@ -5638,7 +5558,7 @@
           <p:cNvPr id="2" name="">
             <a:extLst xmlns:a="http://schemas.openxmlformats.org/drawingml/2006/main">
               <a:ext uri="{FF2B5EF4-FFF2-40B4-BE49-F238E27FC236}">
-                <a16:creationId xmlns:a16="http://schemas.microsoft.com/office/drawing/2014/main" id="{03AFD325-789F-4B94-96AA-F80816A3DE81}"/>
+                <a16:creationId xmlns:a16="http://schemas.microsoft.com/office/drawing/2014/main" id="{1F7BA83E-E6E8-4361-B576-E14AA562C1F6}"/>
               </a:ext>
             </a:extLst>
           </p:cNvPr>
@@ -5695,7 +5615,7 @@
           <p:cNvPr id="3" name="">
             <a:extLst xmlns:a="http://schemas.openxmlformats.org/drawingml/2006/main">
               <a:ext uri="{FF2B5EF4-FFF2-40B4-BE49-F238E27FC236}">
-                <a16:creationId xmlns:a16="http://schemas.microsoft.com/office/drawing/2014/main" id="{BF91386C-07E2-4E76-B095-B25442AA038E}"/>
+                <a16:creationId xmlns:a16="http://schemas.microsoft.com/office/drawing/2014/main" id="{DE3FEBBA-34AE-4FF3-85BE-40B7DA1730CA}"/>
               </a:ext>
             </a:extLst>
           </p:cNvPr>
@@ -5752,7 +5672,7 @@
           <p:cNvPr id="4" name="">
             <a:extLst xmlns:a="http://schemas.openxmlformats.org/drawingml/2006/main">
               <a:ext uri="{FF2B5EF4-FFF2-40B4-BE49-F238E27FC236}">
-                <a16:creationId xmlns:a16="http://schemas.microsoft.com/office/drawing/2014/main" id="{40DC600E-BAA0-431C-928D-30E78272EA43}"/>
+                <a16:creationId xmlns:a16="http://schemas.microsoft.com/office/drawing/2014/main" id="{C4F9840B-8270-4B86-B97E-FFA591710A4D}"/>
               </a:ext>
             </a:extLst>
           </p:cNvPr>
@@ -5809,7 +5729,7 @@
           <p:cNvPr id="5" name="">
             <a:extLst xmlns:a="http://schemas.openxmlformats.org/drawingml/2006/main">
               <a:ext uri="{FF2B5EF4-FFF2-40B4-BE49-F238E27FC236}">
-                <a16:creationId xmlns:a16="http://schemas.microsoft.com/office/drawing/2014/main" id="{6EF82A42-A7BE-453C-AAE1-884610E59030}"/>
+                <a16:creationId xmlns:a16="http://schemas.microsoft.com/office/drawing/2014/main" id="{54AB582B-248D-4562-B571-4C0A9599101C}"/>
               </a:ext>
             </a:extLst>
           </p:cNvPr>
@@ -5889,7 +5809,7 @@
           <p:cNvPr id="6" name="">
             <a:extLst xmlns:a="http://schemas.openxmlformats.org/drawingml/2006/main">
               <a:ext uri="{FF2B5EF4-FFF2-40B4-BE49-F238E27FC236}">
-                <a16:creationId xmlns:a16="http://schemas.microsoft.com/office/drawing/2014/main" id="{3826511D-60B2-44B1-A035-B2B2420B85E5}"/>
+                <a16:creationId xmlns:a16="http://schemas.microsoft.com/office/drawing/2014/main" id="{6457C772-93F0-42F0-A816-CCBEB583954D}"/>
               </a:ext>
             </a:extLst>
           </p:cNvPr>
@@ -5946,7 +5866,7 @@
           <p:cNvPr id="7" name="">
             <a:extLst xmlns:a="http://schemas.openxmlformats.org/drawingml/2006/main">
               <a:ext uri="{FF2B5EF4-FFF2-40B4-BE49-F238E27FC236}">
-                <a16:creationId xmlns:a16="http://schemas.microsoft.com/office/drawing/2014/main" id="{B3AC31FD-2415-4FA1-9656-6BB718EF65BC}"/>
+                <a16:creationId xmlns:a16="http://schemas.microsoft.com/office/drawing/2014/main" id="{21E0435E-DC84-456A-82F1-522FAA1D0C37}"/>
               </a:ext>
             </a:extLst>
           </p:cNvPr>
@@ -6001,7 +5921,7 @@
     </p:spTree>
     <p:extLst>
       <p:ext uri="{BB962C8B-B14F-4D97-AF65-F5344CB8AC3E}">
-        <p14:creationId xmlns:p14="http://schemas.microsoft.com/office/powerpoint/2010/main" val="914274376"/>
+        <p14:creationId xmlns:p14="http://schemas.microsoft.com/office/powerpoint/2010/main" val="2143064017"/>
       </p:ext>
     </p:extLst>
   </p:cSld>
@@ -6032,7 +5952,7 @@
           <p:cNvPr id="5" name="">
             <a:extLst xmlns:a="http://schemas.openxmlformats.org/drawingml/2006/main">
               <a:ext uri="{FF2B5EF4-FFF2-40B4-BE49-F238E27FC236}">
-                <a16:creationId xmlns:a16="http://schemas.microsoft.com/office/drawing/2014/main" id="{FD9B8DA2-8030-4994-B38A-F21530D41424}"/>
+                <a16:creationId xmlns:a16="http://schemas.microsoft.com/office/drawing/2014/main" id="{0E10FB05-56B4-4F5B-8DC7-52F5B7180437}"/>
               </a:ext>
             </a:extLst>
           </p:cNvPr>
@@ -7090,7 +7010,7 @@
           <p:cNvPr id="3" name="">
             <a:extLst xmlns:a="http://schemas.openxmlformats.org/drawingml/2006/main">
               <a:ext uri="{FF2B5EF4-FFF2-40B4-BE49-F238E27FC236}">
-                <a16:creationId xmlns:a16="http://schemas.microsoft.com/office/drawing/2014/main" id="{E32D5052-91F3-4B3B-8C48-9CF02A570DB8}"/>
+                <a16:creationId xmlns:a16="http://schemas.microsoft.com/office/drawing/2014/main" id="{80B90CEA-8C49-4A5C-9BFF-71D919F1A0B1}"/>
               </a:ext>
             </a:extLst>
           </p:cNvPr>
@@ -7147,7 +7067,7 @@
           <p:cNvPr id="4" name="">
             <a:extLst xmlns:a="http://schemas.openxmlformats.org/drawingml/2006/main">
               <a:ext uri="{FF2B5EF4-FFF2-40B4-BE49-F238E27FC236}">
-                <a16:creationId xmlns:a16="http://schemas.microsoft.com/office/drawing/2014/main" id="{F462587A-DD46-478E-B2A6-9F8CFC8E2084}"/>
+                <a16:creationId xmlns:a16="http://schemas.microsoft.com/office/drawing/2014/main" id="{9B5A3615-4C5D-4D30-8C36-143F23AE526B}"/>
               </a:ext>
             </a:extLst>
           </p:cNvPr>
@@ -7202,7 +7122,7 @@
     </p:spTree>
     <p:extLst>
       <p:ext uri="{BB962C8B-B14F-4D97-AF65-F5344CB8AC3E}">
-        <p14:creationId xmlns:p14="http://schemas.microsoft.com/office/powerpoint/2010/main" val="1075142501"/>
+        <p14:creationId xmlns:p14="http://schemas.microsoft.com/office/powerpoint/2010/main" val="1454820789"/>
       </p:ext>
     </p:extLst>
   </p:cSld>
@@ -7233,7 +7153,7 @@
           <p:cNvPr id="5" name="">
             <a:extLst xmlns:a="http://schemas.openxmlformats.org/drawingml/2006/main">
               <a:ext uri="{FF2B5EF4-FFF2-40B4-BE49-F238E27FC236}">
-                <a16:creationId xmlns:a16="http://schemas.microsoft.com/office/drawing/2014/main" id="{CF3E522B-1007-4419-95F0-471D1D49AE71}"/>
+                <a16:creationId xmlns:a16="http://schemas.microsoft.com/office/drawing/2014/main" id="{3E0B60C5-40E6-431C-B907-A0F5AE6D2D6E}"/>
               </a:ext>
             </a:extLst>
           </p:cNvPr>
@@ -7280,7 +7200,7 @@
                 <a:ea typeface="Arial"/>
                 <a:cs typeface="Arial"/>
               </a:rPr>
-              <a:t>Контур внедрения и следующий рубеж</a:t>
+              <a:t>Один ансамбль в Python и в браузере</a:t>
             </a:r>
           </a:p>
         </p:txBody>
@@ -7292,18 +7212,18 @@
           <p:nvPr/>
         </p:nvGraphicFramePr>
         <p:xfrm>
-          <a:off xmlns:a="http://schemas.openxmlformats.org/drawingml/2006/main" x="609600" y="1895475"/>
-          <a:ext xmlns:a="http://schemas.openxmlformats.org/drawingml/2006/main" cx="10972800" cy="3429000"/>
+          <a:off xmlns:a="http://schemas.openxmlformats.org/drawingml/2006/main" x="609600" y="1733550"/>
+          <a:ext xmlns:a="http://schemas.openxmlformats.org/drawingml/2006/main" cx="10972800" cy="3886200"/>
         </p:xfrm>
         <a:graphic xmlns:a="http://schemas.openxmlformats.org/drawingml/2006/main">
           <a:graphicData uri="http://schemas.openxmlformats.org/drawingml/2006/table">
             <a:tbl>
               <a:tblPr/>
               <a:tblGrid>
-                <a:gridCol w="5381625"/>
-                <a:gridCol w="5591175"/>
+                <a:gridCol w="5172075"/>
+                <a:gridCol w="5800725"/>
               </a:tblGrid>
-              <a:tr h="685800">
+              <a:tr h="647700">
                 <a:tc>
                   <a:txBody>
                     <a:bodyPr/>
@@ -7318,7 +7238,7 @@
                           <a:ea typeface="Arial"/>
                           <a:cs typeface="Arial"/>
                         </a:rPr>
-                        <a:t>Есть в репозитории</a:t>
+                        <a:t>Проверка</a:t>
                       </a:r>
                     </a:p>
                   </a:txBody>
@@ -7342,7 +7262,7 @@
                           <a:ea typeface="Arial"/>
                           <a:cs typeface="Arial"/>
                         </a:rPr>
-                        <a:t>Следующий шаг</a:t>
+                        <a:t>Результат</a:t>
                       </a:r>
                     </a:p>
                   </a:txBody>
@@ -7353,7 +7273,7 @@
                   </a:tcPr>
                 </a:tc>
               </a:tr>
-              <a:tr h="685800">
+              <a:tr h="647700">
                 <a:tc>
                   <a:txBody>
                     <a:bodyPr/>
@@ -7368,7 +7288,7 @@
                           <a:ea typeface="Arial"/>
                           <a:cs typeface="Arial"/>
                         </a:rPr>
-                        <a:t>Импорт журналов и витрина признаков</a:t>
+                        <a:t>Все 8 базовых моделей</a:t>
                       </a:r>
                     </a:p>
                   </a:txBody>
@@ -7392,7 +7312,7 @@
                           <a:ea typeface="Arial"/>
                           <a:cs typeface="Arial"/>
                         </a:rPr>
-                        <a:t>Стабильная ежедневная загрузка</a:t>
+                        <a:t>5 LightGBM, CatBoost, Extra Trees, Logistic</a:t>
                       </a:r>
                     </a:p>
                   </a:txBody>
@@ -7403,7 +7323,7 @@
                   </a:tcPr>
                 </a:tc>
               </a:tr>
-              <a:tr h="685800">
+              <a:tr h="647700">
                 <a:tc>
                   <a:txBody>
                     <a:bodyPr/>
@@ -7418,7 +7338,7 @@
                           <a:ea typeface="Arial"/>
                           <a:cs typeface="Arial"/>
                         </a:rPr>
-                        <a:t>API, роли и история заявок</a:t>
+                        <a:t>Контракт входа</a:t>
                       </a:r>
                     </a:p>
                   </a:txBody>
@@ -7442,7 +7362,7 @@
                           <a:ea typeface="Arial"/>
                           <a:cs typeface="Arial"/>
                         </a:rPr>
-                        <a:t>Интеграция с рабочей системой заказчика</a:t>
+                        <a:t>178 признаков и дата, 179 столбцов CSV</a:t>
                       </a:r>
                     </a:p>
                   </a:txBody>
@@ -7453,7 +7373,7 @@
                   </a:tcPr>
                 </a:tc>
               </a:tr>
-              <a:tr h="685800">
+              <a:tr h="647700">
                 <a:tc>
                   <a:txBody>
                     <a:bodyPr/>
@@ -7468,7 +7388,7 @@
                           <a:ea typeface="Arial"/>
                           <a:cs typeface="Arial"/>
                         </a:rPr>
-                        <a:t>Прототип очереди и решений</a:t>
+                        <a:t>Сравнение с Python</a:t>
                       </a:r>
                     </a:p>
                   </a:txBody>
@@ -7492,7 +7412,7 @@
                           <a:ea typeface="Arial"/>
                           <a:cs typeface="Arial"/>
                         </a:rPr>
-                        <a:t>Результаты осмотров как обратная связь</a:t>
+                        <a:t>783 строки, включая пропуски и новую группу</a:t>
                       </a:r>
                     </a:p>
                   </a:txBody>
@@ -7503,7 +7423,7 @@
                   </a:tcPr>
                 </a:tc>
               </a:tr>
-              <a:tr h="685800">
+              <a:tr h="647700">
                 <a:tc>
                   <a:txBody>
                     <a:bodyPr/>
@@ -7518,7 +7438,7 @@
                           <a:ea typeface="Arial"/>
                           <a:cs typeface="Arial"/>
                         </a:rPr>
-                        <a:t>OOF-оценка ансамбля и сохранённые прогнозы</a:t>
+                        <a:t>Максимальная абсолютная разница</a:t>
                       </a:r>
                     </a:p>
                   </a:txBody>
@@ -7542,7 +7462,57 @@
                           <a:ea typeface="Arial"/>
                           <a:cs typeface="Arial"/>
                         </a:rPr>
-                        <a:t>Воспроизведение инференса и новый закрытый тест</a:t>
+                        <a:t>3,9 × 10⁻¹⁶ при допуске 10⁻¹⁰</a:t>
+                      </a:r>
+                    </a:p>
+                  </a:txBody>
+                  <a:tcPr marL="133350" marR="133350" marT="95250" marB="95250">
+                    <a:solidFill>
+                      <a:srgbClr val="0D201B"/>
+                    </a:solidFill>
+                  </a:tcPr>
+                </a:tc>
+              </a:tr>
+              <a:tr h="647700">
+                <a:tc>
+                  <a:txBody>
+                    <a:bodyPr/>
+                    <a:lstStyle/>
+                    <a:p>
+                      <a:r>
+                        <a:rPr sz="1800">
+                          <a:solidFill>
+                            <a:srgbClr val="F3F1E9"/>
+                          </a:solidFill>
+                          <a:latin typeface="Arial"/>
+                          <a:ea typeface="Arial"/>
+                          <a:cs typeface="Arial"/>
+                        </a:rPr>
+                        <a:t>Версия / обучение</a:t>
+                      </a:r>
+                    </a:p>
+                  </a:txBody>
+                  <a:tcPr marL="133350" marR="133350" marT="95250" marB="95250">
+                    <a:solidFill>
+                      <a:srgbClr val="0D201B"/>
+                    </a:solidFill>
+                  </a:tcPr>
+                </a:tc>
+                <a:tc>
+                  <a:txBody>
+                    <a:bodyPr/>
+                    <a:lstStyle/>
+                    <a:p>
+                      <a:r>
+                        <a:rPr sz="1800">
+                          <a:solidFill>
+                            <a:srgbClr val="F3F1E9"/>
+                          </a:solidFill>
+                          <a:latin typeface="Arial"/>
+                          <a:ea typeface="Arial"/>
+                          <a:cs typeface="Arial"/>
+                        </a:rPr>
+                        <a:t>piket-eight-2026-06 / до 16.05.2026</a:t>
                       </a:r>
                     </a:p>
                   </a:txBody>
@@ -7562,7 +7532,7 @@
           <p:cNvPr id="3" name="">
             <a:extLst xmlns:a="http://schemas.openxmlformats.org/drawingml/2006/main">
               <a:ext uri="{FF2B5EF4-FFF2-40B4-BE49-F238E27FC236}">
-                <a16:creationId xmlns:a16="http://schemas.microsoft.com/office/drawing/2014/main" id="{B089CA74-4083-44F5-86C0-488D0528E0AC}"/>
+                <a16:creationId xmlns:a16="http://schemas.microsoft.com/office/drawing/2014/main" id="{62328995-DBE4-4F27-8D3F-924424F193DB}"/>
               </a:ext>
             </a:extLst>
           </p:cNvPr>
@@ -7609,7 +7579,7 @@
                 <a:ea typeface="Arial"/>
                 <a:cs typeface="Arial"/>
               </a:rPr>
-              <a:t>Критерий внедрения: прирост полезных проверок на новом периоде при согласованном лимите выездов.</a:t>
+              <a:t>Метрики на слайде 9 относятся к ежемесячному replay. Совпадение расчёта не доказывает качество прогноза.</a:t>
             </a:r>
           </a:p>
         </p:txBody>
@@ -7619,7 +7589,7 @@
           <p:cNvPr id="4" name="">
             <a:extLst xmlns:a="http://schemas.openxmlformats.org/drawingml/2006/main">
               <a:ext uri="{FF2B5EF4-FFF2-40B4-BE49-F238E27FC236}">
-                <a16:creationId xmlns:a16="http://schemas.microsoft.com/office/drawing/2014/main" id="{3202D9DA-3B5C-4685-94AB-C1BA1662B52D}"/>
+                <a16:creationId xmlns:a16="http://schemas.microsoft.com/office/drawing/2014/main" id="{D99C1016-7F50-4C38-9244-984E51891288}"/>
               </a:ext>
             </a:extLst>
           </p:cNvPr>
@@ -7674,7 +7644,7 @@
     </p:spTree>
     <p:extLst>
       <p:ext uri="{BB962C8B-B14F-4D97-AF65-F5344CB8AC3E}">
-        <p14:creationId xmlns:p14="http://schemas.microsoft.com/office/powerpoint/2010/main" val="316007379"/>
+        <p14:creationId xmlns:p14="http://schemas.microsoft.com/office/powerpoint/2010/main" val="1114000889"/>
       </p:ext>
     </p:extLst>
   </p:cSld>
@@ -7705,7 +7675,7 @@
           <p:cNvPr id="8" name="">
             <a:extLst xmlns:a="http://schemas.openxmlformats.org/drawingml/2006/main">
               <a:ext uri="{FF2B5EF4-FFF2-40B4-BE49-F238E27FC236}">
-                <a16:creationId xmlns:a16="http://schemas.microsoft.com/office/drawing/2014/main" id="{4B1DDF85-099F-4BB1-A016-8F6620C39E72}"/>
+                <a16:creationId xmlns:a16="http://schemas.microsoft.com/office/drawing/2014/main" id="{6AB8AC31-729B-407B-82FB-0A987DACE1DA}"/>
               </a:ext>
             </a:extLst>
           </p:cNvPr>
@@ -7762,7 +7732,7 @@
           <p:cNvPr id="2" name="">
             <a:extLst xmlns:a="http://schemas.openxmlformats.org/drawingml/2006/main">
               <a:ext uri="{FF2B5EF4-FFF2-40B4-BE49-F238E27FC236}">
-                <a16:creationId xmlns:a16="http://schemas.microsoft.com/office/drawing/2014/main" id="{2451A6B6-B4D7-41A4-96C8-700B7ACA16F0}"/>
+                <a16:creationId xmlns:a16="http://schemas.microsoft.com/office/drawing/2014/main" id="{AAB490E4-D4DA-4F2A-B15D-0D33F4DBFB80}"/>
               </a:ext>
             </a:extLst>
           </p:cNvPr>
@@ -7819,7 +7789,7 @@
           <p:cNvPr id="3" name="">
             <a:extLst xmlns:a="http://schemas.openxmlformats.org/drawingml/2006/main">
               <a:ext uri="{FF2B5EF4-FFF2-40B4-BE49-F238E27FC236}">
-                <a16:creationId xmlns:a16="http://schemas.microsoft.com/office/drawing/2014/main" id="{CAE9A360-6985-4CCF-A2C4-4A354214ADC5}"/>
+                <a16:creationId xmlns:a16="http://schemas.microsoft.com/office/drawing/2014/main" id="{1B0D6F69-71C9-4DD9-AD28-9E3651CA1633}"/>
               </a:ext>
             </a:extLst>
           </p:cNvPr>
@@ -7876,7 +7846,7 @@
           <p:cNvPr id="4" name="">
             <a:extLst xmlns:a="http://schemas.openxmlformats.org/drawingml/2006/main">
               <a:ext uri="{FF2B5EF4-FFF2-40B4-BE49-F238E27FC236}">
-                <a16:creationId xmlns:a16="http://schemas.microsoft.com/office/drawing/2014/main" id="{3F65240C-9990-4E5F-B650-4F93A3C39590}"/>
+                <a16:creationId xmlns:a16="http://schemas.microsoft.com/office/drawing/2014/main" id="{B69F41E2-8318-4433-B58D-1E87BDD22B16}"/>
               </a:ext>
             </a:extLst>
           </p:cNvPr>
@@ -7933,7 +7903,7 @@
           <p:cNvPr id="5" name="">
             <a:extLst xmlns:a="http://schemas.openxmlformats.org/drawingml/2006/main">
               <a:ext uri="{FF2B5EF4-FFF2-40B4-BE49-F238E27FC236}">
-                <a16:creationId xmlns:a16="http://schemas.microsoft.com/office/drawing/2014/main" id="{4E200ECB-3372-4978-8A84-832303B33651}"/>
+                <a16:creationId xmlns:a16="http://schemas.microsoft.com/office/drawing/2014/main" id="{C664C405-9EB0-4738-ABA8-A501B423C7CC}"/>
               </a:ext>
             </a:extLst>
           </p:cNvPr>
@@ -8013,7 +7983,7 @@
           <p:cNvPr id="6" name="">
             <a:extLst xmlns:a="http://schemas.openxmlformats.org/drawingml/2006/main">
               <a:ext uri="{FF2B5EF4-FFF2-40B4-BE49-F238E27FC236}">
-                <a16:creationId xmlns:a16="http://schemas.microsoft.com/office/drawing/2014/main" id="{552DA118-70F8-4E50-82DC-ED8731B8E8AA}"/>
+                <a16:creationId xmlns:a16="http://schemas.microsoft.com/office/drawing/2014/main" id="{9C0CAA57-62E1-4475-8682-A2C2C6B59E66}"/>
               </a:ext>
             </a:extLst>
           </p:cNvPr>
@@ -8070,7 +8040,7 @@
           <p:cNvPr id="7" name="">
             <a:extLst xmlns:a="http://schemas.openxmlformats.org/drawingml/2006/main">
               <a:ext uri="{FF2B5EF4-FFF2-40B4-BE49-F238E27FC236}">
-                <a16:creationId xmlns:a16="http://schemas.microsoft.com/office/drawing/2014/main" id="{F471D902-8DA9-4380-A0EF-67F7329FB8F8}"/>
+                <a16:creationId xmlns:a16="http://schemas.microsoft.com/office/drawing/2014/main" id="{9240972C-B689-4C45-B942-84861AEBDA7A}"/>
               </a:ext>
             </a:extLst>
           </p:cNvPr>
@@ -8125,7 +8095,7 @@
     </p:spTree>
     <p:extLst>
       <p:ext uri="{BB962C8B-B14F-4D97-AF65-F5344CB8AC3E}">
-        <p14:creationId xmlns:p14="http://schemas.microsoft.com/office/powerpoint/2010/main" val="1177473365"/>
+        <p14:creationId xmlns:p14="http://schemas.microsoft.com/office/powerpoint/2010/main" val="1211393227"/>
       </p:ext>
     </p:extLst>
   </p:cSld>
@@ -8156,7 +8126,7 @@
           <p:cNvPr id="6" name="">
             <a:extLst xmlns:a="http://schemas.openxmlformats.org/drawingml/2006/main">
               <a:ext uri="{FF2B5EF4-FFF2-40B4-BE49-F238E27FC236}">
-                <a16:creationId xmlns:a16="http://schemas.microsoft.com/office/drawing/2014/main" id="{CEBBF60E-314C-4F55-809E-D90402838430}"/>
+                <a16:creationId xmlns:a16="http://schemas.microsoft.com/office/drawing/2014/main" id="{C3A4A5DD-0EBA-4842-A613-188A3A9EE890}"/>
               </a:ext>
             </a:extLst>
           </p:cNvPr>
@@ -8848,7 +8818,7 @@
           <p:cNvPr id="3" name="">
             <a:extLst xmlns:a="http://schemas.openxmlformats.org/drawingml/2006/main">
               <a:ext uri="{FF2B5EF4-FFF2-40B4-BE49-F238E27FC236}">
-                <a16:creationId xmlns:a16="http://schemas.microsoft.com/office/drawing/2014/main" id="{769FF710-A0A5-4762-9C39-C9E6B043DD11}"/>
+                <a16:creationId xmlns:a16="http://schemas.microsoft.com/office/drawing/2014/main" id="{B57DFDAD-9CC5-4E6A-A4A0-C1AF5D3C7C7E}"/>
               </a:ext>
             </a:extLst>
           </p:cNvPr>
@@ -8905,7 +8875,7 @@
           <p:cNvPr id="4" name="">
             <a:extLst xmlns:a="http://schemas.openxmlformats.org/drawingml/2006/main">
               <a:ext uri="{FF2B5EF4-FFF2-40B4-BE49-F238E27FC236}">
-                <a16:creationId xmlns:a16="http://schemas.microsoft.com/office/drawing/2014/main" id="{DD3B8A86-592B-4487-B739-F46DD33DA12F}"/>
+                <a16:creationId xmlns:a16="http://schemas.microsoft.com/office/drawing/2014/main" id="{0726B6B5-5A8F-49E8-8CDC-6369F6E370D9}"/>
               </a:ext>
             </a:extLst>
           </p:cNvPr>
@@ -8962,7 +8932,7 @@
           <p:cNvPr id="5" name="">
             <a:extLst xmlns:a="http://schemas.openxmlformats.org/drawingml/2006/main">
               <a:ext uri="{FF2B5EF4-FFF2-40B4-BE49-F238E27FC236}">
-                <a16:creationId xmlns:a16="http://schemas.microsoft.com/office/drawing/2014/main" id="{E51E3075-3B1C-4D27-ACF7-53D293526F97}"/>
+                <a16:creationId xmlns:a16="http://schemas.microsoft.com/office/drawing/2014/main" id="{DA2E3413-5361-46B2-9F7E-613544FB1CE3}"/>
               </a:ext>
             </a:extLst>
           </p:cNvPr>
@@ -9017,7 +8987,7 @@
     </p:spTree>
     <p:extLst>
       <p:ext uri="{BB962C8B-B14F-4D97-AF65-F5344CB8AC3E}">
-        <p14:creationId xmlns:p14="http://schemas.microsoft.com/office/powerpoint/2010/main" val="1814263152"/>
+        <p14:creationId xmlns:p14="http://schemas.microsoft.com/office/powerpoint/2010/main" val="1384764593"/>
       </p:ext>
     </p:extLst>
   </p:cSld>
@@ -9048,7 +9018,7 @@
           <p:cNvPr id="10" name="">
             <a:extLst xmlns:a="http://schemas.openxmlformats.org/drawingml/2006/main">
               <a:ext uri="{FF2B5EF4-FFF2-40B4-BE49-F238E27FC236}">
-                <a16:creationId xmlns:a16="http://schemas.microsoft.com/office/drawing/2014/main" id="{E5287397-DD24-4B1F-94FA-3701B54BD283}"/>
+                <a16:creationId xmlns:a16="http://schemas.microsoft.com/office/drawing/2014/main" id="{FF17EC4A-0BA8-4331-8809-7BBA33B693DF}"/>
               </a:ext>
             </a:extLst>
           </p:cNvPr>
@@ -9128,7 +9098,7 @@
           <p:cNvPr id="2" name="">
             <a:extLst xmlns:a="http://schemas.openxmlformats.org/drawingml/2006/main">
               <a:ext uri="{FF2B5EF4-FFF2-40B4-BE49-F238E27FC236}">
-                <a16:creationId xmlns:a16="http://schemas.microsoft.com/office/drawing/2014/main" id="{103387C4-400A-422F-B289-883015EBF302}"/>
+                <a16:creationId xmlns:a16="http://schemas.microsoft.com/office/drawing/2014/main" id="{18AD2DD5-B219-408D-993C-EF09A615DC27}"/>
               </a:ext>
             </a:extLst>
           </p:cNvPr>
@@ -9185,7 +9155,7 @@
           <p:cNvPr id="3" name="">
             <a:extLst xmlns:a="http://schemas.openxmlformats.org/drawingml/2006/main">
               <a:ext uri="{FF2B5EF4-FFF2-40B4-BE49-F238E27FC236}">
-                <a16:creationId xmlns:a16="http://schemas.microsoft.com/office/drawing/2014/main" id="{E7A85FDB-A13F-496D-9355-C4A4FCEA374A}"/>
+                <a16:creationId xmlns:a16="http://schemas.microsoft.com/office/drawing/2014/main" id="{0A5C1ED3-141A-4E7C-BF72-20FDB73AF5F0}"/>
               </a:ext>
             </a:extLst>
           </p:cNvPr>
@@ -9242,7 +9212,7 @@
           <p:cNvPr id="4" name="">
             <a:extLst xmlns:a="http://schemas.openxmlformats.org/drawingml/2006/main">
               <a:ext uri="{FF2B5EF4-FFF2-40B4-BE49-F238E27FC236}">
-                <a16:creationId xmlns:a16="http://schemas.microsoft.com/office/drawing/2014/main" id="{3E0EF037-5458-434C-A43F-2562CAE17A91}"/>
+                <a16:creationId xmlns:a16="http://schemas.microsoft.com/office/drawing/2014/main" id="{1D8B9211-3976-4C8A-8361-47AA396BE2BF}"/>
               </a:ext>
             </a:extLst>
           </p:cNvPr>
@@ -9299,7 +9269,7 @@
           <p:cNvPr id="5" name="">
             <a:extLst xmlns:a="http://schemas.openxmlformats.org/drawingml/2006/main">
               <a:ext uri="{FF2B5EF4-FFF2-40B4-BE49-F238E27FC236}">
-                <a16:creationId xmlns:a16="http://schemas.microsoft.com/office/drawing/2014/main" id="{4451C953-EC2E-4F7F-8E5A-E7246EB85759}"/>
+                <a16:creationId xmlns:a16="http://schemas.microsoft.com/office/drawing/2014/main" id="{FF25E49D-7E45-43C5-9426-42598B633DB7}"/>
               </a:ext>
             </a:extLst>
           </p:cNvPr>
@@ -9356,7 +9326,7 @@
           <p:cNvPr id="6" name="">
             <a:extLst xmlns:a="http://schemas.openxmlformats.org/drawingml/2006/main">
               <a:ext uri="{FF2B5EF4-FFF2-40B4-BE49-F238E27FC236}">
-                <a16:creationId xmlns:a16="http://schemas.microsoft.com/office/drawing/2014/main" id="{BA8ABD65-6A60-4951-9258-DBAB7D7D3C33}"/>
+                <a16:creationId xmlns:a16="http://schemas.microsoft.com/office/drawing/2014/main" id="{F903D34A-6B66-4794-A8F4-8D005F999846}"/>
               </a:ext>
             </a:extLst>
           </p:cNvPr>
@@ -9413,7 +9383,7 @@
           <p:cNvPr id="7" name="">
             <a:extLst xmlns:a="http://schemas.openxmlformats.org/drawingml/2006/main">
               <a:ext uri="{FF2B5EF4-FFF2-40B4-BE49-F238E27FC236}">
-                <a16:creationId xmlns:a16="http://schemas.microsoft.com/office/drawing/2014/main" id="{FE97E8DC-CFB6-4734-8A87-D520C50C8DA6}"/>
+                <a16:creationId xmlns:a16="http://schemas.microsoft.com/office/drawing/2014/main" id="{0B4B91A8-B585-4B51-821F-FC6834245826}"/>
               </a:ext>
             </a:extLst>
           </p:cNvPr>
@@ -9470,7 +9440,7 @@
           <p:cNvPr id="8" name="">
             <a:extLst xmlns:a="http://schemas.openxmlformats.org/drawingml/2006/main">
               <a:ext uri="{FF2B5EF4-FFF2-40B4-BE49-F238E27FC236}">
-                <a16:creationId xmlns:a16="http://schemas.microsoft.com/office/drawing/2014/main" id="{4F0FEDC7-C212-4D36-918D-14C7F64155A8}"/>
+                <a16:creationId xmlns:a16="http://schemas.microsoft.com/office/drawing/2014/main" id="{72042E87-C327-4D32-A8FF-5BD2744327E2}"/>
               </a:ext>
             </a:extLst>
           </p:cNvPr>
@@ -9527,7 +9497,7 @@
           <p:cNvPr id="9" name="">
             <a:extLst xmlns:a="http://schemas.openxmlformats.org/drawingml/2006/main">
               <a:ext uri="{FF2B5EF4-FFF2-40B4-BE49-F238E27FC236}">
-                <a16:creationId xmlns:a16="http://schemas.microsoft.com/office/drawing/2014/main" id="{1B92B93B-D642-408F-B233-18313EEFEE4F}"/>
+                <a16:creationId xmlns:a16="http://schemas.microsoft.com/office/drawing/2014/main" id="{3FDD6BD9-8F87-47B1-BBF7-333CF16FC0A2}"/>
               </a:ext>
             </a:extLst>
           </p:cNvPr>
@@ -9582,7 +9552,7 @@
     </p:spTree>
     <p:extLst>
       <p:ext uri="{BB962C8B-B14F-4D97-AF65-F5344CB8AC3E}">
-        <p14:creationId xmlns:p14="http://schemas.microsoft.com/office/powerpoint/2010/main" val="386744656"/>
+        <p14:creationId xmlns:p14="http://schemas.microsoft.com/office/powerpoint/2010/main" val="245025361"/>
       </p:ext>
     </p:extLst>
   </p:cSld>
@@ -9613,7 +9583,7 @@
           <p:cNvPr id="8" name="">
             <a:extLst xmlns:a="http://schemas.openxmlformats.org/drawingml/2006/main">
               <a:ext uri="{FF2B5EF4-FFF2-40B4-BE49-F238E27FC236}">
-                <a16:creationId xmlns:a16="http://schemas.microsoft.com/office/drawing/2014/main" id="{EBAA0359-6399-403E-9072-1E71910DDF03}"/>
+                <a16:creationId xmlns:a16="http://schemas.microsoft.com/office/drawing/2014/main" id="{F8B17259-9C84-4248-BE54-2E7CFA455C84}"/>
               </a:ext>
             </a:extLst>
           </p:cNvPr>
@@ -9693,7 +9663,7 @@
           <p:cNvPr id="2" name="">
             <a:extLst xmlns:a="http://schemas.openxmlformats.org/drawingml/2006/main">
               <a:ext uri="{FF2B5EF4-FFF2-40B4-BE49-F238E27FC236}">
-                <a16:creationId xmlns:a16="http://schemas.microsoft.com/office/drawing/2014/main" id="{0880EFF4-FD85-478E-B7E6-4E86D032B8AC}"/>
+                <a16:creationId xmlns:a16="http://schemas.microsoft.com/office/drawing/2014/main" id="{0EBD925B-2CF2-4374-8E15-3F7CA1C46EC4}"/>
               </a:ext>
             </a:extLst>
           </p:cNvPr>
@@ -9750,7 +9720,7 @@
           <p:cNvPr id="3" name="">
             <a:extLst xmlns:a="http://schemas.openxmlformats.org/drawingml/2006/main">
               <a:ext uri="{FF2B5EF4-FFF2-40B4-BE49-F238E27FC236}">
-                <a16:creationId xmlns:a16="http://schemas.microsoft.com/office/drawing/2014/main" id="{47DF8F2A-F581-4A17-9D5B-E47460E2B851}"/>
+                <a16:creationId xmlns:a16="http://schemas.microsoft.com/office/drawing/2014/main" id="{5B12D977-5308-4C31-9B31-AF2E2CA3C5EC}"/>
               </a:ext>
             </a:extLst>
           </p:cNvPr>
@@ -9807,7 +9777,7 @@
           <p:cNvPr id="4" name="">
             <a:extLst xmlns:a="http://schemas.openxmlformats.org/drawingml/2006/main">
               <a:ext uri="{FF2B5EF4-FFF2-40B4-BE49-F238E27FC236}">
-                <a16:creationId xmlns:a16="http://schemas.microsoft.com/office/drawing/2014/main" id="{D38D3F1B-FC23-4609-A34D-23B3B5DBE711}"/>
+                <a16:creationId xmlns:a16="http://schemas.microsoft.com/office/drawing/2014/main" id="{7CFD8A74-3B28-4BA1-B1FE-E1D006273E10}"/>
               </a:ext>
             </a:extLst>
           </p:cNvPr>
@@ -9864,7 +9834,7 @@
           <p:cNvPr id="5" name="">
             <a:extLst xmlns:a="http://schemas.openxmlformats.org/drawingml/2006/main">
               <a:ext uri="{FF2B5EF4-FFF2-40B4-BE49-F238E27FC236}">
-                <a16:creationId xmlns:a16="http://schemas.microsoft.com/office/drawing/2014/main" id="{3A3315C9-C60B-4B44-9DE1-18A8E77D7CB2}"/>
+                <a16:creationId xmlns:a16="http://schemas.microsoft.com/office/drawing/2014/main" id="{A3302650-7C07-4EEB-BD53-63ACE4E5C524}"/>
               </a:ext>
             </a:extLst>
           </p:cNvPr>
@@ -9977,7 +9947,7 @@
           <p:cNvPr id="6" name="">
             <a:extLst xmlns:a="http://schemas.openxmlformats.org/drawingml/2006/main">
               <a:ext uri="{FF2B5EF4-FFF2-40B4-BE49-F238E27FC236}">
-                <a16:creationId xmlns:a16="http://schemas.microsoft.com/office/drawing/2014/main" id="{1B2535AF-057E-4BAC-AFD7-092081BE6104}"/>
+                <a16:creationId xmlns:a16="http://schemas.microsoft.com/office/drawing/2014/main" id="{869C5D48-BC6B-40ED-BAC1-CD6B4F92B486}"/>
               </a:ext>
             </a:extLst>
           </p:cNvPr>
@@ -10034,7 +10004,7 @@
           <p:cNvPr id="7" name="">
             <a:extLst xmlns:a="http://schemas.openxmlformats.org/drawingml/2006/main">
               <a:ext uri="{FF2B5EF4-FFF2-40B4-BE49-F238E27FC236}">
-                <a16:creationId xmlns:a16="http://schemas.microsoft.com/office/drawing/2014/main" id="{D95C47F6-07E0-426C-B466-278864D841F0}"/>
+                <a16:creationId xmlns:a16="http://schemas.microsoft.com/office/drawing/2014/main" id="{85A0BC49-7A93-4E84-B4E5-E69006453AC0}"/>
               </a:ext>
             </a:extLst>
           </p:cNvPr>
@@ -10089,7 +10059,7 @@
     </p:spTree>
     <p:extLst>
       <p:ext uri="{BB962C8B-B14F-4D97-AF65-F5344CB8AC3E}">
-        <p14:creationId xmlns:p14="http://schemas.microsoft.com/office/powerpoint/2010/main" val="393925908"/>
+        <p14:creationId xmlns:p14="http://schemas.microsoft.com/office/powerpoint/2010/main" val="430427173"/>
       </p:ext>
     </p:extLst>
   </p:cSld>
@@ -10120,7 +10090,7 @@
           <p:cNvPr id="9" name="">
             <a:extLst xmlns:a="http://schemas.openxmlformats.org/drawingml/2006/main">
               <a:ext uri="{FF2B5EF4-FFF2-40B4-BE49-F238E27FC236}">
-                <a16:creationId xmlns:a16="http://schemas.microsoft.com/office/drawing/2014/main" id="{E858CDB6-8EE3-430F-B0D1-778DC9D483D3}"/>
+                <a16:creationId xmlns:a16="http://schemas.microsoft.com/office/drawing/2014/main" id="{566A450C-18B9-40EA-AC63-CD374F9DBAEA}"/>
               </a:ext>
             </a:extLst>
           </p:cNvPr>
@@ -10181,7 +10151,7 @@
           <p:nvPr/>
         </p:nvPicPr>
         <p:blipFill>
-          <a:blip xmlns:r="http://schemas.openxmlformats.org/officeDocument/2006/relationships" xmlns:a="http://schemas.openxmlformats.org/drawingml/2006/main" r:embed="Rde1066cfd6714622"/>
+          <a:blip xmlns:r="http://schemas.openxmlformats.org/officeDocument/2006/relationships" xmlns:a="http://schemas.openxmlformats.org/drawingml/2006/main" r:embed="R03b6439da10d4fae"/>
           <a:stretch xmlns:a="http://schemas.openxmlformats.org/drawingml/2006/main"/>
         </p:blipFill>
         <p:spPr>
@@ -10199,7 +10169,7 @@
           <p:cNvPr id="3" name="">
             <a:extLst xmlns:a="http://schemas.openxmlformats.org/drawingml/2006/main">
               <a:ext uri="{FF2B5EF4-FFF2-40B4-BE49-F238E27FC236}">
-                <a16:creationId xmlns:a16="http://schemas.microsoft.com/office/drawing/2014/main" id="{CE183929-02C1-4C46-AC51-E7E67648C706}"/>
+                <a16:creationId xmlns:a16="http://schemas.microsoft.com/office/drawing/2014/main" id="{077FE33D-DC12-4107-9ACB-BD6E2BA9FE66}"/>
               </a:ext>
             </a:extLst>
           </p:cNvPr>
@@ -10256,7 +10226,7 @@
           <p:cNvPr id="4" name="">
             <a:extLst xmlns:a="http://schemas.openxmlformats.org/drawingml/2006/main">
               <a:ext uri="{FF2B5EF4-FFF2-40B4-BE49-F238E27FC236}">
-                <a16:creationId xmlns:a16="http://schemas.microsoft.com/office/drawing/2014/main" id="{68748E8C-25EA-4752-88D4-F4DA5F6107B0}"/>
+                <a16:creationId xmlns:a16="http://schemas.microsoft.com/office/drawing/2014/main" id="{7B971ADA-9142-45EA-B081-4181C8F2B1FF}"/>
               </a:ext>
             </a:extLst>
           </p:cNvPr>
@@ -10313,7 +10283,7 @@
           <p:cNvPr id="5" name="">
             <a:extLst xmlns:a="http://schemas.openxmlformats.org/drawingml/2006/main">
               <a:ext uri="{FF2B5EF4-FFF2-40B4-BE49-F238E27FC236}">
-                <a16:creationId xmlns:a16="http://schemas.microsoft.com/office/drawing/2014/main" id="{5CB3E775-6172-4C02-AA8B-6D1872799D88}"/>
+                <a16:creationId xmlns:a16="http://schemas.microsoft.com/office/drawing/2014/main" id="{0937FDA6-D72F-4D92-AAEC-7087F0EB2A01}"/>
               </a:ext>
             </a:extLst>
           </p:cNvPr>
@@ -10370,7 +10340,7 @@
           <p:cNvPr id="6" name="">
             <a:extLst xmlns:a="http://schemas.openxmlformats.org/drawingml/2006/main">
               <a:ext uri="{FF2B5EF4-FFF2-40B4-BE49-F238E27FC236}">
-                <a16:creationId xmlns:a16="http://schemas.microsoft.com/office/drawing/2014/main" id="{20984F67-FB4E-41A6-BAAA-D56E9E0F0141}"/>
+                <a16:creationId xmlns:a16="http://schemas.microsoft.com/office/drawing/2014/main" id="{1C4713D7-A759-4D0B-B217-AC0DD3B0EAB1}"/>
               </a:ext>
             </a:extLst>
           </p:cNvPr>
@@ -10427,7 +10397,7 @@
           <p:cNvPr id="7" name="">
             <a:extLst xmlns:a="http://schemas.openxmlformats.org/drawingml/2006/main">
               <a:ext uri="{FF2B5EF4-FFF2-40B4-BE49-F238E27FC236}">
-                <a16:creationId xmlns:a16="http://schemas.microsoft.com/office/drawing/2014/main" id="{8534D3E4-C081-4183-BC15-C26D581CF26D}"/>
+                <a16:creationId xmlns:a16="http://schemas.microsoft.com/office/drawing/2014/main" id="{F9CE2D05-4EE7-4064-AF2C-761D620A5461}"/>
               </a:ext>
             </a:extLst>
           </p:cNvPr>
@@ -10484,7 +10454,7 @@
           <p:cNvPr id="8" name="">
             <a:extLst xmlns:a="http://schemas.openxmlformats.org/drawingml/2006/main">
               <a:ext uri="{FF2B5EF4-FFF2-40B4-BE49-F238E27FC236}">
-                <a16:creationId xmlns:a16="http://schemas.microsoft.com/office/drawing/2014/main" id="{800302EF-2EF1-4A39-968C-82D6A6E83C3F}"/>
+                <a16:creationId xmlns:a16="http://schemas.microsoft.com/office/drawing/2014/main" id="{DF0E3505-560C-4E03-85F5-EFFD4B198FAC}"/>
               </a:ext>
             </a:extLst>
           </p:cNvPr>
@@ -10539,7 +10509,7 @@
     </p:spTree>
     <p:extLst>
       <p:ext uri="{BB962C8B-B14F-4D97-AF65-F5344CB8AC3E}">
-        <p14:creationId xmlns:p14="http://schemas.microsoft.com/office/powerpoint/2010/main" val="405503024"/>
+        <p14:creationId xmlns:p14="http://schemas.microsoft.com/office/powerpoint/2010/main" val="868464201"/>
       </p:ext>
     </p:extLst>
   </p:cSld>
@@ -10570,7 +10540,7 @@
           <p:cNvPr id="8" name="">
             <a:extLst xmlns:a="http://schemas.openxmlformats.org/drawingml/2006/main">
               <a:ext uri="{FF2B5EF4-FFF2-40B4-BE49-F238E27FC236}">
-                <a16:creationId xmlns:a16="http://schemas.microsoft.com/office/drawing/2014/main" id="{C5171D51-D817-414C-8DD5-E32C371BE682}"/>
+                <a16:creationId xmlns:a16="http://schemas.microsoft.com/office/drawing/2014/main" id="{CFC7A826-F935-498D-B901-A53E47C57125}"/>
               </a:ext>
             </a:extLst>
           </p:cNvPr>
@@ -10634,7 +10604,7 @@
         </p:xfrm>
         <a:graphic xmlns:a="http://schemas.openxmlformats.org/drawingml/2006/main">
           <a:graphicData uri="http://schemas.openxmlformats.org/drawingml/2006/chart">
-            <c:chart xmlns:r="http://schemas.openxmlformats.org/officeDocument/2006/relationships" xmlns:c="http://schemas.openxmlformats.org/drawingml/2006/chart" r:id="Rd6ad760abfc443b5"/>
+            <c:chart xmlns:r="http://schemas.openxmlformats.org/officeDocument/2006/relationships" xmlns:c="http://schemas.openxmlformats.org/drawingml/2006/chart" r:id="R7255a6730b714d27"/>
           </a:graphicData>
         </a:graphic>
       </p:graphicFrame>
@@ -10643,7 +10613,7 @@
           <p:cNvPr id="3" name="">
             <a:extLst xmlns:a="http://schemas.openxmlformats.org/drawingml/2006/main">
               <a:ext uri="{FF2B5EF4-FFF2-40B4-BE49-F238E27FC236}">
-                <a16:creationId xmlns:a16="http://schemas.microsoft.com/office/drawing/2014/main" id="{B29C0568-5EDA-4626-AC57-1183DC5B1AAE}"/>
+                <a16:creationId xmlns:a16="http://schemas.microsoft.com/office/drawing/2014/main" id="{95DC348E-95A5-4250-8DEC-2D0C48783592}"/>
               </a:ext>
             </a:extLst>
           </p:cNvPr>
@@ -10700,7 +10670,7 @@
           <p:cNvPr id="4" name="">
             <a:extLst xmlns:a="http://schemas.openxmlformats.org/drawingml/2006/main">
               <a:ext uri="{FF2B5EF4-FFF2-40B4-BE49-F238E27FC236}">
-                <a16:creationId xmlns:a16="http://schemas.microsoft.com/office/drawing/2014/main" id="{67B4ED50-031F-41E1-9673-15C2743910B0}"/>
+                <a16:creationId xmlns:a16="http://schemas.microsoft.com/office/drawing/2014/main" id="{0828FAE8-2067-47F8-9B61-66E1273C86C2}"/>
               </a:ext>
             </a:extLst>
           </p:cNvPr>
@@ -10780,7 +10750,7 @@
           <p:cNvPr id="5" name="">
             <a:extLst xmlns:a="http://schemas.openxmlformats.org/drawingml/2006/main">
               <a:ext uri="{FF2B5EF4-FFF2-40B4-BE49-F238E27FC236}">
-                <a16:creationId xmlns:a16="http://schemas.microsoft.com/office/drawing/2014/main" id="{3497F813-59C8-4096-A4C0-2F73BBF97134}"/>
+                <a16:creationId xmlns:a16="http://schemas.microsoft.com/office/drawing/2014/main" id="{D6FFA74A-1052-4373-9580-E52EA2419159}"/>
               </a:ext>
             </a:extLst>
           </p:cNvPr>
@@ -10860,7 +10830,7 @@
           <p:cNvPr id="6" name="">
             <a:extLst xmlns:a="http://schemas.openxmlformats.org/drawingml/2006/main">
               <a:ext uri="{FF2B5EF4-FFF2-40B4-BE49-F238E27FC236}">
-                <a16:creationId xmlns:a16="http://schemas.microsoft.com/office/drawing/2014/main" id="{C31A5EC9-BFC2-4049-9C29-30116DA4E32F}"/>
+                <a16:creationId xmlns:a16="http://schemas.microsoft.com/office/drawing/2014/main" id="{7CE9E91D-4FE8-4342-8828-08EBB1EAAF0E}"/>
               </a:ext>
             </a:extLst>
           </p:cNvPr>
@@ -10917,7 +10887,7 @@
           <p:cNvPr id="7" name="">
             <a:extLst xmlns:a="http://schemas.openxmlformats.org/drawingml/2006/main">
               <a:ext uri="{FF2B5EF4-FFF2-40B4-BE49-F238E27FC236}">
-                <a16:creationId xmlns:a16="http://schemas.microsoft.com/office/drawing/2014/main" id="{405D396A-625C-477A-A610-AFB4DB8F6C8A}"/>
+                <a16:creationId xmlns:a16="http://schemas.microsoft.com/office/drawing/2014/main" id="{B2CEFEE2-C4D9-4EDE-9BF6-29276B4589F8}"/>
               </a:ext>
             </a:extLst>
           </p:cNvPr>
@@ -10972,7 +10942,7 @@
     </p:spTree>
     <p:extLst>
       <p:ext uri="{BB962C8B-B14F-4D97-AF65-F5344CB8AC3E}">
-        <p14:creationId xmlns:p14="http://schemas.microsoft.com/office/powerpoint/2010/main" val="99444501"/>
+        <p14:creationId xmlns:p14="http://schemas.microsoft.com/office/powerpoint/2010/main" val="1009002284"/>
       </p:ext>
     </p:extLst>
   </p:cSld>
@@ -11003,7 +10973,7 @@
           <p:cNvPr id="5" name="">
             <a:extLst xmlns:a="http://schemas.openxmlformats.org/drawingml/2006/main">
               <a:ext uri="{FF2B5EF4-FFF2-40B4-BE49-F238E27FC236}">
-                <a16:creationId xmlns:a16="http://schemas.microsoft.com/office/drawing/2014/main" id="{BBB8F3F3-37C9-4CD7-A0A2-04B1C268EA43}"/>
+                <a16:creationId xmlns:a16="http://schemas.microsoft.com/office/drawing/2014/main" id="{941177DB-62D0-4E92-960E-2EA0351CCA94}"/>
               </a:ext>
             </a:extLst>
           </p:cNvPr>
@@ -11050,7 +11020,7 @@
                 <a:ea typeface="Arial"/>
                 <a:cs typeface="Arial"/>
               </a:rPr>
-              <a:t>18 моделей на одной истории</a:t>
+              <a:t>22 классификатора и 3 регрессора</a:t>
             </a:r>
           </a:p>
         </p:txBody>
@@ -11138,7 +11108,7 @@
                           <a:ea typeface="Arial"/>
                           <a:cs typeface="Arial"/>
                         </a:rPr>
-                        <a:t>18 базовых моделей</a:t>
+                        <a:t>25 моделей</a:t>
                       </a:r>
                     </a:p>
                   </a:txBody>
@@ -11162,7 +11132,7 @@
                           <a:ea typeface="Arial"/>
                           <a:cs typeface="Arial"/>
                         </a:rPr>
-                        <a:t>Разные глубины, окна истории и функции потерь</a:t>
+                        <a:t>22 классификатора и 3 интервальных регрессора</a:t>
                       </a:r>
                     </a:p>
                   </a:txBody>
@@ -11188,7 +11158,7 @@
                           <a:ea typeface="Arial"/>
                           <a:cs typeface="Arial"/>
                         </a:rPr>
-                        <a:t>238 признаков</a:t>
+                        <a:t>362 признака</a:t>
                       </a:r>
                     </a:p>
                   </a:txBody>
@@ -11212,7 +11182,7 @@
                           <a:ea typeface="Arial"/>
                           <a:cs typeface="Arial"/>
                         </a:rPr>
-                        <a:t>Динамика состояний и повторяемость инцидентов</a:t>
+                        <a:t>Дискретные события, повторяемость и измерения</a:t>
                       </a:r>
                     </a:p>
                   </a:txBody>
@@ -11332,7 +11302,7 @@
           <p:cNvPr id="3" name="">
             <a:extLst xmlns:a="http://schemas.openxmlformats.org/drawingml/2006/main">
               <a:ext uri="{FF2B5EF4-FFF2-40B4-BE49-F238E27FC236}">
-                <a16:creationId xmlns:a16="http://schemas.microsoft.com/office/drawing/2014/main" id="{31D6B961-B01E-4AF7-BD09-F4986991E6EC}"/>
+                <a16:creationId xmlns:a16="http://schemas.microsoft.com/office/drawing/2014/main" id="{4467C86D-E947-48E2-A4AF-3B1982C59BCA}"/>
               </a:ext>
             </a:extLst>
           </p:cNvPr>
@@ -11379,7 +11349,7 @@
                 <a:ea typeface="Arial"/>
                 <a:cs typeface="Arial"/>
               </a:rPr>
-              <a:t>Перебор моделей в исследовательском пайплайне. Результат ансамбля 8 моделей показан отдельно.</a:t>
+              <a:t>В опубликованном ансамбле 8 моделей и 178 признаков. Расширенный поиск не дал устойчивого улучшения.</a:t>
             </a:r>
           </a:p>
         </p:txBody>
@@ -11389,7 +11359,7 @@
           <p:cNvPr id="4" name="">
             <a:extLst xmlns:a="http://schemas.openxmlformats.org/drawingml/2006/main">
               <a:ext uri="{FF2B5EF4-FFF2-40B4-BE49-F238E27FC236}">
-                <a16:creationId xmlns:a16="http://schemas.microsoft.com/office/drawing/2014/main" id="{88BA48AB-6B3D-42F6-B35B-63B7F3EFD716}"/>
+                <a16:creationId xmlns:a16="http://schemas.microsoft.com/office/drawing/2014/main" id="{5E1487C2-40C3-4027-9707-AA37E5E75802}"/>
               </a:ext>
             </a:extLst>
           </p:cNvPr>
@@ -11444,7 +11414,7 @@
     </p:spTree>
     <p:extLst>
       <p:ext uri="{BB962C8B-B14F-4D97-AF65-F5344CB8AC3E}">
-        <p14:creationId xmlns:p14="http://schemas.microsoft.com/office/powerpoint/2010/main" val="330615068"/>
+        <p14:creationId xmlns:p14="http://schemas.microsoft.com/office/powerpoint/2010/main" val="1783826378"/>
       </p:ext>
     </p:extLst>
   </p:cSld>
@@ -11475,7 +11445,7 @@
           <p:cNvPr id="12" name="">
             <a:extLst xmlns:a="http://schemas.openxmlformats.org/drawingml/2006/main">
               <a:ext uri="{FF2B5EF4-FFF2-40B4-BE49-F238E27FC236}">
-                <a16:creationId xmlns:a16="http://schemas.microsoft.com/office/drawing/2014/main" id="{437CEA1F-FFD2-4C20-B4EC-8B93C952BCD4}"/>
+                <a16:creationId xmlns:a16="http://schemas.microsoft.com/office/drawing/2014/main" id="{DB10A5F5-87AD-402B-B394-0372E66019ED}"/>
               </a:ext>
             </a:extLst>
           </p:cNvPr>
@@ -11555,7 +11525,7 @@
           <p:cNvPr id="2" name="">
             <a:extLst xmlns:a="http://schemas.openxmlformats.org/drawingml/2006/main">
               <a:ext uri="{FF2B5EF4-FFF2-40B4-BE49-F238E27FC236}">
-                <a16:creationId xmlns:a16="http://schemas.microsoft.com/office/drawing/2014/main" id="{133B3C98-F693-46FA-B8BD-2BC47A278204}"/>
+                <a16:creationId xmlns:a16="http://schemas.microsoft.com/office/drawing/2014/main" id="{ED7DEF4D-1F32-44C9-8BF4-59E05449653C}"/>
               </a:ext>
             </a:extLst>
           </p:cNvPr>
@@ -11612,7 +11582,7 @@
           <p:cNvPr id="3" name="">
             <a:extLst xmlns:a="http://schemas.openxmlformats.org/drawingml/2006/main">
               <a:ext uri="{FF2B5EF4-FFF2-40B4-BE49-F238E27FC236}">
-                <a16:creationId xmlns:a16="http://schemas.microsoft.com/office/drawing/2014/main" id="{F846A056-F2DB-4ADD-837C-70C11E55AD43}"/>
+                <a16:creationId xmlns:a16="http://schemas.microsoft.com/office/drawing/2014/main" id="{1EB36588-2EBB-4204-8779-29D2A3AFAC7E}"/>
               </a:ext>
             </a:extLst>
           </p:cNvPr>
@@ -11692,7 +11662,7 @@
           <p:cNvPr id="4" name="">
             <a:extLst xmlns:a="http://schemas.openxmlformats.org/drawingml/2006/main">
               <a:ext uri="{FF2B5EF4-FFF2-40B4-BE49-F238E27FC236}">
-                <a16:creationId xmlns:a16="http://schemas.microsoft.com/office/drawing/2014/main" id="{80F4E31F-43C0-49F1-9635-97ADA8900720}"/>
+                <a16:creationId xmlns:a16="http://schemas.microsoft.com/office/drawing/2014/main" id="{568144EE-6090-46BB-9778-62E8FCEAECC2}"/>
               </a:ext>
             </a:extLst>
           </p:cNvPr>
@@ -11749,7 +11719,7 @@
           <p:cNvPr id="5" name="">
             <a:extLst xmlns:a="http://schemas.openxmlformats.org/drawingml/2006/main">
               <a:ext uri="{FF2B5EF4-FFF2-40B4-BE49-F238E27FC236}">
-                <a16:creationId xmlns:a16="http://schemas.microsoft.com/office/drawing/2014/main" id="{54A46A15-FF62-4827-B75F-EC354693DD1B}"/>
+                <a16:creationId xmlns:a16="http://schemas.microsoft.com/office/drawing/2014/main" id="{C70E38B6-E766-4366-9E4F-C3AE4F6F82F8}"/>
               </a:ext>
             </a:extLst>
           </p:cNvPr>
@@ -11829,7 +11799,7 @@
           <p:cNvPr id="6" name="">
             <a:extLst xmlns:a="http://schemas.openxmlformats.org/drawingml/2006/main">
               <a:ext uri="{FF2B5EF4-FFF2-40B4-BE49-F238E27FC236}">
-                <a16:creationId xmlns:a16="http://schemas.microsoft.com/office/drawing/2014/main" id="{3719C41D-5FFB-4060-B24A-70AE8012F7B7}"/>
+                <a16:creationId xmlns:a16="http://schemas.microsoft.com/office/drawing/2014/main" id="{A908A0BC-4A2E-404E-9480-34E4188C56BD}"/>
               </a:ext>
             </a:extLst>
           </p:cNvPr>
@@ -11886,7 +11856,7 @@
           <p:cNvPr id="7" name="">
             <a:extLst xmlns:a="http://schemas.openxmlformats.org/drawingml/2006/main">
               <a:ext uri="{FF2B5EF4-FFF2-40B4-BE49-F238E27FC236}">
-                <a16:creationId xmlns:a16="http://schemas.microsoft.com/office/drawing/2014/main" id="{156CF968-35ED-4C50-A75A-5C64B149259A}"/>
+                <a16:creationId xmlns:a16="http://schemas.microsoft.com/office/drawing/2014/main" id="{80A22A07-D3FA-414F-925C-FF02106CC596}"/>
               </a:ext>
             </a:extLst>
           </p:cNvPr>
@@ -11966,7 +11936,7 @@
           <p:cNvPr id="8" name="">
             <a:extLst xmlns:a="http://schemas.openxmlformats.org/drawingml/2006/main">
               <a:ext uri="{FF2B5EF4-FFF2-40B4-BE49-F238E27FC236}">
-                <a16:creationId xmlns:a16="http://schemas.microsoft.com/office/drawing/2014/main" id="{FAE200A5-848C-4D25-8EBB-B1670988479A}"/>
+                <a16:creationId xmlns:a16="http://schemas.microsoft.com/office/drawing/2014/main" id="{EFB38BAE-E216-41C0-8719-CE30FF9A4730}"/>
               </a:ext>
             </a:extLst>
           </p:cNvPr>
@@ -12023,7 +11993,7 @@
           <p:cNvPr id="9" name="">
             <a:extLst xmlns:a="http://schemas.openxmlformats.org/drawingml/2006/main">
               <a:ext uri="{FF2B5EF4-FFF2-40B4-BE49-F238E27FC236}">
-                <a16:creationId xmlns:a16="http://schemas.microsoft.com/office/drawing/2014/main" id="{013069EA-724A-4706-83FF-5CBD36EFA410}"/>
+                <a16:creationId xmlns:a16="http://schemas.microsoft.com/office/drawing/2014/main" id="{0BBEE167-D85C-41E6-A42A-631FDB692F12}"/>
               </a:ext>
             </a:extLst>
           </p:cNvPr>
@@ -12103,7 +12073,7 @@
           <p:cNvPr id="10" name="">
             <a:extLst xmlns:a="http://schemas.openxmlformats.org/drawingml/2006/main">
               <a:ext uri="{FF2B5EF4-FFF2-40B4-BE49-F238E27FC236}">
-                <a16:creationId xmlns:a16="http://schemas.microsoft.com/office/drawing/2014/main" id="{34CD9C4D-B22E-4C89-9E85-AAD8E6F6A136}"/>
+                <a16:creationId xmlns:a16="http://schemas.microsoft.com/office/drawing/2014/main" id="{3E7C5D77-70D4-429B-88D3-8597AD9F861C}"/>
               </a:ext>
             </a:extLst>
           </p:cNvPr>
@@ -12160,7 +12130,7 @@
           <p:cNvPr id="11" name="">
             <a:extLst xmlns:a="http://schemas.openxmlformats.org/drawingml/2006/main">
               <a:ext uri="{FF2B5EF4-FFF2-40B4-BE49-F238E27FC236}">
-                <a16:creationId xmlns:a16="http://schemas.microsoft.com/office/drawing/2014/main" id="{CFEE3D13-246B-4AF9-8AF5-1D0D6627A344}"/>
+                <a16:creationId xmlns:a16="http://schemas.microsoft.com/office/drawing/2014/main" id="{86167E6A-8E52-4996-84C6-0499E31C85A3}"/>
               </a:ext>
             </a:extLst>
           </p:cNvPr>
@@ -12215,7 +12185,7 @@
     </p:spTree>
     <p:extLst>
       <p:ext uri="{BB962C8B-B14F-4D97-AF65-F5344CB8AC3E}">
-        <p14:creationId xmlns:p14="http://schemas.microsoft.com/office/powerpoint/2010/main" val="25633071"/>
+        <p14:creationId xmlns:p14="http://schemas.microsoft.com/office/powerpoint/2010/main" val="11215789"/>
       </p:ext>
     </p:extLst>
   </p:cSld>
@@ -12246,7 +12216,7 @@
           <p:cNvPr id="7" name="">
             <a:extLst xmlns:a="http://schemas.openxmlformats.org/drawingml/2006/main">
               <a:ext uri="{FF2B5EF4-FFF2-40B4-BE49-F238E27FC236}">
-                <a16:creationId xmlns:a16="http://schemas.microsoft.com/office/drawing/2014/main" id="{DF8D3C19-3AA0-4356-9DCE-96789C330952}"/>
+                <a16:creationId xmlns:a16="http://schemas.microsoft.com/office/drawing/2014/main" id="{6FD874CE-8158-4DEB-81DB-8ABA41C715D8}"/>
               </a:ext>
             </a:extLst>
           </p:cNvPr>
@@ -12525,7 +12495,7 @@
           <p:cNvPr id="3" name="">
             <a:extLst xmlns:a="http://schemas.openxmlformats.org/drawingml/2006/main">
               <a:ext uri="{FF2B5EF4-FFF2-40B4-BE49-F238E27FC236}">
-                <a16:creationId xmlns:a16="http://schemas.microsoft.com/office/drawing/2014/main" id="{DC0CBD80-A5CE-4FCC-9059-C1666C30DABE}"/>
+                <a16:creationId xmlns:a16="http://schemas.microsoft.com/office/drawing/2014/main" id="{25D10D70-8CA7-4624-9458-E6303929AE15}"/>
               </a:ext>
             </a:extLst>
           </p:cNvPr>
@@ -12582,7 +12552,7 @@
           <p:cNvPr id="4" name="">
             <a:extLst xmlns:a="http://schemas.openxmlformats.org/drawingml/2006/main">
               <a:ext uri="{FF2B5EF4-FFF2-40B4-BE49-F238E27FC236}">
-                <a16:creationId xmlns:a16="http://schemas.microsoft.com/office/drawing/2014/main" id="{65E7D66D-134B-4A72-9780-4C3D2A164AA6}"/>
+                <a16:creationId xmlns:a16="http://schemas.microsoft.com/office/drawing/2014/main" id="{DE28A1CE-A894-46A4-9EEA-0C7ACF8A86F2}"/>
               </a:ext>
             </a:extLst>
           </p:cNvPr>
@@ -12662,7 +12632,7 @@
           <p:cNvPr id="5" name="">
             <a:extLst xmlns:a="http://schemas.openxmlformats.org/drawingml/2006/main">
               <a:ext uri="{FF2B5EF4-FFF2-40B4-BE49-F238E27FC236}">
-                <a16:creationId xmlns:a16="http://schemas.microsoft.com/office/drawing/2014/main" id="{D1CD9B29-6F9F-4389-9013-08D59E8162A5}"/>
+                <a16:creationId xmlns:a16="http://schemas.microsoft.com/office/drawing/2014/main" id="{679BE4E6-6056-49CC-9629-04298F21AC5A}"/>
               </a:ext>
             </a:extLst>
           </p:cNvPr>
@@ -12719,7 +12689,7 @@
           <p:cNvPr id="6" name="">
             <a:extLst xmlns:a="http://schemas.openxmlformats.org/drawingml/2006/main">
               <a:ext uri="{FF2B5EF4-FFF2-40B4-BE49-F238E27FC236}">
-                <a16:creationId xmlns:a16="http://schemas.microsoft.com/office/drawing/2014/main" id="{55904BC8-BB83-4CBE-BFC5-559D04E2DEB1}"/>
+                <a16:creationId xmlns:a16="http://schemas.microsoft.com/office/drawing/2014/main" id="{585E6AE7-817B-4AB7-82CB-111FDED4E6AF}"/>
               </a:ext>
             </a:extLst>
           </p:cNvPr>
@@ -12774,7 +12744,7 @@
     </p:spTree>
     <p:extLst>
       <p:ext uri="{BB962C8B-B14F-4D97-AF65-F5344CB8AC3E}">
-        <p14:creationId xmlns:p14="http://schemas.microsoft.com/office/powerpoint/2010/main" val="640956263"/>
+        <p14:creationId xmlns:p14="http://schemas.microsoft.com/office/powerpoint/2010/main" val="536333033"/>
       </p:ext>
     </p:extLst>
   </p:cSld>
@@ -12805,7 +12775,7 @@
           <p:cNvPr id="9" name="">
             <a:extLst xmlns:a="http://schemas.openxmlformats.org/drawingml/2006/main">
               <a:ext uri="{FF2B5EF4-FFF2-40B4-BE49-F238E27FC236}">
-                <a16:creationId xmlns:a16="http://schemas.microsoft.com/office/drawing/2014/main" id="{99F70084-A3F8-43F0-ADED-ACD6B2AEDFCD}"/>
+                <a16:creationId xmlns:a16="http://schemas.microsoft.com/office/drawing/2014/main" id="{48889B03-14EB-414C-A0DB-85C1F97802D7}"/>
               </a:ext>
             </a:extLst>
           </p:cNvPr>
@@ -12892,7 +12862,7 @@
         </p:xfrm>
         <a:graphic xmlns:a="http://schemas.openxmlformats.org/drawingml/2006/main">
           <a:graphicData uri="http://schemas.openxmlformats.org/drawingml/2006/chart">
-            <c:chart xmlns:r="http://schemas.openxmlformats.org/officeDocument/2006/relationships" xmlns:c="http://schemas.openxmlformats.org/drawingml/2006/chart" r:id="R96de10a66f7a488d"/>
+            <c:chart xmlns:r="http://schemas.openxmlformats.org/officeDocument/2006/relationships" xmlns:c="http://schemas.openxmlformats.org/drawingml/2006/chart" r:id="R98eaa01165a243c9"/>
           </a:graphicData>
         </a:graphic>
       </p:graphicFrame>
@@ -12901,7 +12871,7 @@
           <p:cNvPr id="3" name="">
             <a:extLst xmlns:a="http://schemas.openxmlformats.org/drawingml/2006/main">
               <a:ext uri="{FF2B5EF4-FFF2-40B4-BE49-F238E27FC236}">
-                <a16:creationId xmlns:a16="http://schemas.microsoft.com/office/drawing/2014/main" id="{BFE47772-E54A-4FE1-9E32-D9E115287C39}"/>
+                <a16:creationId xmlns:a16="http://schemas.microsoft.com/office/drawing/2014/main" id="{E8A31B71-9842-4138-B083-64E2F186E201}"/>
               </a:ext>
             </a:extLst>
           </p:cNvPr>
@@ -12958,7 +12928,7 @@
           <p:cNvPr id="4" name="">
             <a:extLst xmlns:a="http://schemas.openxmlformats.org/drawingml/2006/main">
               <a:ext uri="{FF2B5EF4-FFF2-40B4-BE49-F238E27FC236}">
-                <a16:creationId xmlns:a16="http://schemas.microsoft.com/office/drawing/2014/main" id="{45EF13B4-568B-401B-A07F-3F0737FE8095}"/>
+                <a16:creationId xmlns:a16="http://schemas.microsoft.com/office/drawing/2014/main" id="{FED1087F-7C6B-4585-9F28-4C8A6CA33143}"/>
               </a:ext>
             </a:extLst>
           </p:cNvPr>
@@ -13015,7 +12985,7 @@
           <p:cNvPr id="5" name="">
             <a:extLst xmlns:a="http://schemas.openxmlformats.org/drawingml/2006/main">
               <a:ext uri="{FF2B5EF4-FFF2-40B4-BE49-F238E27FC236}">
-                <a16:creationId xmlns:a16="http://schemas.microsoft.com/office/drawing/2014/main" id="{CB8EBE80-54F8-4585-A12B-DB4259734123}"/>
+                <a16:creationId xmlns:a16="http://schemas.microsoft.com/office/drawing/2014/main" id="{1F0551DD-48E1-474B-9FA2-F797438FDD09}"/>
               </a:ext>
             </a:extLst>
           </p:cNvPr>
@@ -13072,7 +13042,7 @@
           <p:cNvPr id="6" name="">
             <a:extLst xmlns:a="http://schemas.openxmlformats.org/drawingml/2006/main">
               <a:ext uri="{FF2B5EF4-FFF2-40B4-BE49-F238E27FC236}">
-                <a16:creationId xmlns:a16="http://schemas.microsoft.com/office/drawing/2014/main" id="{2DF14FA9-9A2A-40A3-B466-0701D7D4DE46}"/>
+                <a16:creationId xmlns:a16="http://schemas.microsoft.com/office/drawing/2014/main" id="{283C4875-3F80-4CB6-8CE7-1F4F7EF182B9}"/>
               </a:ext>
             </a:extLst>
           </p:cNvPr>
@@ -13129,7 +13099,7 @@
           <p:cNvPr id="7" name="">
             <a:extLst xmlns:a="http://schemas.openxmlformats.org/drawingml/2006/main">
               <a:ext uri="{FF2B5EF4-FFF2-40B4-BE49-F238E27FC236}">
-                <a16:creationId xmlns:a16="http://schemas.microsoft.com/office/drawing/2014/main" id="{137177D3-BC90-44B4-9A0F-F01DF978FEA0}"/>
+                <a16:creationId xmlns:a16="http://schemas.microsoft.com/office/drawing/2014/main" id="{210F2077-FE9E-4C5E-85F0-4D0B2EDEBE91}"/>
               </a:ext>
             </a:extLst>
           </p:cNvPr>
@@ -13186,7 +13156,7 @@
           <p:cNvPr id="8" name="">
             <a:extLst xmlns:a="http://schemas.openxmlformats.org/drawingml/2006/main">
               <a:ext uri="{FF2B5EF4-FFF2-40B4-BE49-F238E27FC236}">
-                <a16:creationId xmlns:a16="http://schemas.microsoft.com/office/drawing/2014/main" id="{D5EB9667-5118-4B19-8979-16A0DD71E1BA}"/>
+                <a16:creationId xmlns:a16="http://schemas.microsoft.com/office/drawing/2014/main" id="{ED2A81A2-FD7F-4700-B3F8-1A62852177AE}"/>
               </a:ext>
             </a:extLst>
           </p:cNvPr>
@@ -13241,7 +13211,7 @@
     </p:spTree>
     <p:extLst>
       <p:ext uri="{BB962C8B-B14F-4D97-AF65-F5344CB8AC3E}">
-        <p14:creationId xmlns:p14="http://schemas.microsoft.com/office/powerpoint/2010/main" val="1261270232"/>
+        <p14:creationId xmlns:p14="http://schemas.microsoft.com/office/powerpoint/2010/main" val="1309923234"/>
       </p:ext>
     </p:extLst>
   </p:cSld>
@@ -13249,9 +13219,9 @@
 </file>
 
 <file path=ppt/theme/theme1.xml><?xml version="1.0" encoding="utf-8"?>
-<a:theme xmlns:a="http://schemas.openxmlformats.org/drawingml/2006/main" name="ChatGPT">
+<a:theme xmlns:a="http://schemas.openxmlformats.org/drawingml/2006/main" name="PIKET">
   <a:themeElements>
-    <a:clrScheme name="ChatGPT">
+    <a:clrScheme name="PIKET">
       <a:dk1>
         <a:srgbClr val="000000"/>
       </a:dk1>
@@ -13301,7 +13271,7 @@
         <a:cs typeface="Calibri"/>
       </a:minorFont>
     </a:fontScheme>
-    <a:fmtScheme name="ChatGPT">
+    <a:fmtScheme name="PIKET">
       <a:fillStyleLst>
         <a:solidFill>
           <a:schemeClr val="phClr"/>

</xml_diff>